<commit_message>
docs: add requirement questions and API DB decks
</commit_message>
<xml_diff>
--- a/html/project-links/documents/MACHINE_IQ_요구사항_회의질의서_PPT_20260829.pptx
+++ b/html/project-links/documents/MACHINE_IQ_요구사항_회의질의서_PPT_20260829.pptx
@@ -2,27 +2,27 @@
 <file path=ppt/presentation.xml><?xml version="1.0" encoding="utf-8"?>
 <p:presentation xmlns:p="http://schemas.openxmlformats.org/presentationml/2006/main">
   <p:sldMasterIdLst>
-    <p:sldMasterId xmlns:r="http://schemas.openxmlformats.org/officeDocument/2006/relationships" id="2147483648" r:id="R604aea45dd9946ef"/>
+    <p:sldMasterId xmlns:r="http://schemas.openxmlformats.org/officeDocument/2006/relationships" id="2147483648" r:id="R757e5fda9df64413"/>
   </p:sldMasterIdLst>
   <p:notesMasterIdLst>
-    <p:notesMasterId xmlns:r="http://schemas.openxmlformats.org/officeDocument/2006/relationships" r:id="R15c96b6c1be146e0"/>
+    <p:notesMasterId xmlns:r="http://schemas.openxmlformats.org/officeDocument/2006/relationships" r:id="R51393dbcd0334317"/>
   </p:notesMasterIdLst>
   <p:sldIdLst>
-    <p:sldId xmlns:r="http://schemas.openxmlformats.org/officeDocument/2006/relationships" id="256" r:id="Rfffe4d5be6914aef"/>
-    <p:sldId xmlns:r="http://schemas.openxmlformats.org/officeDocument/2006/relationships" id="257" r:id="R6b6bd547c6794a02"/>
-    <p:sldId xmlns:r="http://schemas.openxmlformats.org/officeDocument/2006/relationships" id="258" r:id="R2a8d9e06df2a42d7"/>
-    <p:sldId xmlns:r="http://schemas.openxmlformats.org/officeDocument/2006/relationships" id="259" r:id="R33699a674409480f"/>
-    <p:sldId xmlns:r="http://schemas.openxmlformats.org/officeDocument/2006/relationships" id="260" r:id="Rfb36e95dcc6c462c"/>
-    <p:sldId xmlns:r="http://schemas.openxmlformats.org/officeDocument/2006/relationships" id="261" r:id="R35ed0f40210f439f"/>
-    <p:sldId xmlns:r="http://schemas.openxmlformats.org/officeDocument/2006/relationships" id="262" r:id="R205843af2ac14345"/>
-    <p:sldId xmlns:r="http://schemas.openxmlformats.org/officeDocument/2006/relationships" id="263" r:id="Rffb555e259384fb2"/>
-    <p:sldId xmlns:r="http://schemas.openxmlformats.org/officeDocument/2006/relationships" id="264" r:id="R77232e403fa64110"/>
-    <p:sldId xmlns:r="http://schemas.openxmlformats.org/officeDocument/2006/relationships" id="265" r:id="Ra859bb0b92454ac2"/>
-    <p:sldId xmlns:r="http://schemas.openxmlformats.org/officeDocument/2006/relationships" id="266" r:id="Rd0af5193f6d04be3"/>
-    <p:sldId xmlns:r="http://schemas.openxmlformats.org/officeDocument/2006/relationships" id="267" r:id="Red85f4043c9e4194"/>
-    <p:sldId xmlns:r="http://schemas.openxmlformats.org/officeDocument/2006/relationships" id="268" r:id="Ra75561cec43c44da"/>
-    <p:sldId xmlns:r="http://schemas.openxmlformats.org/officeDocument/2006/relationships" id="269" r:id="R2594ab91373a4bd9"/>
-    <p:sldId xmlns:r="http://schemas.openxmlformats.org/officeDocument/2006/relationships" id="270" r:id="R3770b3dcc4de46bc"/>
+    <p:sldId xmlns:r="http://schemas.openxmlformats.org/officeDocument/2006/relationships" id="256" r:id="R3d64cad148b74f54"/>
+    <p:sldId xmlns:r="http://schemas.openxmlformats.org/officeDocument/2006/relationships" id="257" r:id="R93af7b9759eb4d1d"/>
+    <p:sldId xmlns:r="http://schemas.openxmlformats.org/officeDocument/2006/relationships" id="258" r:id="Rfe4d1971d17a4a5c"/>
+    <p:sldId xmlns:r="http://schemas.openxmlformats.org/officeDocument/2006/relationships" id="259" r:id="R9056db1032fe429a"/>
+    <p:sldId xmlns:r="http://schemas.openxmlformats.org/officeDocument/2006/relationships" id="260" r:id="R2f8b7630443d4081"/>
+    <p:sldId xmlns:r="http://schemas.openxmlformats.org/officeDocument/2006/relationships" id="261" r:id="R28fd0de6cf804ddd"/>
+    <p:sldId xmlns:r="http://schemas.openxmlformats.org/officeDocument/2006/relationships" id="262" r:id="Rf7268432418c4c4b"/>
+    <p:sldId xmlns:r="http://schemas.openxmlformats.org/officeDocument/2006/relationships" id="263" r:id="R30c660eefc484988"/>
+    <p:sldId xmlns:r="http://schemas.openxmlformats.org/officeDocument/2006/relationships" id="264" r:id="R93725ef40788484c"/>
+    <p:sldId xmlns:r="http://schemas.openxmlformats.org/officeDocument/2006/relationships" id="265" r:id="R8fd3cc4bb9f04ea8"/>
+    <p:sldId xmlns:r="http://schemas.openxmlformats.org/officeDocument/2006/relationships" id="266" r:id="R1b6eff2c936a4e30"/>
+    <p:sldId xmlns:r="http://schemas.openxmlformats.org/officeDocument/2006/relationships" id="267" r:id="R923b963d83184b14"/>
+    <p:sldId xmlns:r="http://schemas.openxmlformats.org/officeDocument/2006/relationships" id="268" r:id="Rc100067afe734326"/>
+    <p:sldId xmlns:r="http://schemas.openxmlformats.org/officeDocument/2006/relationships" id="269" r:id="R0b6de28fdf864c8c"/>
+    <p:sldId xmlns:r="http://schemas.openxmlformats.org/officeDocument/2006/relationships" id="270" r:id="Rd3ba7f15c68f4594"/>
   </p:sldIdLst>
   <p:sldSz cx="12192000" cy="6858000"/>
   <p:notesSz cx="6858000" cy="9144000"/>
@@ -1729,7 +1729,7 @@
   </p:cSld>
   <p:clrMap bg1="lt1" tx1="dk1" bg2="lt2" tx2="dk2" accent1="accent1" accent2="accent2" accent3="accent3" accent4="accent4" accent5="accent5" accent6="accent6" hlink="hlink" folHlink="folHlink"/>
   <p:sldLayoutIdLst>
-    <p:sldLayoutId xmlns:r="http://schemas.openxmlformats.org/officeDocument/2006/relationships" id="2147483649" r:id="Rf41345aea897424e"/>
+    <p:sldLayoutId xmlns:r="http://schemas.openxmlformats.org/officeDocument/2006/relationships" id="2147483649" r:id="R3974bf3b885d40cb"/>
   </p:sldLayoutIdLst>
   <p:txStyles>
     <p:titleStyle>
@@ -2280,7 +2280,7 @@
           <p:cNvPr id="8" name="">
             <a:extLst xmlns:a="http://schemas.openxmlformats.org/drawingml/2006/main">
               <a:ext uri="{FF2B5EF4-FFF2-40B4-BE49-F238E27FC236}">
-                <a16:creationId xmlns:a16="http://schemas.microsoft.com/office/drawing/2014/main" id="{9D3027F4-DB65-40A9-9008-5DC911859D04}"/>
+                <a16:creationId xmlns:a16="http://schemas.microsoft.com/office/drawing/2014/main" id="{891A0BE9-ABEB-4610-8EBD-A33999DF2957}"/>
               </a:ext>
             </a:extLst>
           </p:cNvPr>
@@ -2313,7 +2313,7 @@
           <p:cNvPr id="2" name="">
             <a:extLst xmlns:a="http://schemas.openxmlformats.org/drawingml/2006/main">
               <a:ext uri="{FF2B5EF4-FFF2-40B4-BE49-F238E27FC236}">
-                <a16:creationId xmlns:a16="http://schemas.microsoft.com/office/drawing/2014/main" id="{00E5D25A-0098-4FF6-A109-D6E058171101}"/>
+                <a16:creationId xmlns:a16="http://schemas.microsoft.com/office/drawing/2014/main" id="{15EC7755-90CD-4406-A587-09097B107E1C}"/>
               </a:ext>
             </a:extLst>
           </p:cNvPr>
@@ -2363,7 +2363,7 @@
           <p:cNvPr id="3" name="">
             <a:extLst xmlns:a="http://schemas.openxmlformats.org/drawingml/2006/main">
               <a:ext uri="{FF2B5EF4-FFF2-40B4-BE49-F238E27FC236}">
-                <a16:creationId xmlns:a16="http://schemas.microsoft.com/office/drawing/2014/main" id="{4482BD31-9494-4656-B151-89A2ED977EBA}"/>
+                <a16:creationId xmlns:a16="http://schemas.microsoft.com/office/drawing/2014/main" id="{19123EA9-FF31-45DC-95E9-B195E520BE62}"/>
               </a:ext>
             </a:extLst>
           </p:cNvPr>
@@ -2430,7 +2430,7 @@
           <p:cNvPr id="4" name="">
             <a:extLst xmlns:a="http://schemas.openxmlformats.org/drawingml/2006/main">
               <a:ext uri="{FF2B5EF4-FFF2-40B4-BE49-F238E27FC236}">
-                <a16:creationId xmlns:a16="http://schemas.microsoft.com/office/drawing/2014/main" id="{70F6D6CB-E2A8-4E04-A78E-0D57671A64B8}"/>
+                <a16:creationId xmlns:a16="http://schemas.microsoft.com/office/drawing/2014/main" id="{7A1246BB-C812-4978-9C41-3501AB92F9CE}"/>
               </a:ext>
             </a:extLst>
           </p:cNvPr>
@@ -2470,7 +2470,7 @@
                   <a:srgbClr val="D1D5DB"/>
                 </a:solidFill>
               </a:rPr>
-              <a:t>화면·메뉴별 요구사항 31건과 확인 질의 25건</a:t>
+              <a:t>화면·메뉴별 요구사항 31건과 확인 질의 23건</a:t>
             </a:r>
           </a:p>
         </p:txBody>
@@ -2480,7 +2480,7 @@
           <p:cNvPr id="5" name="">
             <a:extLst xmlns:a="http://schemas.openxmlformats.org/drawingml/2006/main">
               <a:ext uri="{FF2B5EF4-FFF2-40B4-BE49-F238E27FC236}">
-                <a16:creationId xmlns:a16="http://schemas.microsoft.com/office/drawing/2014/main" id="{C99B98A9-8007-4A68-8B23-1323D16C272F}"/>
+                <a16:creationId xmlns:a16="http://schemas.microsoft.com/office/drawing/2014/main" id="{0A9DAE78-7E6A-4D5B-BFE4-AD240347C996}"/>
               </a:ext>
             </a:extLst>
           </p:cNvPr>
@@ -2530,7 +2530,7 @@
           <p:cNvPr id="6" name="">
             <a:extLst xmlns:a="http://schemas.openxmlformats.org/drawingml/2006/main">
               <a:ext uri="{FF2B5EF4-FFF2-40B4-BE49-F238E27FC236}">
-                <a16:creationId xmlns:a16="http://schemas.microsoft.com/office/drawing/2014/main" id="{561A5FBE-DAB9-4FE0-A6E4-F522F8161610}"/>
+                <a16:creationId xmlns:a16="http://schemas.microsoft.com/office/drawing/2014/main" id="{5BE958C2-7526-4E9D-AC6F-86936DF23683}"/>
               </a:ext>
             </a:extLst>
           </p:cNvPr>
@@ -2597,7 +2597,7 @@
           <p:cNvPr id="7" name="">
             <a:extLst xmlns:a="http://schemas.openxmlformats.org/drawingml/2006/main">
               <a:ext uri="{FF2B5EF4-FFF2-40B4-BE49-F238E27FC236}">
-                <a16:creationId xmlns:a16="http://schemas.microsoft.com/office/drawing/2014/main" id="{B425FEC9-21B9-4D86-AFAB-E82B8F7AE6FA}"/>
+                <a16:creationId xmlns:a16="http://schemas.microsoft.com/office/drawing/2014/main" id="{9D020EB7-E790-4932-9789-C074B02FB097}"/>
               </a:ext>
             </a:extLst>
           </p:cNvPr>
@@ -2645,7 +2645,7 @@
     </p:spTree>
     <p:extLst>
       <p:ext uri="{BB962C8B-B14F-4D97-AF65-F5344CB8AC3E}">
-        <p14:creationId xmlns:p14="http://schemas.microsoft.com/office/powerpoint/2010/main" val="399025506"/>
+        <p14:creationId xmlns:p14="http://schemas.microsoft.com/office/powerpoint/2010/main" val="1942360878"/>
       </p:ext>
     </p:extLst>
   </p:cSld>
@@ -2676,7 +2676,7 @@
           <p:cNvPr id="28" name="">
             <a:extLst xmlns:a="http://schemas.openxmlformats.org/drawingml/2006/main">
               <a:ext uri="{FF2B5EF4-FFF2-40B4-BE49-F238E27FC236}">
-                <a16:creationId xmlns:a16="http://schemas.microsoft.com/office/drawing/2014/main" id="{6B7392D1-1757-41DF-84A3-1B198439BBB2}"/>
+                <a16:creationId xmlns:a16="http://schemas.microsoft.com/office/drawing/2014/main" id="{BF47D638-8A94-4C49-ACCF-C24C37B66093}"/>
               </a:ext>
             </a:extLst>
           </p:cNvPr>
@@ -2709,7 +2709,7 @@
           <p:cNvPr id="2" name="">
             <a:extLst xmlns:a="http://schemas.openxmlformats.org/drawingml/2006/main">
               <a:ext uri="{FF2B5EF4-FFF2-40B4-BE49-F238E27FC236}">
-                <a16:creationId xmlns:a16="http://schemas.microsoft.com/office/drawing/2014/main" id="{7FDD1334-5C61-4117-B27A-E33F42679C0A}"/>
+                <a16:creationId xmlns:a16="http://schemas.microsoft.com/office/drawing/2014/main" id="{A5329758-9B5D-4C4A-A0BC-744325DA5603}"/>
               </a:ext>
             </a:extLst>
           </p:cNvPr>
@@ -2759,7 +2759,7 @@
           <p:cNvPr id="3" name="">
             <a:extLst xmlns:a="http://schemas.openxmlformats.org/drawingml/2006/main">
               <a:ext uri="{FF2B5EF4-FFF2-40B4-BE49-F238E27FC236}">
-                <a16:creationId xmlns:a16="http://schemas.microsoft.com/office/drawing/2014/main" id="{15A7F0D8-312F-4FCF-8248-0ED19040586F}"/>
+                <a16:creationId xmlns:a16="http://schemas.microsoft.com/office/drawing/2014/main" id="{2E493B0A-1E2B-4AB3-9B77-28EDD4A5100E}"/>
               </a:ext>
             </a:extLst>
           </p:cNvPr>
@@ -2809,7 +2809,7 @@
           <p:cNvPr id="4" name="">
             <a:extLst xmlns:a="http://schemas.openxmlformats.org/drawingml/2006/main">
               <a:ext uri="{FF2B5EF4-FFF2-40B4-BE49-F238E27FC236}">
-                <a16:creationId xmlns:a16="http://schemas.microsoft.com/office/drawing/2014/main" id="{CC055FEF-5DA0-4790-AB7E-FC2120B7F87A}"/>
+                <a16:creationId xmlns:a16="http://schemas.microsoft.com/office/drawing/2014/main" id="{0CB12A53-5647-416B-A99E-BEA7C05C4F42}"/>
               </a:ext>
             </a:extLst>
           </p:cNvPr>
@@ -2859,7 +2859,7 @@
           <p:cNvPr id="5" name="">
             <a:extLst xmlns:a="http://schemas.openxmlformats.org/drawingml/2006/main">
               <a:ext uri="{FF2B5EF4-FFF2-40B4-BE49-F238E27FC236}">
-                <a16:creationId xmlns:a16="http://schemas.microsoft.com/office/drawing/2014/main" id="{1696D4AA-08E4-4495-9865-4D07857B5CFB}"/>
+                <a16:creationId xmlns:a16="http://schemas.microsoft.com/office/drawing/2014/main" id="{50FDB331-FBB9-4FCE-BC7B-316DF7E5B156}"/>
               </a:ext>
             </a:extLst>
           </p:cNvPr>
@@ -2909,7 +2909,7 @@
           <p:cNvPr id="6" name="">
             <a:extLst xmlns:a="http://schemas.openxmlformats.org/drawingml/2006/main">
               <a:ext uri="{FF2B5EF4-FFF2-40B4-BE49-F238E27FC236}">
-                <a16:creationId xmlns:a16="http://schemas.microsoft.com/office/drawing/2014/main" id="{D8C548F3-0610-4A13-A3A6-027654F571DE}"/>
+                <a16:creationId xmlns:a16="http://schemas.microsoft.com/office/drawing/2014/main" id="{5FAD7BB3-F850-4E0F-AD92-4CC7BA76914A}"/>
               </a:ext>
             </a:extLst>
           </p:cNvPr>
@@ -2942,7 +2942,7 @@
           <p:cNvPr id="7" name="">
             <a:extLst xmlns:a="http://schemas.openxmlformats.org/drawingml/2006/main">
               <a:ext uri="{FF2B5EF4-FFF2-40B4-BE49-F238E27FC236}">
-                <a16:creationId xmlns:a16="http://schemas.microsoft.com/office/drawing/2014/main" id="{1F4CB7B2-35E6-4232-A87B-38452573E5C0}"/>
+                <a16:creationId xmlns:a16="http://schemas.microsoft.com/office/drawing/2014/main" id="{9B6A05BB-4CF3-4032-A8D7-D8573F92088B}"/>
               </a:ext>
             </a:extLst>
           </p:cNvPr>
@@ -2977,7 +2977,7 @@
           <p:cNvPr id="8" name="">
             <a:extLst xmlns:a="http://schemas.openxmlformats.org/drawingml/2006/main">
               <a:ext uri="{FF2B5EF4-FFF2-40B4-BE49-F238E27FC236}">
-                <a16:creationId xmlns:a16="http://schemas.microsoft.com/office/drawing/2014/main" id="{F297EFCF-E427-4363-ABF5-CAD64B87EFA5}"/>
+                <a16:creationId xmlns:a16="http://schemas.microsoft.com/office/drawing/2014/main" id="{7C66EE8E-03FE-4E6A-8F94-8EEF0B27E2DB}"/>
               </a:ext>
             </a:extLst>
           </p:cNvPr>
@@ -3010,7 +3010,7 @@
           <p:cNvPr id="9" name="">
             <a:extLst xmlns:a="http://schemas.openxmlformats.org/drawingml/2006/main">
               <a:ext uri="{FF2B5EF4-FFF2-40B4-BE49-F238E27FC236}">
-                <a16:creationId xmlns:a16="http://schemas.microsoft.com/office/drawing/2014/main" id="{0FBDB1EB-320B-463B-86BF-3F051343FFEC}"/>
+                <a16:creationId xmlns:a16="http://schemas.microsoft.com/office/drawing/2014/main" id="{EF0ED1EC-2F30-4851-B31E-D78E32F09B31}"/>
               </a:ext>
             </a:extLst>
           </p:cNvPr>
@@ -3060,7 +3060,7 @@
           <p:cNvPr id="10" name="">
             <a:extLst xmlns:a="http://schemas.openxmlformats.org/drawingml/2006/main">
               <a:ext uri="{FF2B5EF4-FFF2-40B4-BE49-F238E27FC236}">
-                <a16:creationId xmlns:a16="http://schemas.microsoft.com/office/drawing/2014/main" id="{E7BFD0B0-79C8-4180-8AAC-1A17E70E5BD9}"/>
+                <a16:creationId xmlns:a16="http://schemas.microsoft.com/office/drawing/2014/main" id="{5E06CB88-9BBF-43CF-91DF-E41822640A50}"/>
               </a:ext>
             </a:extLst>
           </p:cNvPr>
@@ -3110,7 +3110,7 @@
           <p:cNvPr id="11" name="">
             <a:extLst xmlns:a="http://schemas.openxmlformats.org/drawingml/2006/main">
               <a:ext uri="{FF2B5EF4-FFF2-40B4-BE49-F238E27FC236}">
-                <a16:creationId xmlns:a16="http://schemas.microsoft.com/office/drawing/2014/main" id="{3DF6B8BA-3F4D-4F84-BFD7-F7DCAF84FF7C}"/>
+                <a16:creationId xmlns:a16="http://schemas.microsoft.com/office/drawing/2014/main" id="{85B1B2B9-4A49-436F-A293-C1CC4B4948BD}"/>
               </a:ext>
             </a:extLst>
           </p:cNvPr>
@@ -3160,7 +3160,7 @@
           <p:cNvPr id="12" name="">
             <a:extLst xmlns:a="http://schemas.openxmlformats.org/drawingml/2006/main">
               <a:ext uri="{FF2B5EF4-FFF2-40B4-BE49-F238E27FC236}">
-                <a16:creationId xmlns:a16="http://schemas.microsoft.com/office/drawing/2014/main" id="{5F5DDE21-136E-4D68-9477-CAF5345A3EBE}"/>
+                <a16:creationId xmlns:a16="http://schemas.microsoft.com/office/drawing/2014/main" id="{A327880E-73E6-4C05-ABFB-F5504D3A94F5}"/>
               </a:ext>
             </a:extLst>
           </p:cNvPr>
@@ -3210,7 +3210,7 @@
           <p:cNvPr id="13" name="">
             <a:extLst xmlns:a="http://schemas.openxmlformats.org/drawingml/2006/main">
               <a:ext uri="{FF2B5EF4-FFF2-40B4-BE49-F238E27FC236}">
-                <a16:creationId xmlns:a16="http://schemas.microsoft.com/office/drawing/2014/main" id="{BB1A6EDD-5045-4906-8F44-7C0BBD46FC5F}"/>
+                <a16:creationId xmlns:a16="http://schemas.microsoft.com/office/drawing/2014/main" id="{D871CAAB-9C17-42D1-8A15-D884680FDC68}"/>
               </a:ext>
             </a:extLst>
           </p:cNvPr>
@@ -3243,7 +3243,7 @@
           <p:cNvPr id="14" name="">
             <a:extLst xmlns:a="http://schemas.openxmlformats.org/drawingml/2006/main">
               <a:ext uri="{FF2B5EF4-FFF2-40B4-BE49-F238E27FC236}">
-                <a16:creationId xmlns:a16="http://schemas.microsoft.com/office/drawing/2014/main" id="{D6E4E0A2-9463-49C1-B6EA-8EA9C7C91B03}"/>
+                <a16:creationId xmlns:a16="http://schemas.microsoft.com/office/drawing/2014/main" id="{D2E93893-20FC-438A-8800-7D9BF452FA21}"/>
               </a:ext>
             </a:extLst>
           </p:cNvPr>
@@ -3293,7 +3293,7 @@
           <p:cNvPr id="15" name="">
             <a:extLst xmlns:a="http://schemas.openxmlformats.org/drawingml/2006/main">
               <a:ext uri="{FF2B5EF4-FFF2-40B4-BE49-F238E27FC236}">
-                <a16:creationId xmlns:a16="http://schemas.microsoft.com/office/drawing/2014/main" id="{2C9D6EB6-4C0E-4B56-A34C-780A2FFE957D}"/>
+                <a16:creationId xmlns:a16="http://schemas.microsoft.com/office/drawing/2014/main" id="{9E16EF2A-CAB6-4A47-B212-A9A6F3AE02A9}"/>
               </a:ext>
             </a:extLst>
           </p:cNvPr>
@@ -3343,7 +3343,7 @@
           <p:cNvPr id="16" name="">
             <a:extLst xmlns:a="http://schemas.openxmlformats.org/drawingml/2006/main">
               <a:ext uri="{FF2B5EF4-FFF2-40B4-BE49-F238E27FC236}">
-                <a16:creationId xmlns:a16="http://schemas.microsoft.com/office/drawing/2014/main" id="{61323936-BBDC-43BF-8A06-21F22EDA9EFB}"/>
+                <a16:creationId xmlns:a16="http://schemas.microsoft.com/office/drawing/2014/main" id="{D8480415-2284-479B-9A89-6138C5445E1C}"/>
               </a:ext>
             </a:extLst>
           </p:cNvPr>
@@ -3378,7 +3378,7 @@
           <p:cNvPr id="17" name="">
             <a:extLst xmlns:a="http://schemas.openxmlformats.org/drawingml/2006/main">
               <a:ext uri="{FF2B5EF4-FFF2-40B4-BE49-F238E27FC236}">
-                <a16:creationId xmlns:a16="http://schemas.microsoft.com/office/drawing/2014/main" id="{E4DFE205-5B6F-4D92-834E-C97DD5D6D70E}"/>
+                <a16:creationId xmlns:a16="http://schemas.microsoft.com/office/drawing/2014/main" id="{D2A8F08D-B94E-4DB4-B113-0D116000E37E}"/>
               </a:ext>
             </a:extLst>
           </p:cNvPr>
@@ -3411,7 +3411,7 @@
           <p:cNvPr id="18" name="">
             <a:extLst xmlns:a="http://schemas.openxmlformats.org/drawingml/2006/main">
               <a:ext uri="{FF2B5EF4-FFF2-40B4-BE49-F238E27FC236}">
-                <a16:creationId xmlns:a16="http://schemas.microsoft.com/office/drawing/2014/main" id="{1D79CD43-21AA-4F4C-B9D5-C3401FDEBB48}"/>
+                <a16:creationId xmlns:a16="http://schemas.microsoft.com/office/drawing/2014/main" id="{F1E2B128-1DBE-41A8-A393-3CD4ADC396B1}"/>
               </a:ext>
             </a:extLst>
           </p:cNvPr>
@@ -3461,7 +3461,7 @@
           <p:cNvPr id="19" name="">
             <a:extLst xmlns:a="http://schemas.openxmlformats.org/drawingml/2006/main">
               <a:ext uri="{FF2B5EF4-FFF2-40B4-BE49-F238E27FC236}">
-                <a16:creationId xmlns:a16="http://schemas.microsoft.com/office/drawing/2014/main" id="{DAB82F25-11CB-4279-B5AE-87170567C94D}"/>
+                <a16:creationId xmlns:a16="http://schemas.microsoft.com/office/drawing/2014/main" id="{5E094B93-F70F-4C5C-AD9F-44C381C38974}"/>
               </a:ext>
             </a:extLst>
           </p:cNvPr>
@@ -3511,7 +3511,7 @@
           <p:cNvPr id="20" name="">
             <a:extLst xmlns:a="http://schemas.openxmlformats.org/drawingml/2006/main">
               <a:ext uri="{FF2B5EF4-FFF2-40B4-BE49-F238E27FC236}">
-                <a16:creationId xmlns:a16="http://schemas.microsoft.com/office/drawing/2014/main" id="{D02FE45E-0D2E-494B-BCA5-A5A7065769EA}"/>
+                <a16:creationId xmlns:a16="http://schemas.microsoft.com/office/drawing/2014/main" id="{128E0849-48AC-4F3B-B2A0-446150835B18}"/>
               </a:ext>
             </a:extLst>
           </p:cNvPr>
@@ -3561,7 +3561,7 @@
           <p:cNvPr id="21" name="">
             <a:extLst xmlns:a="http://schemas.openxmlformats.org/drawingml/2006/main">
               <a:ext uri="{FF2B5EF4-FFF2-40B4-BE49-F238E27FC236}">
-                <a16:creationId xmlns:a16="http://schemas.microsoft.com/office/drawing/2014/main" id="{1D5E945A-C507-4376-8131-3AB595E5BE80}"/>
+                <a16:creationId xmlns:a16="http://schemas.microsoft.com/office/drawing/2014/main" id="{2C47DD44-95C4-49D9-8827-BEC22FC73589}"/>
               </a:ext>
             </a:extLst>
           </p:cNvPr>
@@ -3611,7 +3611,7 @@
           <p:cNvPr id="22" name="">
             <a:extLst xmlns:a="http://schemas.openxmlformats.org/drawingml/2006/main">
               <a:ext uri="{FF2B5EF4-FFF2-40B4-BE49-F238E27FC236}">
-                <a16:creationId xmlns:a16="http://schemas.microsoft.com/office/drawing/2014/main" id="{C7D2C9F8-1561-4666-A943-AC4C75B77F3E}"/>
+                <a16:creationId xmlns:a16="http://schemas.microsoft.com/office/drawing/2014/main" id="{760EF4EF-0FCA-4995-931E-9E0FA25C280B}"/>
               </a:ext>
             </a:extLst>
           </p:cNvPr>
@@ -3644,7 +3644,7 @@
           <p:cNvPr id="23" name="">
             <a:extLst xmlns:a="http://schemas.openxmlformats.org/drawingml/2006/main">
               <a:ext uri="{FF2B5EF4-FFF2-40B4-BE49-F238E27FC236}">
-                <a16:creationId xmlns:a16="http://schemas.microsoft.com/office/drawing/2014/main" id="{B9CE9677-9C8A-43CB-9B56-183E36F4E302}"/>
+                <a16:creationId xmlns:a16="http://schemas.microsoft.com/office/drawing/2014/main" id="{14611B64-8CEA-42C7-96D5-D9CDEC2A3C63}"/>
               </a:ext>
             </a:extLst>
           </p:cNvPr>
@@ -3711,7 +3711,7 @@
           <p:cNvPr id="24" name="">
             <a:extLst xmlns:a="http://schemas.openxmlformats.org/drawingml/2006/main">
               <a:ext uri="{FF2B5EF4-FFF2-40B4-BE49-F238E27FC236}">
-                <a16:creationId xmlns:a16="http://schemas.microsoft.com/office/drawing/2014/main" id="{5DFBC9BA-A04E-40B7-8104-3156A14F9E59}"/>
+                <a16:creationId xmlns:a16="http://schemas.microsoft.com/office/drawing/2014/main" id="{229DD6C5-C098-4F41-9B78-9CE7E245BA8C}"/>
               </a:ext>
             </a:extLst>
           </p:cNvPr>
@@ -3778,7 +3778,7 @@
           <p:cNvPr id="25" name="">
             <a:extLst xmlns:a="http://schemas.openxmlformats.org/drawingml/2006/main">
               <a:ext uri="{FF2B5EF4-FFF2-40B4-BE49-F238E27FC236}">
-                <a16:creationId xmlns:a16="http://schemas.microsoft.com/office/drawing/2014/main" id="{CF0A6033-4F72-4744-9F1B-3014BFF3D0CA}"/>
+                <a16:creationId xmlns:a16="http://schemas.microsoft.com/office/drawing/2014/main" id="{C033B7FB-B4FA-41ED-908B-70D04B78A1E0}"/>
               </a:ext>
             </a:extLst>
           </p:cNvPr>
@@ -3811,7 +3811,7 @@
           <p:cNvPr id="26" name="">
             <a:extLst xmlns:a="http://schemas.openxmlformats.org/drawingml/2006/main">
               <a:ext uri="{FF2B5EF4-FFF2-40B4-BE49-F238E27FC236}">
-                <a16:creationId xmlns:a16="http://schemas.microsoft.com/office/drawing/2014/main" id="{1AFA2D2E-0698-4549-9F68-F0D6BA08426F}"/>
+                <a16:creationId xmlns:a16="http://schemas.microsoft.com/office/drawing/2014/main" id="{2C74A23C-D39F-4B4E-B03E-B27F4270929A}"/>
               </a:ext>
             </a:extLst>
           </p:cNvPr>
@@ -3861,7 +3861,7 @@
           <p:cNvPr id="27" name="">
             <a:extLst xmlns:a="http://schemas.openxmlformats.org/drawingml/2006/main">
               <a:ext uri="{FF2B5EF4-FFF2-40B4-BE49-F238E27FC236}">
-                <a16:creationId xmlns:a16="http://schemas.microsoft.com/office/drawing/2014/main" id="{93B03CC3-2CF3-470D-A231-AB044A29DDD3}"/>
+                <a16:creationId xmlns:a16="http://schemas.microsoft.com/office/drawing/2014/main" id="{224278CA-6CED-4E96-96B2-9609063EFEE2}"/>
               </a:ext>
             </a:extLst>
           </p:cNvPr>
@@ -3909,7 +3909,7 @@
     </p:spTree>
     <p:extLst>
       <p:ext uri="{BB962C8B-B14F-4D97-AF65-F5344CB8AC3E}">
-        <p14:creationId xmlns:p14="http://schemas.microsoft.com/office/powerpoint/2010/main" val="174801120"/>
+        <p14:creationId xmlns:p14="http://schemas.microsoft.com/office/powerpoint/2010/main" val="1868999898"/>
       </p:ext>
     </p:extLst>
   </p:cSld>
@@ -3940,7 +3940,7 @@
           <p:cNvPr id="25" name="">
             <a:extLst xmlns:a="http://schemas.openxmlformats.org/drawingml/2006/main">
               <a:ext uri="{FF2B5EF4-FFF2-40B4-BE49-F238E27FC236}">
-                <a16:creationId xmlns:a16="http://schemas.microsoft.com/office/drawing/2014/main" id="{9ABA910A-3144-4F63-AA3A-B758EF62FBDC}"/>
+                <a16:creationId xmlns:a16="http://schemas.microsoft.com/office/drawing/2014/main" id="{E66BECF4-1A58-4995-9A6C-5995375A8874}"/>
               </a:ext>
             </a:extLst>
           </p:cNvPr>
@@ -3973,7 +3973,7 @@
           <p:cNvPr id="2" name="">
             <a:extLst xmlns:a="http://schemas.openxmlformats.org/drawingml/2006/main">
               <a:ext uri="{FF2B5EF4-FFF2-40B4-BE49-F238E27FC236}">
-                <a16:creationId xmlns:a16="http://schemas.microsoft.com/office/drawing/2014/main" id="{BC849408-0361-43FE-A2DE-1AD692AD3F2B}"/>
+                <a16:creationId xmlns:a16="http://schemas.microsoft.com/office/drawing/2014/main" id="{9094CA36-F85E-4D48-B8EE-C0239B97F168}"/>
               </a:ext>
             </a:extLst>
           </p:cNvPr>
@@ -4023,7 +4023,7 @@
           <p:cNvPr id="3" name="">
             <a:extLst xmlns:a="http://schemas.openxmlformats.org/drawingml/2006/main">
               <a:ext uri="{FF2B5EF4-FFF2-40B4-BE49-F238E27FC236}">
-                <a16:creationId xmlns:a16="http://schemas.microsoft.com/office/drawing/2014/main" id="{573993E3-F531-45CE-8A49-D943D120D0D1}"/>
+                <a16:creationId xmlns:a16="http://schemas.microsoft.com/office/drawing/2014/main" id="{1DA484CE-F85C-446C-AAB6-2AF7080E63CC}"/>
               </a:ext>
             </a:extLst>
           </p:cNvPr>
@@ -4073,7 +4073,7 @@
           <p:cNvPr id="4" name="">
             <a:extLst xmlns:a="http://schemas.openxmlformats.org/drawingml/2006/main">
               <a:ext uri="{FF2B5EF4-FFF2-40B4-BE49-F238E27FC236}">
-                <a16:creationId xmlns:a16="http://schemas.microsoft.com/office/drawing/2014/main" id="{110A6F3D-C801-4C16-BE94-0E20154D1CB9}"/>
+                <a16:creationId xmlns:a16="http://schemas.microsoft.com/office/drawing/2014/main" id="{3552838F-F57A-4BBF-903C-271EB240E06F}"/>
               </a:ext>
             </a:extLst>
           </p:cNvPr>
@@ -4123,7 +4123,7 @@
           <p:cNvPr id="5" name="">
             <a:extLst xmlns:a="http://schemas.openxmlformats.org/drawingml/2006/main">
               <a:ext uri="{FF2B5EF4-FFF2-40B4-BE49-F238E27FC236}">
-                <a16:creationId xmlns:a16="http://schemas.microsoft.com/office/drawing/2014/main" id="{E9621331-0698-4437-9207-E7A34EBDF429}"/>
+                <a16:creationId xmlns:a16="http://schemas.microsoft.com/office/drawing/2014/main" id="{C8B20061-ADB0-45F2-9E46-E61AE71DC0E4}"/>
               </a:ext>
             </a:extLst>
           </p:cNvPr>
@@ -4173,7 +4173,7 @@
           <p:cNvPr id="6" name="">
             <a:extLst xmlns:a="http://schemas.openxmlformats.org/drawingml/2006/main">
               <a:ext uri="{FF2B5EF4-FFF2-40B4-BE49-F238E27FC236}">
-                <a16:creationId xmlns:a16="http://schemas.microsoft.com/office/drawing/2014/main" id="{A7B19538-E8CD-41FD-8DBF-39771EB03D54}"/>
+                <a16:creationId xmlns:a16="http://schemas.microsoft.com/office/drawing/2014/main" id="{53297858-4D5C-4397-802C-A5E2DE118AD8}"/>
               </a:ext>
             </a:extLst>
           </p:cNvPr>
@@ -4206,7 +4206,7 @@
           <p:cNvPr id="7" name="">
             <a:extLst xmlns:a="http://schemas.openxmlformats.org/drawingml/2006/main">
               <a:ext uri="{FF2B5EF4-FFF2-40B4-BE49-F238E27FC236}">
-                <a16:creationId xmlns:a16="http://schemas.microsoft.com/office/drawing/2014/main" id="{02AD5B5F-C350-4A8B-B216-C0A85E6A4945}"/>
+                <a16:creationId xmlns:a16="http://schemas.microsoft.com/office/drawing/2014/main" id="{BC47FD9A-13D1-467B-BF34-60997412EB31}"/>
               </a:ext>
             </a:extLst>
           </p:cNvPr>
@@ -4241,7 +4241,7 @@
           <p:cNvPr id="8" name="">
             <a:extLst xmlns:a="http://schemas.openxmlformats.org/drawingml/2006/main">
               <a:ext uri="{FF2B5EF4-FFF2-40B4-BE49-F238E27FC236}">
-                <a16:creationId xmlns:a16="http://schemas.microsoft.com/office/drawing/2014/main" id="{845DCD83-F5FF-4CA9-884F-74DD5A57D7C9}"/>
+                <a16:creationId xmlns:a16="http://schemas.microsoft.com/office/drawing/2014/main" id="{F749091B-74C8-4ED3-AAAD-F0604C778D95}"/>
               </a:ext>
             </a:extLst>
           </p:cNvPr>
@@ -4274,7 +4274,7 @@
           <p:cNvPr id="9" name="">
             <a:extLst xmlns:a="http://schemas.openxmlformats.org/drawingml/2006/main">
               <a:ext uri="{FF2B5EF4-FFF2-40B4-BE49-F238E27FC236}">
-                <a16:creationId xmlns:a16="http://schemas.microsoft.com/office/drawing/2014/main" id="{E664D67B-17AF-4964-80DF-D5405A38B574}"/>
+                <a16:creationId xmlns:a16="http://schemas.microsoft.com/office/drawing/2014/main" id="{379604F6-F335-4612-A515-C1ED8918A94A}"/>
               </a:ext>
             </a:extLst>
           </p:cNvPr>
@@ -4324,7 +4324,7 @@
           <p:cNvPr id="10" name="">
             <a:extLst xmlns:a="http://schemas.openxmlformats.org/drawingml/2006/main">
               <a:ext uri="{FF2B5EF4-FFF2-40B4-BE49-F238E27FC236}">
-                <a16:creationId xmlns:a16="http://schemas.microsoft.com/office/drawing/2014/main" id="{9E580FD9-E883-4B8C-9CF1-54745AF464C7}"/>
+                <a16:creationId xmlns:a16="http://schemas.microsoft.com/office/drawing/2014/main" id="{968C7B1A-EFBF-4C57-89EC-CAE83C3F9271}"/>
               </a:ext>
             </a:extLst>
           </p:cNvPr>
@@ -4374,7 +4374,7 @@
           <p:cNvPr id="11" name="">
             <a:extLst xmlns:a="http://schemas.openxmlformats.org/drawingml/2006/main">
               <a:ext uri="{FF2B5EF4-FFF2-40B4-BE49-F238E27FC236}">
-                <a16:creationId xmlns:a16="http://schemas.microsoft.com/office/drawing/2014/main" id="{93F90673-F9A5-4270-91AA-3A53C651B3AF}"/>
+                <a16:creationId xmlns:a16="http://schemas.microsoft.com/office/drawing/2014/main" id="{066E95B8-21A5-4F2D-B292-FF31EE8AA3F2}"/>
               </a:ext>
             </a:extLst>
           </p:cNvPr>
@@ -4424,7 +4424,7 @@
           <p:cNvPr id="12" name="">
             <a:extLst xmlns:a="http://schemas.openxmlformats.org/drawingml/2006/main">
               <a:ext uri="{FF2B5EF4-FFF2-40B4-BE49-F238E27FC236}">
-                <a16:creationId xmlns:a16="http://schemas.microsoft.com/office/drawing/2014/main" id="{A1EE36EE-F646-48F1-96F2-835A601A2CA7}"/>
+                <a16:creationId xmlns:a16="http://schemas.microsoft.com/office/drawing/2014/main" id="{E038FC21-F7E5-4690-96E0-13528B79B0EB}"/>
               </a:ext>
             </a:extLst>
           </p:cNvPr>
@@ -4474,7 +4474,7 @@
           <p:cNvPr id="13" name="">
             <a:extLst xmlns:a="http://schemas.openxmlformats.org/drawingml/2006/main">
               <a:ext uri="{FF2B5EF4-FFF2-40B4-BE49-F238E27FC236}">
-                <a16:creationId xmlns:a16="http://schemas.microsoft.com/office/drawing/2014/main" id="{0819A2FB-6A75-4C06-9DAD-C40190DBEFF6}"/>
+                <a16:creationId xmlns:a16="http://schemas.microsoft.com/office/drawing/2014/main" id="{6AE7775D-1D44-4A32-A9B2-1AFD36A14B5B}"/>
               </a:ext>
             </a:extLst>
           </p:cNvPr>
@@ -4509,7 +4509,7 @@
           <p:cNvPr id="14" name="">
             <a:extLst xmlns:a="http://schemas.openxmlformats.org/drawingml/2006/main">
               <a:ext uri="{FF2B5EF4-FFF2-40B4-BE49-F238E27FC236}">
-                <a16:creationId xmlns:a16="http://schemas.microsoft.com/office/drawing/2014/main" id="{1A42C413-F656-4187-AE1E-8B714DDB85B6}"/>
+                <a16:creationId xmlns:a16="http://schemas.microsoft.com/office/drawing/2014/main" id="{AABB63FB-4F8D-4E8B-8709-E5763B001BB8}"/>
               </a:ext>
             </a:extLst>
           </p:cNvPr>
@@ -4542,7 +4542,7 @@
           <p:cNvPr id="15" name="">
             <a:extLst xmlns:a="http://schemas.openxmlformats.org/drawingml/2006/main">
               <a:ext uri="{FF2B5EF4-FFF2-40B4-BE49-F238E27FC236}">
-                <a16:creationId xmlns:a16="http://schemas.microsoft.com/office/drawing/2014/main" id="{6E7E8EE8-603F-4E05-A7B8-EE9BFD82B182}"/>
+                <a16:creationId xmlns:a16="http://schemas.microsoft.com/office/drawing/2014/main" id="{631EFA79-047B-477F-AE62-F18942D88AC7}"/>
               </a:ext>
             </a:extLst>
           </p:cNvPr>
@@ -4592,7 +4592,7 @@
           <p:cNvPr id="16" name="">
             <a:extLst xmlns:a="http://schemas.openxmlformats.org/drawingml/2006/main">
               <a:ext uri="{FF2B5EF4-FFF2-40B4-BE49-F238E27FC236}">
-                <a16:creationId xmlns:a16="http://schemas.microsoft.com/office/drawing/2014/main" id="{CBE9DEE6-3B65-4005-99B1-8292031DB25C}"/>
+                <a16:creationId xmlns:a16="http://schemas.microsoft.com/office/drawing/2014/main" id="{0AFB6765-9424-4588-8FCC-AA00819A191C}"/>
               </a:ext>
             </a:extLst>
           </p:cNvPr>
@@ -4642,7 +4642,7 @@
           <p:cNvPr id="17" name="">
             <a:extLst xmlns:a="http://schemas.openxmlformats.org/drawingml/2006/main">
               <a:ext uri="{FF2B5EF4-FFF2-40B4-BE49-F238E27FC236}">
-                <a16:creationId xmlns:a16="http://schemas.microsoft.com/office/drawing/2014/main" id="{F67C3342-D73B-4325-BA26-AEFD433990BC}"/>
+                <a16:creationId xmlns:a16="http://schemas.microsoft.com/office/drawing/2014/main" id="{901D3CA6-DBE8-4700-A5BE-A6908EAF2C60}"/>
               </a:ext>
             </a:extLst>
           </p:cNvPr>
@@ -4692,7 +4692,7 @@
           <p:cNvPr id="18" name="">
             <a:extLst xmlns:a="http://schemas.openxmlformats.org/drawingml/2006/main">
               <a:ext uri="{FF2B5EF4-FFF2-40B4-BE49-F238E27FC236}">
-                <a16:creationId xmlns:a16="http://schemas.microsoft.com/office/drawing/2014/main" id="{EF0C7EDC-D206-4906-B64A-E20642D3BECC}"/>
+                <a16:creationId xmlns:a16="http://schemas.microsoft.com/office/drawing/2014/main" id="{76983462-6271-4230-B1DD-F7CEB04467E9}"/>
               </a:ext>
             </a:extLst>
           </p:cNvPr>
@@ -4742,7 +4742,7 @@
           <p:cNvPr id="19" name="">
             <a:extLst xmlns:a="http://schemas.openxmlformats.org/drawingml/2006/main">
               <a:ext uri="{FF2B5EF4-FFF2-40B4-BE49-F238E27FC236}">
-                <a16:creationId xmlns:a16="http://schemas.microsoft.com/office/drawing/2014/main" id="{CD5ACB2F-0567-4A5C-8FC0-FF7BBE88FD2D}"/>
+                <a16:creationId xmlns:a16="http://schemas.microsoft.com/office/drawing/2014/main" id="{E7B188C9-A161-4ECC-9989-3F992327F06D}"/>
               </a:ext>
             </a:extLst>
           </p:cNvPr>
@@ -4775,7 +4775,7 @@
           <p:cNvPr id="20" name="">
             <a:extLst xmlns:a="http://schemas.openxmlformats.org/drawingml/2006/main">
               <a:ext uri="{FF2B5EF4-FFF2-40B4-BE49-F238E27FC236}">
-                <a16:creationId xmlns:a16="http://schemas.microsoft.com/office/drawing/2014/main" id="{EEA29CDE-E5C7-440E-8073-5BB027C38BC3}"/>
+                <a16:creationId xmlns:a16="http://schemas.microsoft.com/office/drawing/2014/main" id="{BDD079E6-A086-47EB-B6C9-5C1CA817D974}"/>
               </a:ext>
             </a:extLst>
           </p:cNvPr>
@@ -4825,7 +4825,7 @@
           <p:cNvPr id="21" name="">
             <a:extLst xmlns:a="http://schemas.openxmlformats.org/drawingml/2006/main">
               <a:ext uri="{FF2B5EF4-FFF2-40B4-BE49-F238E27FC236}">
-                <a16:creationId xmlns:a16="http://schemas.microsoft.com/office/drawing/2014/main" id="{3E1FF88A-AAA3-4E8C-9FCA-AED68D80BD52}"/>
+                <a16:creationId xmlns:a16="http://schemas.microsoft.com/office/drawing/2014/main" id="{ECB0758B-718B-4208-AFFC-93C29184F14A}"/>
               </a:ext>
             </a:extLst>
           </p:cNvPr>
@@ -4875,7 +4875,7 @@
           <p:cNvPr id="22" name="">
             <a:extLst xmlns:a="http://schemas.openxmlformats.org/drawingml/2006/main">
               <a:ext uri="{FF2B5EF4-FFF2-40B4-BE49-F238E27FC236}">
-                <a16:creationId xmlns:a16="http://schemas.microsoft.com/office/drawing/2014/main" id="{37973E61-D852-4D77-8546-31F46DC6CCB8}"/>
+                <a16:creationId xmlns:a16="http://schemas.microsoft.com/office/drawing/2014/main" id="{651DAADB-6072-4BE6-B9B1-A97DD436B4BC}"/>
               </a:ext>
             </a:extLst>
           </p:cNvPr>
@@ -4908,7 +4908,7 @@
           <p:cNvPr id="23" name="">
             <a:extLst xmlns:a="http://schemas.openxmlformats.org/drawingml/2006/main">
               <a:ext uri="{FF2B5EF4-FFF2-40B4-BE49-F238E27FC236}">
-                <a16:creationId xmlns:a16="http://schemas.microsoft.com/office/drawing/2014/main" id="{01996694-2C43-423E-A663-44CB660FE5A9}"/>
+                <a16:creationId xmlns:a16="http://schemas.microsoft.com/office/drawing/2014/main" id="{E7E48A68-3D79-4E83-83C4-452C2CAB6444}"/>
               </a:ext>
             </a:extLst>
           </p:cNvPr>
@@ -4958,7 +4958,7 @@
           <p:cNvPr id="24" name="">
             <a:extLst xmlns:a="http://schemas.openxmlformats.org/drawingml/2006/main">
               <a:ext uri="{FF2B5EF4-FFF2-40B4-BE49-F238E27FC236}">
-                <a16:creationId xmlns:a16="http://schemas.microsoft.com/office/drawing/2014/main" id="{BF73173E-0022-4522-886C-E7AB2B6201A5}"/>
+                <a16:creationId xmlns:a16="http://schemas.microsoft.com/office/drawing/2014/main" id="{70B72E12-3FDD-4633-A07C-91FADFD52B31}"/>
               </a:ext>
             </a:extLst>
           </p:cNvPr>
@@ -5006,7 +5006,7 @@
     </p:spTree>
     <p:extLst>
       <p:ext uri="{BB962C8B-B14F-4D97-AF65-F5344CB8AC3E}">
-        <p14:creationId xmlns:p14="http://schemas.microsoft.com/office/powerpoint/2010/main" val="139728294"/>
+        <p14:creationId xmlns:p14="http://schemas.microsoft.com/office/powerpoint/2010/main" val="856164794"/>
       </p:ext>
     </p:extLst>
   </p:cSld>
@@ -5037,7 +5037,7 @@
           <p:cNvPr id="28" name="">
             <a:extLst xmlns:a="http://schemas.openxmlformats.org/drawingml/2006/main">
               <a:ext uri="{FF2B5EF4-FFF2-40B4-BE49-F238E27FC236}">
-                <a16:creationId xmlns:a16="http://schemas.microsoft.com/office/drawing/2014/main" id="{B1A2E003-18ED-4D23-A8E9-E6DC06B473EB}"/>
+                <a16:creationId xmlns:a16="http://schemas.microsoft.com/office/drawing/2014/main" id="{F788D732-B68D-4FAA-9560-B0DF1D237F1F}"/>
               </a:ext>
             </a:extLst>
           </p:cNvPr>
@@ -5070,7 +5070,7 @@
           <p:cNvPr id="2" name="">
             <a:extLst xmlns:a="http://schemas.openxmlformats.org/drawingml/2006/main">
               <a:ext uri="{FF2B5EF4-FFF2-40B4-BE49-F238E27FC236}">
-                <a16:creationId xmlns:a16="http://schemas.microsoft.com/office/drawing/2014/main" id="{E98CC226-8980-40BA-A703-1A01C22DA114}"/>
+                <a16:creationId xmlns:a16="http://schemas.microsoft.com/office/drawing/2014/main" id="{F9E2E8A6-F8E8-4D5C-AE35-89E55DEA78DC}"/>
               </a:ext>
             </a:extLst>
           </p:cNvPr>
@@ -5120,7 +5120,7 @@
           <p:cNvPr id="3" name="">
             <a:extLst xmlns:a="http://schemas.openxmlformats.org/drawingml/2006/main">
               <a:ext uri="{FF2B5EF4-FFF2-40B4-BE49-F238E27FC236}">
-                <a16:creationId xmlns:a16="http://schemas.microsoft.com/office/drawing/2014/main" id="{94ACB97B-A5DE-4827-A234-019B02F38640}"/>
+                <a16:creationId xmlns:a16="http://schemas.microsoft.com/office/drawing/2014/main" id="{72BAD747-57A9-4649-A7A6-A59FC0E72552}"/>
               </a:ext>
             </a:extLst>
           </p:cNvPr>
@@ -5170,7 +5170,7 @@
           <p:cNvPr id="4" name="">
             <a:extLst xmlns:a="http://schemas.openxmlformats.org/drawingml/2006/main">
               <a:ext uri="{FF2B5EF4-FFF2-40B4-BE49-F238E27FC236}">
-                <a16:creationId xmlns:a16="http://schemas.microsoft.com/office/drawing/2014/main" id="{A3FDE671-A5F7-4969-AF87-99C08C219226}"/>
+                <a16:creationId xmlns:a16="http://schemas.microsoft.com/office/drawing/2014/main" id="{DAD38CD5-C8AA-4BF8-95CC-A4A4F2A69C36}"/>
               </a:ext>
             </a:extLst>
           </p:cNvPr>
@@ -5220,7 +5220,7 @@
           <p:cNvPr id="5" name="">
             <a:extLst xmlns:a="http://schemas.openxmlformats.org/drawingml/2006/main">
               <a:ext uri="{FF2B5EF4-FFF2-40B4-BE49-F238E27FC236}">
-                <a16:creationId xmlns:a16="http://schemas.microsoft.com/office/drawing/2014/main" id="{52D7E308-375E-4DCE-908D-84BE5BF4CBC9}"/>
+                <a16:creationId xmlns:a16="http://schemas.microsoft.com/office/drawing/2014/main" id="{5A60F18C-36FE-462B-86BE-B49C45F1F5FB}"/>
               </a:ext>
             </a:extLst>
           </p:cNvPr>
@@ -5270,7 +5270,7 @@
           <p:cNvPr id="6" name="">
             <a:extLst xmlns:a="http://schemas.openxmlformats.org/drawingml/2006/main">
               <a:ext uri="{FF2B5EF4-FFF2-40B4-BE49-F238E27FC236}">
-                <a16:creationId xmlns:a16="http://schemas.microsoft.com/office/drawing/2014/main" id="{0CE14860-8C2C-4D16-8F3A-0E241BB59686}"/>
+                <a16:creationId xmlns:a16="http://schemas.microsoft.com/office/drawing/2014/main" id="{AC577EA7-23E6-4F03-9C63-1FC81F3B7FBC}"/>
               </a:ext>
             </a:extLst>
           </p:cNvPr>
@@ -5303,7 +5303,7 @@
           <p:cNvPr id="7" name="">
             <a:extLst xmlns:a="http://schemas.openxmlformats.org/drawingml/2006/main">
               <a:ext uri="{FF2B5EF4-FFF2-40B4-BE49-F238E27FC236}">
-                <a16:creationId xmlns:a16="http://schemas.microsoft.com/office/drawing/2014/main" id="{910A5F5F-AF06-4DBB-8442-2A283CB1216A}"/>
+                <a16:creationId xmlns:a16="http://schemas.microsoft.com/office/drawing/2014/main" id="{DA9B4C4E-EBC7-481D-AA68-E2202B0472D9}"/>
               </a:ext>
             </a:extLst>
           </p:cNvPr>
@@ -5338,7 +5338,7 @@
           <p:cNvPr id="8" name="">
             <a:extLst xmlns:a="http://schemas.openxmlformats.org/drawingml/2006/main">
               <a:ext uri="{FF2B5EF4-FFF2-40B4-BE49-F238E27FC236}">
-                <a16:creationId xmlns:a16="http://schemas.microsoft.com/office/drawing/2014/main" id="{DAF2ACF8-1B60-4BA9-93E3-380D13951B6B}"/>
+                <a16:creationId xmlns:a16="http://schemas.microsoft.com/office/drawing/2014/main" id="{BC50B1CA-F7AB-4C7B-AB71-FA99F66BA638}"/>
               </a:ext>
             </a:extLst>
           </p:cNvPr>
@@ -5371,7 +5371,7 @@
           <p:cNvPr id="9" name="">
             <a:extLst xmlns:a="http://schemas.openxmlformats.org/drawingml/2006/main">
               <a:ext uri="{FF2B5EF4-FFF2-40B4-BE49-F238E27FC236}">
-                <a16:creationId xmlns:a16="http://schemas.microsoft.com/office/drawing/2014/main" id="{DA4702AE-23BC-457C-A846-1A1EBD614B9B}"/>
+                <a16:creationId xmlns:a16="http://schemas.microsoft.com/office/drawing/2014/main" id="{6F46379E-939E-4F7A-B1DF-41134D44B7BF}"/>
               </a:ext>
             </a:extLst>
           </p:cNvPr>
@@ -5421,7 +5421,7 @@
           <p:cNvPr id="10" name="">
             <a:extLst xmlns:a="http://schemas.openxmlformats.org/drawingml/2006/main">
               <a:ext uri="{FF2B5EF4-FFF2-40B4-BE49-F238E27FC236}">
-                <a16:creationId xmlns:a16="http://schemas.microsoft.com/office/drawing/2014/main" id="{2608B790-FBCD-4DEF-92A3-385FB14841C7}"/>
+                <a16:creationId xmlns:a16="http://schemas.microsoft.com/office/drawing/2014/main" id="{C1B50BC0-7EDC-406A-BA2F-EA5685EC9ADB}"/>
               </a:ext>
             </a:extLst>
           </p:cNvPr>
@@ -5471,7 +5471,7 @@
           <p:cNvPr id="11" name="">
             <a:extLst xmlns:a="http://schemas.openxmlformats.org/drawingml/2006/main">
               <a:ext uri="{FF2B5EF4-FFF2-40B4-BE49-F238E27FC236}">
-                <a16:creationId xmlns:a16="http://schemas.microsoft.com/office/drawing/2014/main" id="{636C68D9-D9B9-47E3-BD3F-C834D306341F}"/>
+                <a16:creationId xmlns:a16="http://schemas.microsoft.com/office/drawing/2014/main" id="{DC3B9F90-AA81-4D21-9AC3-9FDAAE4B0BC7}"/>
               </a:ext>
             </a:extLst>
           </p:cNvPr>
@@ -5521,7 +5521,7 @@
           <p:cNvPr id="12" name="">
             <a:extLst xmlns:a="http://schemas.openxmlformats.org/drawingml/2006/main">
               <a:ext uri="{FF2B5EF4-FFF2-40B4-BE49-F238E27FC236}">
-                <a16:creationId xmlns:a16="http://schemas.microsoft.com/office/drawing/2014/main" id="{26C63A22-E4D1-4E7B-BCF8-73134949800A}"/>
+                <a16:creationId xmlns:a16="http://schemas.microsoft.com/office/drawing/2014/main" id="{22609069-C782-4FFE-891A-77B0746DAE45}"/>
               </a:ext>
             </a:extLst>
           </p:cNvPr>
@@ -5571,7 +5571,7 @@
           <p:cNvPr id="13" name="">
             <a:extLst xmlns:a="http://schemas.openxmlformats.org/drawingml/2006/main">
               <a:ext uri="{FF2B5EF4-FFF2-40B4-BE49-F238E27FC236}">
-                <a16:creationId xmlns:a16="http://schemas.microsoft.com/office/drawing/2014/main" id="{16179CA9-E9AA-4A59-A040-B54FFC8FEB9D}"/>
+                <a16:creationId xmlns:a16="http://schemas.microsoft.com/office/drawing/2014/main" id="{5D7AC6EB-A0B0-4182-BE6E-09C798C2AA8B}"/>
               </a:ext>
             </a:extLst>
           </p:cNvPr>
@@ -5604,7 +5604,7 @@
           <p:cNvPr id="14" name="">
             <a:extLst xmlns:a="http://schemas.openxmlformats.org/drawingml/2006/main">
               <a:ext uri="{FF2B5EF4-FFF2-40B4-BE49-F238E27FC236}">
-                <a16:creationId xmlns:a16="http://schemas.microsoft.com/office/drawing/2014/main" id="{0F75D621-B612-4FDF-8A33-6E8EFCB258AC}"/>
+                <a16:creationId xmlns:a16="http://schemas.microsoft.com/office/drawing/2014/main" id="{51195C88-188B-4D2B-BD1D-8A06AD392923}"/>
               </a:ext>
             </a:extLst>
           </p:cNvPr>
@@ -5671,7 +5671,7 @@
           <p:cNvPr id="15" name="">
             <a:extLst xmlns:a="http://schemas.openxmlformats.org/drawingml/2006/main">
               <a:ext uri="{FF2B5EF4-FFF2-40B4-BE49-F238E27FC236}">
-                <a16:creationId xmlns:a16="http://schemas.microsoft.com/office/drawing/2014/main" id="{4D75CC4F-9173-477F-B944-E4BF8D5F8F8F}"/>
+                <a16:creationId xmlns:a16="http://schemas.microsoft.com/office/drawing/2014/main" id="{7EB1E26E-6AB1-44CF-8612-F98E3B31D93E}"/>
               </a:ext>
             </a:extLst>
           </p:cNvPr>
@@ -5738,7 +5738,7 @@
           <p:cNvPr id="16" name="">
             <a:extLst xmlns:a="http://schemas.openxmlformats.org/drawingml/2006/main">
               <a:ext uri="{FF2B5EF4-FFF2-40B4-BE49-F238E27FC236}">
-                <a16:creationId xmlns:a16="http://schemas.microsoft.com/office/drawing/2014/main" id="{1CB2ED31-9A19-45D4-BEEC-854005CD8E59}"/>
+                <a16:creationId xmlns:a16="http://schemas.microsoft.com/office/drawing/2014/main" id="{58783EE2-6650-4B73-8542-3EF9BB8CC350}"/>
               </a:ext>
             </a:extLst>
           </p:cNvPr>
@@ -5773,7 +5773,7 @@
           <p:cNvPr id="17" name="">
             <a:extLst xmlns:a="http://schemas.openxmlformats.org/drawingml/2006/main">
               <a:ext uri="{FF2B5EF4-FFF2-40B4-BE49-F238E27FC236}">
-                <a16:creationId xmlns:a16="http://schemas.microsoft.com/office/drawing/2014/main" id="{BB72E940-0366-4FC6-9892-48FD77783E75}"/>
+                <a16:creationId xmlns:a16="http://schemas.microsoft.com/office/drawing/2014/main" id="{4B41417C-7B14-437F-BE1E-B38B62D44970}"/>
               </a:ext>
             </a:extLst>
           </p:cNvPr>
@@ -5806,7 +5806,7 @@
           <p:cNvPr id="18" name="">
             <a:extLst xmlns:a="http://schemas.openxmlformats.org/drawingml/2006/main">
               <a:ext uri="{FF2B5EF4-FFF2-40B4-BE49-F238E27FC236}">
-                <a16:creationId xmlns:a16="http://schemas.microsoft.com/office/drawing/2014/main" id="{42BD2A14-9AFC-426E-93FE-160A9624F81D}"/>
+                <a16:creationId xmlns:a16="http://schemas.microsoft.com/office/drawing/2014/main" id="{F3C405B5-2F13-4273-8ABD-25CF3C49EC58}"/>
               </a:ext>
             </a:extLst>
           </p:cNvPr>
@@ -5856,7 +5856,7 @@
           <p:cNvPr id="19" name="">
             <a:extLst xmlns:a="http://schemas.openxmlformats.org/drawingml/2006/main">
               <a:ext uri="{FF2B5EF4-FFF2-40B4-BE49-F238E27FC236}">
-                <a16:creationId xmlns:a16="http://schemas.microsoft.com/office/drawing/2014/main" id="{A6124F6D-205F-4B24-9ECD-452BD6C0BB3D}"/>
+                <a16:creationId xmlns:a16="http://schemas.microsoft.com/office/drawing/2014/main" id="{18CA2C54-C8CC-4D1D-8082-CEA6F2D9CBC0}"/>
               </a:ext>
             </a:extLst>
           </p:cNvPr>
@@ -5906,7 +5906,7 @@
           <p:cNvPr id="20" name="">
             <a:extLst xmlns:a="http://schemas.openxmlformats.org/drawingml/2006/main">
               <a:ext uri="{FF2B5EF4-FFF2-40B4-BE49-F238E27FC236}">
-                <a16:creationId xmlns:a16="http://schemas.microsoft.com/office/drawing/2014/main" id="{0F7EB3D6-D0F6-4B9B-B199-5ADB123DE2E4}"/>
+                <a16:creationId xmlns:a16="http://schemas.microsoft.com/office/drawing/2014/main" id="{35EB7E02-7F70-40D1-8274-95AE4B2858D8}"/>
               </a:ext>
             </a:extLst>
           </p:cNvPr>
@@ -5956,7 +5956,7 @@
           <p:cNvPr id="21" name="">
             <a:extLst xmlns:a="http://schemas.openxmlformats.org/drawingml/2006/main">
               <a:ext uri="{FF2B5EF4-FFF2-40B4-BE49-F238E27FC236}">
-                <a16:creationId xmlns:a16="http://schemas.microsoft.com/office/drawing/2014/main" id="{E03BD817-8CF6-4DF7-93AB-676C8596AB5F}"/>
+                <a16:creationId xmlns:a16="http://schemas.microsoft.com/office/drawing/2014/main" id="{064A55B2-85C8-4C5F-BAF1-1CD515C35FAE}"/>
               </a:ext>
             </a:extLst>
           </p:cNvPr>
@@ -6006,7 +6006,7 @@
           <p:cNvPr id="22" name="">
             <a:extLst xmlns:a="http://schemas.openxmlformats.org/drawingml/2006/main">
               <a:ext uri="{FF2B5EF4-FFF2-40B4-BE49-F238E27FC236}">
-                <a16:creationId xmlns:a16="http://schemas.microsoft.com/office/drawing/2014/main" id="{4855DDD1-249F-476B-9537-476185941D71}"/>
+                <a16:creationId xmlns:a16="http://schemas.microsoft.com/office/drawing/2014/main" id="{FBE425D8-AA4D-4CFC-950F-1FF6E05B9F30}"/>
               </a:ext>
             </a:extLst>
           </p:cNvPr>
@@ -6039,7 +6039,7 @@
           <p:cNvPr id="23" name="">
             <a:extLst xmlns:a="http://schemas.openxmlformats.org/drawingml/2006/main">
               <a:ext uri="{FF2B5EF4-FFF2-40B4-BE49-F238E27FC236}">
-                <a16:creationId xmlns:a16="http://schemas.microsoft.com/office/drawing/2014/main" id="{DA17B047-E937-4C19-AFAB-ECDBB2D0A435}"/>
+                <a16:creationId xmlns:a16="http://schemas.microsoft.com/office/drawing/2014/main" id="{42F6B707-E1C6-47D2-8C06-1601306553F7}"/>
               </a:ext>
             </a:extLst>
           </p:cNvPr>
@@ -6089,7 +6089,7 @@
           <p:cNvPr id="24" name="">
             <a:extLst xmlns:a="http://schemas.openxmlformats.org/drawingml/2006/main">
               <a:ext uri="{FF2B5EF4-FFF2-40B4-BE49-F238E27FC236}">
-                <a16:creationId xmlns:a16="http://schemas.microsoft.com/office/drawing/2014/main" id="{9D4B6457-7122-49A6-9DAB-1EDAB6ED86F3}"/>
+                <a16:creationId xmlns:a16="http://schemas.microsoft.com/office/drawing/2014/main" id="{F96725F1-CF87-4C64-A73D-9A56B05E2FE1}"/>
               </a:ext>
             </a:extLst>
           </p:cNvPr>
@@ -6139,7 +6139,7 @@
           <p:cNvPr id="25" name="">
             <a:extLst xmlns:a="http://schemas.openxmlformats.org/drawingml/2006/main">
               <a:ext uri="{FF2B5EF4-FFF2-40B4-BE49-F238E27FC236}">
-                <a16:creationId xmlns:a16="http://schemas.microsoft.com/office/drawing/2014/main" id="{CD56E55C-F0A3-4AFF-AE98-6D6B0E79D93E}"/>
+                <a16:creationId xmlns:a16="http://schemas.microsoft.com/office/drawing/2014/main" id="{C60B89CD-A3B9-4499-938E-C8F7268E1A43}"/>
               </a:ext>
             </a:extLst>
           </p:cNvPr>
@@ -6172,7 +6172,7 @@
           <p:cNvPr id="26" name="">
             <a:extLst xmlns:a="http://schemas.openxmlformats.org/drawingml/2006/main">
               <a:ext uri="{FF2B5EF4-FFF2-40B4-BE49-F238E27FC236}">
-                <a16:creationId xmlns:a16="http://schemas.microsoft.com/office/drawing/2014/main" id="{55BF21BE-B38E-4762-B1E5-82F0CF1E6422}"/>
+                <a16:creationId xmlns:a16="http://schemas.microsoft.com/office/drawing/2014/main" id="{9AD32A3D-C0AD-4C07-84D4-4BA5910C6A72}"/>
               </a:ext>
             </a:extLst>
           </p:cNvPr>
@@ -6222,7 +6222,7 @@
           <p:cNvPr id="27" name="">
             <a:extLst xmlns:a="http://schemas.openxmlformats.org/drawingml/2006/main">
               <a:ext uri="{FF2B5EF4-FFF2-40B4-BE49-F238E27FC236}">
-                <a16:creationId xmlns:a16="http://schemas.microsoft.com/office/drawing/2014/main" id="{613A5E22-BDC5-41C3-A976-8A5F320C17DB}"/>
+                <a16:creationId xmlns:a16="http://schemas.microsoft.com/office/drawing/2014/main" id="{7FE20F14-F94F-4D14-8D66-76CDF2487DED}"/>
               </a:ext>
             </a:extLst>
           </p:cNvPr>
@@ -6270,7 +6270,7 @@
     </p:spTree>
     <p:extLst>
       <p:ext uri="{BB962C8B-B14F-4D97-AF65-F5344CB8AC3E}">
-        <p14:creationId xmlns:p14="http://schemas.microsoft.com/office/powerpoint/2010/main" val="1958643436"/>
+        <p14:creationId xmlns:p14="http://schemas.microsoft.com/office/powerpoint/2010/main" val="1189902132"/>
       </p:ext>
     </p:extLst>
   </p:cSld>
@@ -6301,7 +6301,7 @@
           <p:cNvPr id="46" name="">
             <a:extLst xmlns:a="http://schemas.openxmlformats.org/drawingml/2006/main">
               <a:ext uri="{FF2B5EF4-FFF2-40B4-BE49-F238E27FC236}">
-                <a16:creationId xmlns:a16="http://schemas.microsoft.com/office/drawing/2014/main" id="{ABF812AD-EFAE-4EF7-9F63-968C9AE8771E}"/>
+                <a16:creationId xmlns:a16="http://schemas.microsoft.com/office/drawing/2014/main" id="{D0E4E2A9-10EB-4F73-8AD0-35AC4A9B63BF}"/>
               </a:ext>
             </a:extLst>
           </p:cNvPr>
@@ -6334,7 +6334,7 @@
           <p:cNvPr id="2" name="">
             <a:extLst xmlns:a="http://schemas.openxmlformats.org/drawingml/2006/main">
               <a:ext uri="{FF2B5EF4-FFF2-40B4-BE49-F238E27FC236}">
-                <a16:creationId xmlns:a16="http://schemas.microsoft.com/office/drawing/2014/main" id="{6384D876-9B01-40F5-AD41-CC1E1ABB07E0}"/>
+                <a16:creationId xmlns:a16="http://schemas.microsoft.com/office/drawing/2014/main" id="{93DFB880-2093-4D2A-9C8E-E2139866A9B3}"/>
               </a:ext>
             </a:extLst>
           </p:cNvPr>
@@ -6384,7 +6384,7 @@
           <p:cNvPr id="3" name="">
             <a:extLst xmlns:a="http://schemas.openxmlformats.org/drawingml/2006/main">
               <a:ext uri="{FF2B5EF4-FFF2-40B4-BE49-F238E27FC236}">
-                <a16:creationId xmlns:a16="http://schemas.microsoft.com/office/drawing/2014/main" id="{96CE8AE5-C7E1-4CE3-8F8B-B092F13FE8B3}"/>
+                <a16:creationId xmlns:a16="http://schemas.microsoft.com/office/drawing/2014/main" id="{F04C6836-06B8-4E46-A8B5-FBE35131D277}"/>
               </a:ext>
             </a:extLst>
           </p:cNvPr>
@@ -6434,7 +6434,7 @@
           <p:cNvPr id="4" name="">
             <a:extLst xmlns:a="http://schemas.openxmlformats.org/drawingml/2006/main">
               <a:ext uri="{FF2B5EF4-FFF2-40B4-BE49-F238E27FC236}">
-                <a16:creationId xmlns:a16="http://schemas.microsoft.com/office/drawing/2014/main" id="{A4AB01D5-7B2E-47AE-BF12-FDE237851616}"/>
+                <a16:creationId xmlns:a16="http://schemas.microsoft.com/office/drawing/2014/main" id="{6348FE81-728C-45CF-9D9F-83359878A746}"/>
               </a:ext>
             </a:extLst>
           </p:cNvPr>
@@ -6484,7 +6484,7 @@
           <p:cNvPr id="5" name="">
             <a:extLst xmlns:a="http://schemas.openxmlformats.org/drawingml/2006/main">
               <a:ext uri="{FF2B5EF4-FFF2-40B4-BE49-F238E27FC236}">
-                <a16:creationId xmlns:a16="http://schemas.microsoft.com/office/drawing/2014/main" id="{AB70401E-CB9B-498F-AA44-03416D4BD454}"/>
+                <a16:creationId xmlns:a16="http://schemas.microsoft.com/office/drawing/2014/main" id="{B76468B1-B24D-4EA0-B56B-0AA56E6FEFEF}"/>
               </a:ext>
             </a:extLst>
           </p:cNvPr>
@@ -6534,7 +6534,7 @@
           <p:cNvPr id="6" name="">
             <a:extLst xmlns:a="http://schemas.openxmlformats.org/drawingml/2006/main">
               <a:ext uri="{FF2B5EF4-FFF2-40B4-BE49-F238E27FC236}">
-                <a16:creationId xmlns:a16="http://schemas.microsoft.com/office/drawing/2014/main" id="{F4F8EFD0-A47F-4270-B7A0-A2BF8519E6A1}"/>
+                <a16:creationId xmlns:a16="http://schemas.microsoft.com/office/drawing/2014/main" id="{918C6391-3A0D-4E57-BFB7-C55E6DD8BBFB}"/>
               </a:ext>
             </a:extLst>
           </p:cNvPr>
@@ -6567,7 +6567,7 @@
           <p:cNvPr id="7" name="">
             <a:extLst xmlns:a="http://schemas.openxmlformats.org/drawingml/2006/main">
               <a:ext uri="{FF2B5EF4-FFF2-40B4-BE49-F238E27FC236}">
-                <a16:creationId xmlns:a16="http://schemas.microsoft.com/office/drawing/2014/main" id="{6BB839E4-D8F5-4FAA-AEE0-24C9CC596DB1}"/>
+                <a16:creationId xmlns:a16="http://schemas.microsoft.com/office/drawing/2014/main" id="{B89BF774-D0DC-4E28-9DBE-876CC2E093DB}"/>
               </a:ext>
             </a:extLst>
           </p:cNvPr>
@@ -6602,7 +6602,7 @@
           <p:cNvPr id="8" name="">
             <a:extLst xmlns:a="http://schemas.openxmlformats.org/drawingml/2006/main">
               <a:ext uri="{FF2B5EF4-FFF2-40B4-BE49-F238E27FC236}">
-                <a16:creationId xmlns:a16="http://schemas.microsoft.com/office/drawing/2014/main" id="{41F15FB3-3634-4A16-B2B3-B081004360F2}"/>
+                <a16:creationId xmlns:a16="http://schemas.microsoft.com/office/drawing/2014/main" id="{E2052DAF-13D2-4FE7-A5FD-C964C0C7D2D3}"/>
               </a:ext>
             </a:extLst>
           </p:cNvPr>
@@ -6635,7 +6635,7 @@
           <p:cNvPr id="9" name="">
             <a:extLst xmlns:a="http://schemas.openxmlformats.org/drawingml/2006/main">
               <a:ext uri="{FF2B5EF4-FFF2-40B4-BE49-F238E27FC236}">
-                <a16:creationId xmlns:a16="http://schemas.microsoft.com/office/drawing/2014/main" id="{A3E4FAB7-9B75-4A54-8CEC-3437BE5F29E8}"/>
+                <a16:creationId xmlns:a16="http://schemas.microsoft.com/office/drawing/2014/main" id="{08530201-8D4E-4317-B12C-6C8D55CD8EC8}"/>
               </a:ext>
             </a:extLst>
           </p:cNvPr>
@@ -6685,7 +6685,7 @@
           <p:cNvPr id="10" name="">
             <a:extLst xmlns:a="http://schemas.openxmlformats.org/drawingml/2006/main">
               <a:ext uri="{FF2B5EF4-FFF2-40B4-BE49-F238E27FC236}">
-                <a16:creationId xmlns:a16="http://schemas.microsoft.com/office/drawing/2014/main" id="{36533974-E9FB-49CA-ADB9-1FDA06658193}"/>
+                <a16:creationId xmlns:a16="http://schemas.microsoft.com/office/drawing/2014/main" id="{33A4A9B5-1C58-4DA2-A0D0-C373327326D9}"/>
               </a:ext>
             </a:extLst>
           </p:cNvPr>
@@ -6735,7 +6735,7 @@
           <p:cNvPr id="11" name="">
             <a:extLst xmlns:a="http://schemas.openxmlformats.org/drawingml/2006/main">
               <a:ext uri="{FF2B5EF4-FFF2-40B4-BE49-F238E27FC236}">
-                <a16:creationId xmlns:a16="http://schemas.microsoft.com/office/drawing/2014/main" id="{604085A7-98D9-4D1D-AD1D-DD9B773ED28D}"/>
+                <a16:creationId xmlns:a16="http://schemas.microsoft.com/office/drawing/2014/main" id="{62D04AAA-C18E-46DC-9E93-E31A8C78344D}"/>
               </a:ext>
             </a:extLst>
           </p:cNvPr>
@@ -6785,7 +6785,7 @@
           <p:cNvPr id="12" name="">
             <a:extLst xmlns:a="http://schemas.openxmlformats.org/drawingml/2006/main">
               <a:ext uri="{FF2B5EF4-FFF2-40B4-BE49-F238E27FC236}">
-                <a16:creationId xmlns:a16="http://schemas.microsoft.com/office/drawing/2014/main" id="{CC746D13-DE59-4328-A2A7-BFF0537CDB7E}"/>
+                <a16:creationId xmlns:a16="http://schemas.microsoft.com/office/drawing/2014/main" id="{0681C8B7-460C-4958-A7FB-84549B7409AE}"/>
               </a:ext>
             </a:extLst>
           </p:cNvPr>
@@ -6835,7 +6835,7 @@
           <p:cNvPr id="13" name="">
             <a:extLst xmlns:a="http://schemas.openxmlformats.org/drawingml/2006/main">
               <a:ext uri="{FF2B5EF4-FFF2-40B4-BE49-F238E27FC236}">
-                <a16:creationId xmlns:a16="http://schemas.microsoft.com/office/drawing/2014/main" id="{53ABED44-5C15-4D88-963E-D5B1B4FE2BFD}"/>
+                <a16:creationId xmlns:a16="http://schemas.microsoft.com/office/drawing/2014/main" id="{BBA7F9CC-2243-42A4-88AD-2BA3AAA81397}"/>
               </a:ext>
             </a:extLst>
           </p:cNvPr>
@@ -6868,7 +6868,7 @@
           <p:cNvPr id="14" name="">
             <a:extLst xmlns:a="http://schemas.openxmlformats.org/drawingml/2006/main">
               <a:ext uri="{FF2B5EF4-FFF2-40B4-BE49-F238E27FC236}">
-                <a16:creationId xmlns:a16="http://schemas.microsoft.com/office/drawing/2014/main" id="{F6D6E8BF-8BA3-4E90-B07F-E068FFF4FA98}"/>
+                <a16:creationId xmlns:a16="http://schemas.microsoft.com/office/drawing/2014/main" id="{B21898E0-C3CA-4E23-BB01-2BFAE4CB27EA}"/>
               </a:ext>
             </a:extLst>
           </p:cNvPr>
@@ -6918,7 +6918,7 @@
           <p:cNvPr id="15" name="">
             <a:extLst xmlns:a="http://schemas.openxmlformats.org/drawingml/2006/main">
               <a:ext uri="{FF2B5EF4-FFF2-40B4-BE49-F238E27FC236}">
-                <a16:creationId xmlns:a16="http://schemas.microsoft.com/office/drawing/2014/main" id="{A2FF3E2B-F30C-4506-A342-38808AE967F2}"/>
+                <a16:creationId xmlns:a16="http://schemas.microsoft.com/office/drawing/2014/main" id="{4A1FE1BB-A4EB-42EF-A4DA-C9CA6D77675A}"/>
               </a:ext>
             </a:extLst>
           </p:cNvPr>
@@ -6968,7 +6968,7 @@
           <p:cNvPr id="16" name="">
             <a:extLst xmlns:a="http://schemas.openxmlformats.org/drawingml/2006/main">
               <a:ext uri="{FF2B5EF4-FFF2-40B4-BE49-F238E27FC236}">
-                <a16:creationId xmlns:a16="http://schemas.microsoft.com/office/drawing/2014/main" id="{94E5A1CB-1E5D-498D-9CF7-E7B9C9BBB33B}"/>
+                <a16:creationId xmlns:a16="http://schemas.microsoft.com/office/drawing/2014/main" id="{698E4E41-CECD-4768-9032-75E0D2AD9748}"/>
               </a:ext>
             </a:extLst>
           </p:cNvPr>
@@ -7003,7 +7003,7 @@
           <p:cNvPr id="17" name="">
             <a:extLst xmlns:a="http://schemas.openxmlformats.org/drawingml/2006/main">
               <a:ext uri="{FF2B5EF4-FFF2-40B4-BE49-F238E27FC236}">
-                <a16:creationId xmlns:a16="http://schemas.microsoft.com/office/drawing/2014/main" id="{49C6DFEA-3B10-47FE-A82E-E0FE3A58A4D2}"/>
+                <a16:creationId xmlns:a16="http://schemas.microsoft.com/office/drawing/2014/main" id="{73608987-25A9-4756-A510-37EC0BA51CFF}"/>
               </a:ext>
             </a:extLst>
           </p:cNvPr>
@@ -7036,7 +7036,7 @@
           <p:cNvPr id="18" name="">
             <a:extLst xmlns:a="http://schemas.openxmlformats.org/drawingml/2006/main">
               <a:ext uri="{FF2B5EF4-FFF2-40B4-BE49-F238E27FC236}">
-                <a16:creationId xmlns:a16="http://schemas.microsoft.com/office/drawing/2014/main" id="{AE06E858-1739-4588-A86E-90D0A60ED528}"/>
+                <a16:creationId xmlns:a16="http://schemas.microsoft.com/office/drawing/2014/main" id="{545E6B5A-1610-4825-8407-056121452CC7}"/>
               </a:ext>
             </a:extLst>
           </p:cNvPr>
@@ -7086,7 +7086,7 @@
           <p:cNvPr id="19" name="">
             <a:extLst xmlns:a="http://schemas.openxmlformats.org/drawingml/2006/main">
               <a:ext uri="{FF2B5EF4-FFF2-40B4-BE49-F238E27FC236}">
-                <a16:creationId xmlns:a16="http://schemas.microsoft.com/office/drawing/2014/main" id="{6E416F10-F653-4EBA-A126-730704B89204}"/>
+                <a16:creationId xmlns:a16="http://schemas.microsoft.com/office/drawing/2014/main" id="{62A7AE5E-604F-40C2-B2F1-E31104FB674A}"/>
               </a:ext>
             </a:extLst>
           </p:cNvPr>
@@ -7136,7 +7136,7 @@
           <p:cNvPr id="20" name="">
             <a:extLst xmlns:a="http://schemas.openxmlformats.org/drawingml/2006/main">
               <a:ext uri="{FF2B5EF4-FFF2-40B4-BE49-F238E27FC236}">
-                <a16:creationId xmlns:a16="http://schemas.microsoft.com/office/drawing/2014/main" id="{12821CC4-AAD4-485E-B7B4-D9EF9600CAE8}"/>
+                <a16:creationId xmlns:a16="http://schemas.microsoft.com/office/drawing/2014/main" id="{6382B582-6A1A-44DD-BFD8-1195FC85535B}"/>
               </a:ext>
             </a:extLst>
           </p:cNvPr>
@@ -7186,7 +7186,7 @@
           <p:cNvPr id="21" name="">
             <a:extLst xmlns:a="http://schemas.openxmlformats.org/drawingml/2006/main">
               <a:ext uri="{FF2B5EF4-FFF2-40B4-BE49-F238E27FC236}">
-                <a16:creationId xmlns:a16="http://schemas.microsoft.com/office/drawing/2014/main" id="{37920896-DB78-4884-A98C-6A29E8E252DF}"/>
+                <a16:creationId xmlns:a16="http://schemas.microsoft.com/office/drawing/2014/main" id="{A2F4EA70-381B-4C12-8BC5-FAE2521BB0DB}"/>
               </a:ext>
             </a:extLst>
           </p:cNvPr>
@@ -7236,7 +7236,7 @@
           <p:cNvPr id="22" name="">
             <a:extLst xmlns:a="http://schemas.openxmlformats.org/drawingml/2006/main">
               <a:ext uri="{FF2B5EF4-FFF2-40B4-BE49-F238E27FC236}">
-                <a16:creationId xmlns:a16="http://schemas.microsoft.com/office/drawing/2014/main" id="{BEC4624B-0DF8-42F1-BB78-6E2C84EF97C9}"/>
+                <a16:creationId xmlns:a16="http://schemas.microsoft.com/office/drawing/2014/main" id="{7CC185C8-1AC2-4ED2-9B62-10A09BAC906D}"/>
               </a:ext>
             </a:extLst>
           </p:cNvPr>
@@ -7269,7 +7269,7 @@
           <p:cNvPr id="23" name="">
             <a:extLst xmlns:a="http://schemas.openxmlformats.org/drawingml/2006/main">
               <a:ext uri="{FF2B5EF4-FFF2-40B4-BE49-F238E27FC236}">
-                <a16:creationId xmlns:a16="http://schemas.microsoft.com/office/drawing/2014/main" id="{EA270E7F-9059-4035-9CE5-17E8EF1E97D2}"/>
+                <a16:creationId xmlns:a16="http://schemas.microsoft.com/office/drawing/2014/main" id="{5E7AD087-E7D2-476A-BF3A-1F8605B76374}"/>
               </a:ext>
             </a:extLst>
           </p:cNvPr>
@@ -7319,7 +7319,7 @@
           <p:cNvPr id="24" name="">
             <a:extLst xmlns:a="http://schemas.openxmlformats.org/drawingml/2006/main">
               <a:ext uri="{FF2B5EF4-FFF2-40B4-BE49-F238E27FC236}">
-                <a16:creationId xmlns:a16="http://schemas.microsoft.com/office/drawing/2014/main" id="{84E1EB65-C8ED-4A75-8309-92210DCD8B10}"/>
+                <a16:creationId xmlns:a16="http://schemas.microsoft.com/office/drawing/2014/main" id="{51C1E3A7-73AC-4183-9F12-C34F7BB600B4}"/>
               </a:ext>
             </a:extLst>
           </p:cNvPr>
@@ -7369,7 +7369,7 @@
           <p:cNvPr id="25" name="">
             <a:extLst xmlns:a="http://schemas.openxmlformats.org/drawingml/2006/main">
               <a:ext uri="{FF2B5EF4-FFF2-40B4-BE49-F238E27FC236}">
-                <a16:creationId xmlns:a16="http://schemas.microsoft.com/office/drawing/2014/main" id="{361C9337-FD6B-4500-B0F3-56B57FE2FE50}"/>
+                <a16:creationId xmlns:a16="http://schemas.microsoft.com/office/drawing/2014/main" id="{83F1EE78-604A-4B3C-A677-A1579A021CAB}"/>
               </a:ext>
             </a:extLst>
           </p:cNvPr>
@@ -7404,7 +7404,7 @@
           <p:cNvPr id="26" name="">
             <a:extLst xmlns:a="http://schemas.openxmlformats.org/drawingml/2006/main">
               <a:ext uri="{FF2B5EF4-FFF2-40B4-BE49-F238E27FC236}">
-                <a16:creationId xmlns:a16="http://schemas.microsoft.com/office/drawing/2014/main" id="{D1438421-6BA4-4FC0-A931-EE8A8D9E8F05}"/>
+                <a16:creationId xmlns:a16="http://schemas.microsoft.com/office/drawing/2014/main" id="{BAA47AAB-C46F-4189-B7D8-CF3E2D8BD2D8}"/>
               </a:ext>
             </a:extLst>
           </p:cNvPr>
@@ -7437,7 +7437,7 @@
           <p:cNvPr id="27" name="">
             <a:extLst xmlns:a="http://schemas.openxmlformats.org/drawingml/2006/main">
               <a:ext uri="{FF2B5EF4-FFF2-40B4-BE49-F238E27FC236}">
-                <a16:creationId xmlns:a16="http://schemas.microsoft.com/office/drawing/2014/main" id="{3468AF11-16BD-4D29-A335-0F18346E11FA}"/>
+                <a16:creationId xmlns:a16="http://schemas.microsoft.com/office/drawing/2014/main" id="{801693AC-8DDD-4EE3-8821-177F7F46707C}"/>
               </a:ext>
             </a:extLst>
           </p:cNvPr>
@@ -7487,7 +7487,7 @@
           <p:cNvPr id="28" name="">
             <a:extLst xmlns:a="http://schemas.openxmlformats.org/drawingml/2006/main">
               <a:ext uri="{FF2B5EF4-FFF2-40B4-BE49-F238E27FC236}">
-                <a16:creationId xmlns:a16="http://schemas.microsoft.com/office/drawing/2014/main" id="{6EC866E1-D238-4A7D-94F6-AB02C8307E62}"/>
+                <a16:creationId xmlns:a16="http://schemas.microsoft.com/office/drawing/2014/main" id="{AE8BB8C8-7D35-48B4-AA02-754ECDC9A9A4}"/>
               </a:ext>
             </a:extLst>
           </p:cNvPr>
@@ -7537,7 +7537,7 @@
           <p:cNvPr id="29" name="">
             <a:extLst xmlns:a="http://schemas.openxmlformats.org/drawingml/2006/main">
               <a:ext uri="{FF2B5EF4-FFF2-40B4-BE49-F238E27FC236}">
-                <a16:creationId xmlns:a16="http://schemas.microsoft.com/office/drawing/2014/main" id="{DD3F1CDC-DE6E-42AA-BD7B-FCF105A9EF5D}"/>
+                <a16:creationId xmlns:a16="http://schemas.microsoft.com/office/drawing/2014/main" id="{1E4B5344-91C3-4622-800B-2AE3C852F4B2}"/>
               </a:ext>
             </a:extLst>
           </p:cNvPr>
@@ -7587,7 +7587,7 @@
           <p:cNvPr id="30" name="">
             <a:extLst xmlns:a="http://schemas.openxmlformats.org/drawingml/2006/main">
               <a:ext uri="{FF2B5EF4-FFF2-40B4-BE49-F238E27FC236}">
-                <a16:creationId xmlns:a16="http://schemas.microsoft.com/office/drawing/2014/main" id="{1A78D52F-0D25-4817-B0B7-15CA1E0FC547}"/>
+                <a16:creationId xmlns:a16="http://schemas.microsoft.com/office/drawing/2014/main" id="{77137EB9-8D9F-46DF-B89E-4360B550A429}"/>
               </a:ext>
             </a:extLst>
           </p:cNvPr>
@@ -7637,7 +7637,7 @@
           <p:cNvPr id="31" name="">
             <a:extLst xmlns:a="http://schemas.openxmlformats.org/drawingml/2006/main">
               <a:ext uri="{FF2B5EF4-FFF2-40B4-BE49-F238E27FC236}">
-                <a16:creationId xmlns:a16="http://schemas.microsoft.com/office/drawing/2014/main" id="{229DB03A-FCD4-4BE1-9145-1B7B68B4BB26}"/>
+                <a16:creationId xmlns:a16="http://schemas.microsoft.com/office/drawing/2014/main" id="{A1415358-4EC0-45AF-A565-A9F53939F388}"/>
               </a:ext>
             </a:extLst>
           </p:cNvPr>
@@ -7670,7 +7670,7 @@
           <p:cNvPr id="32" name="">
             <a:extLst xmlns:a="http://schemas.openxmlformats.org/drawingml/2006/main">
               <a:ext uri="{FF2B5EF4-FFF2-40B4-BE49-F238E27FC236}">
-                <a16:creationId xmlns:a16="http://schemas.microsoft.com/office/drawing/2014/main" id="{7D09AB5B-E6C9-4DD2-9C7C-B1CD948D8CF8}"/>
+                <a16:creationId xmlns:a16="http://schemas.microsoft.com/office/drawing/2014/main" id="{83305305-2802-4217-819D-DA6DD0B50D8C}"/>
               </a:ext>
             </a:extLst>
           </p:cNvPr>
@@ -7720,7 +7720,7 @@
           <p:cNvPr id="33" name="">
             <a:extLst xmlns:a="http://schemas.openxmlformats.org/drawingml/2006/main">
               <a:ext uri="{FF2B5EF4-FFF2-40B4-BE49-F238E27FC236}">
-                <a16:creationId xmlns:a16="http://schemas.microsoft.com/office/drawing/2014/main" id="{D5EE2D00-0A06-46C1-BB3A-734154069A58}"/>
+                <a16:creationId xmlns:a16="http://schemas.microsoft.com/office/drawing/2014/main" id="{C0BA3E16-28C1-4130-ADE9-214A50E603A6}"/>
               </a:ext>
             </a:extLst>
           </p:cNvPr>
@@ -7770,7 +7770,7 @@
           <p:cNvPr id="34" name="">
             <a:extLst xmlns:a="http://schemas.openxmlformats.org/drawingml/2006/main">
               <a:ext uri="{FF2B5EF4-FFF2-40B4-BE49-F238E27FC236}">
-                <a16:creationId xmlns:a16="http://schemas.microsoft.com/office/drawing/2014/main" id="{3FB32AFC-C617-4A7B-BC16-0F5270FC2E8D}"/>
+                <a16:creationId xmlns:a16="http://schemas.microsoft.com/office/drawing/2014/main" id="{47C299DE-1D28-452D-97C8-8C8E197E2F8B}"/>
               </a:ext>
             </a:extLst>
           </p:cNvPr>
@@ -7805,7 +7805,7 @@
           <p:cNvPr id="35" name="">
             <a:extLst xmlns:a="http://schemas.openxmlformats.org/drawingml/2006/main">
               <a:ext uri="{FF2B5EF4-FFF2-40B4-BE49-F238E27FC236}">
-                <a16:creationId xmlns:a16="http://schemas.microsoft.com/office/drawing/2014/main" id="{C90F383C-3346-427C-8D90-30C936BE38EC}"/>
+                <a16:creationId xmlns:a16="http://schemas.microsoft.com/office/drawing/2014/main" id="{CE65D5C7-0F4D-4A5C-B8E3-ACE0BAB2E54E}"/>
               </a:ext>
             </a:extLst>
           </p:cNvPr>
@@ -7838,7 +7838,7 @@
           <p:cNvPr id="36" name="">
             <a:extLst xmlns:a="http://schemas.openxmlformats.org/drawingml/2006/main">
               <a:ext uri="{FF2B5EF4-FFF2-40B4-BE49-F238E27FC236}">
-                <a16:creationId xmlns:a16="http://schemas.microsoft.com/office/drawing/2014/main" id="{E847DF2D-7C89-4FCC-B89B-FA926E529C40}"/>
+                <a16:creationId xmlns:a16="http://schemas.microsoft.com/office/drawing/2014/main" id="{F0DE5175-ED10-4DBE-A468-E5E872DA7CE0}"/>
               </a:ext>
             </a:extLst>
           </p:cNvPr>
@@ -7888,7 +7888,7 @@
           <p:cNvPr id="37" name="">
             <a:extLst xmlns:a="http://schemas.openxmlformats.org/drawingml/2006/main">
               <a:ext uri="{FF2B5EF4-FFF2-40B4-BE49-F238E27FC236}">
-                <a16:creationId xmlns:a16="http://schemas.microsoft.com/office/drawing/2014/main" id="{87603108-04C3-4649-8B89-96A8C292A0A7}"/>
+                <a16:creationId xmlns:a16="http://schemas.microsoft.com/office/drawing/2014/main" id="{01E4FB59-9591-4EB1-9E2F-922F69FC94E8}"/>
               </a:ext>
             </a:extLst>
           </p:cNvPr>
@@ -7938,7 +7938,7 @@
           <p:cNvPr id="38" name="">
             <a:extLst xmlns:a="http://schemas.openxmlformats.org/drawingml/2006/main">
               <a:ext uri="{FF2B5EF4-FFF2-40B4-BE49-F238E27FC236}">
-                <a16:creationId xmlns:a16="http://schemas.microsoft.com/office/drawing/2014/main" id="{9248C642-11EE-4D65-B232-565D8E3CF102}"/>
+                <a16:creationId xmlns:a16="http://schemas.microsoft.com/office/drawing/2014/main" id="{7C147A59-1929-417F-9991-087F02DCED38}"/>
               </a:ext>
             </a:extLst>
           </p:cNvPr>
@@ -7988,7 +7988,7 @@
           <p:cNvPr id="39" name="">
             <a:extLst xmlns:a="http://schemas.openxmlformats.org/drawingml/2006/main">
               <a:ext uri="{FF2B5EF4-FFF2-40B4-BE49-F238E27FC236}">
-                <a16:creationId xmlns:a16="http://schemas.microsoft.com/office/drawing/2014/main" id="{066EFE5C-D620-4201-905A-2211D1A9E587}"/>
+                <a16:creationId xmlns:a16="http://schemas.microsoft.com/office/drawing/2014/main" id="{1593A383-F606-4C75-B245-E068646C9A53}"/>
               </a:ext>
             </a:extLst>
           </p:cNvPr>
@@ -8038,7 +8038,7 @@
           <p:cNvPr id="40" name="">
             <a:extLst xmlns:a="http://schemas.openxmlformats.org/drawingml/2006/main">
               <a:ext uri="{FF2B5EF4-FFF2-40B4-BE49-F238E27FC236}">
-                <a16:creationId xmlns:a16="http://schemas.microsoft.com/office/drawing/2014/main" id="{6876B809-759F-465E-95BA-39F3BA35B38C}"/>
+                <a16:creationId xmlns:a16="http://schemas.microsoft.com/office/drawing/2014/main" id="{DD0F7E39-FD31-42AF-906F-928901E5601B}"/>
               </a:ext>
             </a:extLst>
           </p:cNvPr>
@@ -8071,7 +8071,7 @@
           <p:cNvPr id="41" name="">
             <a:extLst xmlns:a="http://schemas.openxmlformats.org/drawingml/2006/main">
               <a:ext uri="{FF2B5EF4-FFF2-40B4-BE49-F238E27FC236}">
-                <a16:creationId xmlns:a16="http://schemas.microsoft.com/office/drawing/2014/main" id="{B4314D07-0268-4853-8140-296BD0291378}"/>
+                <a16:creationId xmlns:a16="http://schemas.microsoft.com/office/drawing/2014/main" id="{2EE21D20-E8E9-40B8-A627-79C0C23E3814}"/>
               </a:ext>
             </a:extLst>
           </p:cNvPr>
@@ -8121,7 +8121,7 @@
           <p:cNvPr id="42" name="">
             <a:extLst xmlns:a="http://schemas.openxmlformats.org/drawingml/2006/main">
               <a:ext uri="{FF2B5EF4-FFF2-40B4-BE49-F238E27FC236}">
-                <a16:creationId xmlns:a16="http://schemas.microsoft.com/office/drawing/2014/main" id="{C536536D-6014-4955-B246-B3114D53024C}"/>
+                <a16:creationId xmlns:a16="http://schemas.microsoft.com/office/drawing/2014/main" id="{A1E92F75-2C85-4C78-9D7A-CFA488CB09DA}"/>
               </a:ext>
             </a:extLst>
           </p:cNvPr>
@@ -8171,7 +8171,7 @@
           <p:cNvPr id="43" name="">
             <a:extLst xmlns:a="http://schemas.openxmlformats.org/drawingml/2006/main">
               <a:ext uri="{FF2B5EF4-FFF2-40B4-BE49-F238E27FC236}">
-                <a16:creationId xmlns:a16="http://schemas.microsoft.com/office/drawing/2014/main" id="{2CDBDCF9-FD96-4F6D-A78B-C5355FE604BC}"/>
+                <a16:creationId xmlns:a16="http://schemas.microsoft.com/office/drawing/2014/main" id="{E9285B91-FCD0-40BC-B823-5CCA7AF9A7FF}"/>
               </a:ext>
             </a:extLst>
           </p:cNvPr>
@@ -8204,7 +8204,7 @@
           <p:cNvPr id="44" name="">
             <a:extLst xmlns:a="http://schemas.openxmlformats.org/drawingml/2006/main">
               <a:ext uri="{FF2B5EF4-FFF2-40B4-BE49-F238E27FC236}">
-                <a16:creationId xmlns:a16="http://schemas.microsoft.com/office/drawing/2014/main" id="{4C2CFAE6-BBB3-42F4-BF91-D1B813906970}"/>
+                <a16:creationId xmlns:a16="http://schemas.microsoft.com/office/drawing/2014/main" id="{EA1111BF-6D41-4E9D-964A-447BB922169C}"/>
               </a:ext>
             </a:extLst>
           </p:cNvPr>
@@ -8254,7 +8254,7 @@
           <p:cNvPr id="45" name="">
             <a:extLst xmlns:a="http://schemas.openxmlformats.org/drawingml/2006/main">
               <a:ext uri="{FF2B5EF4-FFF2-40B4-BE49-F238E27FC236}">
-                <a16:creationId xmlns:a16="http://schemas.microsoft.com/office/drawing/2014/main" id="{BA0523B1-FBA1-4167-8EEA-AB2816447FC6}"/>
+                <a16:creationId xmlns:a16="http://schemas.microsoft.com/office/drawing/2014/main" id="{B0683EBE-6D98-48D0-B621-2B2CF92505DF}"/>
               </a:ext>
             </a:extLst>
           </p:cNvPr>
@@ -8302,7 +8302,7 @@
     </p:spTree>
     <p:extLst>
       <p:ext uri="{BB962C8B-B14F-4D97-AF65-F5344CB8AC3E}">
-        <p14:creationId xmlns:p14="http://schemas.microsoft.com/office/powerpoint/2010/main" val="294152922"/>
+        <p14:creationId xmlns:p14="http://schemas.microsoft.com/office/powerpoint/2010/main" val="913886598"/>
       </p:ext>
     </p:extLst>
   </p:cSld>
@@ -8333,7 +8333,7 @@
           <p:cNvPr id="19" name="">
             <a:extLst xmlns:a="http://schemas.openxmlformats.org/drawingml/2006/main">
               <a:ext uri="{FF2B5EF4-FFF2-40B4-BE49-F238E27FC236}">
-                <a16:creationId xmlns:a16="http://schemas.microsoft.com/office/drawing/2014/main" id="{67ACF23D-D158-4B10-A9BD-573CA6EF0BD1}"/>
+                <a16:creationId xmlns:a16="http://schemas.microsoft.com/office/drawing/2014/main" id="{2E2D48FA-BBEC-4325-823C-95F903152E13}"/>
               </a:ext>
             </a:extLst>
           </p:cNvPr>
@@ -8366,7 +8366,7 @@
           <p:cNvPr id="2" name="">
             <a:extLst xmlns:a="http://schemas.openxmlformats.org/drawingml/2006/main">
               <a:ext uri="{FF2B5EF4-FFF2-40B4-BE49-F238E27FC236}">
-                <a16:creationId xmlns:a16="http://schemas.microsoft.com/office/drawing/2014/main" id="{55ADF4CC-7936-4456-88CA-1A442FA2B66F}"/>
+                <a16:creationId xmlns:a16="http://schemas.microsoft.com/office/drawing/2014/main" id="{B30C30DE-82E4-49BC-B92E-9EEED1D8304E}"/>
               </a:ext>
             </a:extLst>
           </p:cNvPr>
@@ -8416,7 +8416,7 @@
           <p:cNvPr id="3" name="">
             <a:extLst xmlns:a="http://schemas.openxmlformats.org/drawingml/2006/main">
               <a:ext uri="{FF2B5EF4-FFF2-40B4-BE49-F238E27FC236}">
-                <a16:creationId xmlns:a16="http://schemas.microsoft.com/office/drawing/2014/main" id="{4AE2E29E-71A8-4057-B133-496A084C949E}"/>
+                <a16:creationId xmlns:a16="http://schemas.microsoft.com/office/drawing/2014/main" id="{11D84E6E-7BD6-4946-9749-6853C2BC6EC0}"/>
               </a:ext>
             </a:extLst>
           </p:cNvPr>
@@ -8466,7 +8466,7 @@
           <p:cNvPr id="4" name="">
             <a:extLst xmlns:a="http://schemas.openxmlformats.org/drawingml/2006/main">
               <a:ext uri="{FF2B5EF4-FFF2-40B4-BE49-F238E27FC236}">
-                <a16:creationId xmlns:a16="http://schemas.microsoft.com/office/drawing/2014/main" id="{9BB54F2A-6303-4099-9F12-2B29E3CC3B12}"/>
+                <a16:creationId xmlns:a16="http://schemas.microsoft.com/office/drawing/2014/main" id="{A06E1CD0-5B62-4DDD-8AF7-3D49C890560F}"/>
               </a:ext>
             </a:extLst>
           </p:cNvPr>
@@ -8516,7 +8516,7 @@
           <p:cNvPr id="5" name="">
             <a:extLst xmlns:a="http://schemas.openxmlformats.org/drawingml/2006/main">
               <a:ext uri="{FF2B5EF4-FFF2-40B4-BE49-F238E27FC236}">
-                <a16:creationId xmlns:a16="http://schemas.microsoft.com/office/drawing/2014/main" id="{DA6990D8-0927-4E4B-9825-2290AAAD016B}"/>
+                <a16:creationId xmlns:a16="http://schemas.microsoft.com/office/drawing/2014/main" id="{E9A7BF65-A15C-4EAF-BB4E-F89CC58E28BA}"/>
               </a:ext>
             </a:extLst>
           </p:cNvPr>
@@ -8566,7 +8566,7 @@
           <p:cNvPr id="6" name="">
             <a:extLst xmlns:a="http://schemas.openxmlformats.org/drawingml/2006/main">
               <a:ext uri="{FF2B5EF4-FFF2-40B4-BE49-F238E27FC236}">
-                <a16:creationId xmlns:a16="http://schemas.microsoft.com/office/drawing/2014/main" id="{8F39BCDB-FEE9-4470-A25A-6DC78C8ABC70}"/>
+                <a16:creationId xmlns:a16="http://schemas.microsoft.com/office/drawing/2014/main" id="{86987982-1370-473D-8F63-17BCD0DF984D}"/>
               </a:ext>
             </a:extLst>
           </p:cNvPr>
@@ -8599,7 +8599,7 @@
           <p:cNvPr id="7" name="">
             <a:extLst xmlns:a="http://schemas.openxmlformats.org/drawingml/2006/main">
               <a:ext uri="{FF2B5EF4-FFF2-40B4-BE49-F238E27FC236}">
-                <a16:creationId xmlns:a16="http://schemas.microsoft.com/office/drawing/2014/main" id="{A01467AD-AFB9-4327-A91A-779F61ABBEF5}"/>
+                <a16:creationId xmlns:a16="http://schemas.microsoft.com/office/drawing/2014/main" id="{9536ED1D-959A-4883-B2AE-0641845D1840}"/>
               </a:ext>
             </a:extLst>
           </p:cNvPr>
@@ -8634,7 +8634,7 @@
           <p:cNvPr id="8" name="">
             <a:extLst xmlns:a="http://schemas.openxmlformats.org/drawingml/2006/main">
               <a:ext uri="{FF2B5EF4-FFF2-40B4-BE49-F238E27FC236}">
-                <a16:creationId xmlns:a16="http://schemas.microsoft.com/office/drawing/2014/main" id="{B73D1F56-5945-42A4-A672-4A543E5B6A96}"/>
+                <a16:creationId xmlns:a16="http://schemas.microsoft.com/office/drawing/2014/main" id="{62990521-95B1-4395-A28D-92DF2B85FCD2}"/>
               </a:ext>
             </a:extLst>
           </p:cNvPr>
@@ -8667,7 +8667,7 @@
           <p:cNvPr id="9" name="">
             <a:extLst xmlns:a="http://schemas.openxmlformats.org/drawingml/2006/main">
               <a:ext uri="{FF2B5EF4-FFF2-40B4-BE49-F238E27FC236}">
-                <a16:creationId xmlns:a16="http://schemas.microsoft.com/office/drawing/2014/main" id="{4635C424-E1CD-40BC-AE60-93297F126208}"/>
+                <a16:creationId xmlns:a16="http://schemas.microsoft.com/office/drawing/2014/main" id="{9BF06780-863B-4894-97E3-2B206C98A650}"/>
               </a:ext>
             </a:extLst>
           </p:cNvPr>
@@ -8717,7 +8717,7 @@
           <p:cNvPr id="10" name="">
             <a:extLst xmlns:a="http://schemas.openxmlformats.org/drawingml/2006/main">
               <a:ext uri="{FF2B5EF4-FFF2-40B4-BE49-F238E27FC236}">
-                <a16:creationId xmlns:a16="http://schemas.microsoft.com/office/drawing/2014/main" id="{75477F6C-1699-4492-A885-1D84459DD217}"/>
+                <a16:creationId xmlns:a16="http://schemas.microsoft.com/office/drawing/2014/main" id="{AE477A38-08A8-4F54-9C01-868F191F0312}"/>
               </a:ext>
             </a:extLst>
           </p:cNvPr>
@@ -8767,7 +8767,7 @@
           <p:cNvPr id="11" name="">
             <a:extLst xmlns:a="http://schemas.openxmlformats.org/drawingml/2006/main">
               <a:ext uri="{FF2B5EF4-FFF2-40B4-BE49-F238E27FC236}">
-                <a16:creationId xmlns:a16="http://schemas.microsoft.com/office/drawing/2014/main" id="{73812191-6FFD-497E-A8A7-A3DA908047F5}"/>
+                <a16:creationId xmlns:a16="http://schemas.microsoft.com/office/drawing/2014/main" id="{D96538A1-790F-421F-9015-06ACEC9F2A81}"/>
               </a:ext>
             </a:extLst>
           </p:cNvPr>
@@ -8817,7 +8817,7 @@
           <p:cNvPr id="12" name="">
             <a:extLst xmlns:a="http://schemas.openxmlformats.org/drawingml/2006/main">
               <a:ext uri="{FF2B5EF4-FFF2-40B4-BE49-F238E27FC236}">
-                <a16:creationId xmlns:a16="http://schemas.microsoft.com/office/drawing/2014/main" id="{7446040A-DA69-4D48-8AF0-EA9BB56216EF}"/>
+                <a16:creationId xmlns:a16="http://schemas.microsoft.com/office/drawing/2014/main" id="{42499014-BFF6-4F70-B6F2-800A54A91CAA}"/>
               </a:ext>
             </a:extLst>
           </p:cNvPr>
@@ -8867,7 +8867,7 @@
           <p:cNvPr id="13" name="">
             <a:extLst xmlns:a="http://schemas.openxmlformats.org/drawingml/2006/main">
               <a:ext uri="{FF2B5EF4-FFF2-40B4-BE49-F238E27FC236}">
-                <a16:creationId xmlns:a16="http://schemas.microsoft.com/office/drawing/2014/main" id="{D618AEC2-9321-400F-A456-0AD712A0E211}"/>
+                <a16:creationId xmlns:a16="http://schemas.microsoft.com/office/drawing/2014/main" id="{64BD8847-5B72-4654-BE83-C785032DA052}"/>
               </a:ext>
             </a:extLst>
           </p:cNvPr>
@@ -8900,7 +8900,7 @@
           <p:cNvPr id="14" name="">
             <a:extLst xmlns:a="http://schemas.openxmlformats.org/drawingml/2006/main">
               <a:ext uri="{FF2B5EF4-FFF2-40B4-BE49-F238E27FC236}">
-                <a16:creationId xmlns:a16="http://schemas.microsoft.com/office/drawing/2014/main" id="{427853E4-208D-47EE-A7F0-36BEAFAEEFC3}"/>
+                <a16:creationId xmlns:a16="http://schemas.microsoft.com/office/drawing/2014/main" id="{15F8996A-2EC5-42B6-BDCD-58CBEAF29BB5}"/>
               </a:ext>
             </a:extLst>
           </p:cNvPr>
@@ -8950,7 +8950,7 @@
           <p:cNvPr id="15" name="">
             <a:extLst xmlns:a="http://schemas.openxmlformats.org/drawingml/2006/main">
               <a:ext uri="{FF2B5EF4-FFF2-40B4-BE49-F238E27FC236}">
-                <a16:creationId xmlns:a16="http://schemas.microsoft.com/office/drawing/2014/main" id="{338BAC73-EEB3-432C-B986-FA383218A9DE}"/>
+                <a16:creationId xmlns:a16="http://schemas.microsoft.com/office/drawing/2014/main" id="{6826F0D3-B4F4-4624-8E7D-376148B33728}"/>
               </a:ext>
             </a:extLst>
           </p:cNvPr>
@@ -9000,7 +9000,7 @@
           <p:cNvPr id="16" name="">
             <a:extLst xmlns:a="http://schemas.openxmlformats.org/drawingml/2006/main">
               <a:ext uri="{FF2B5EF4-FFF2-40B4-BE49-F238E27FC236}">
-                <a16:creationId xmlns:a16="http://schemas.microsoft.com/office/drawing/2014/main" id="{95DAB2DC-BB0B-49A9-850C-FB3F125415C7}"/>
+                <a16:creationId xmlns:a16="http://schemas.microsoft.com/office/drawing/2014/main" id="{6B97DC58-56B4-4181-9CB2-502ED9DEEF64}"/>
               </a:ext>
             </a:extLst>
           </p:cNvPr>
@@ -9033,7 +9033,7 @@
           <p:cNvPr id="17" name="">
             <a:extLst xmlns:a="http://schemas.openxmlformats.org/drawingml/2006/main">
               <a:ext uri="{FF2B5EF4-FFF2-40B4-BE49-F238E27FC236}">
-                <a16:creationId xmlns:a16="http://schemas.microsoft.com/office/drawing/2014/main" id="{DE0D6298-78DA-4908-85D1-2B6927EB9045}"/>
+                <a16:creationId xmlns:a16="http://schemas.microsoft.com/office/drawing/2014/main" id="{4449EAE7-2420-4B6A-8D6A-CACDBC6AF31A}"/>
               </a:ext>
             </a:extLst>
           </p:cNvPr>
@@ -9083,7 +9083,7 @@
           <p:cNvPr id="18" name="">
             <a:extLst xmlns:a="http://schemas.openxmlformats.org/drawingml/2006/main">
               <a:ext uri="{FF2B5EF4-FFF2-40B4-BE49-F238E27FC236}">
-                <a16:creationId xmlns:a16="http://schemas.microsoft.com/office/drawing/2014/main" id="{72F3DBEE-16CF-46B4-BAD0-13A5C3E5E4FA}"/>
+                <a16:creationId xmlns:a16="http://schemas.microsoft.com/office/drawing/2014/main" id="{0C751A86-2F77-47C9-9380-62F12C74D0D1}"/>
               </a:ext>
             </a:extLst>
           </p:cNvPr>
@@ -9131,7 +9131,7 @@
     </p:spTree>
     <p:extLst>
       <p:ext uri="{BB962C8B-B14F-4D97-AF65-F5344CB8AC3E}">
-        <p14:creationId xmlns:p14="http://schemas.microsoft.com/office/powerpoint/2010/main" val="576359566"/>
+        <p14:creationId xmlns:p14="http://schemas.microsoft.com/office/powerpoint/2010/main" val="744731577"/>
       </p:ext>
     </p:extLst>
   </p:cSld>
@@ -9162,7 +9162,7 @@
           <p:cNvPr id="25" name="">
             <a:extLst xmlns:a="http://schemas.openxmlformats.org/drawingml/2006/main">
               <a:ext uri="{FF2B5EF4-FFF2-40B4-BE49-F238E27FC236}">
-                <a16:creationId xmlns:a16="http://schemas.microsoft.com/office/drawing/2014/main" id="{E4BD1AED-6FA5-4961-9316-B551A28F0D3A}"/>
+                <a16:creationId xmlns:a16="http://schemas.microsoft.com/office/drawing/2014/main" id="{B1CBAC8E-AFC7-4C0E-A149-97D72A0C9A2D}"/>
               </a:ext>
             </a:extLst>
           </p:cNvPr>
@@ -9195,7 +9195,7 @@
           <p:cNvPr id="2" name="">
             <a:extLst xmlns:a="http://schemas.openxmlformats.org/drawingml/2006/main">
               <a:ext uri="{FF2B5EF4-FFF2-40B4-BE49-F238E27FC236}">
-                <a16:creationId xmlns:a16="http://schemas.microsoft.com/office/drawing/2014/main" id="{8CE8DD6A-4E1C-4D9C-BB0C-7F90A9F38ED2}"/>
+                <a16:creationId xmlns:a16="http://schemas.microsoft.com/office/drawing/2014/main" id="{3EE42145-F27B-4677-A3D9-794068075502}"/>
               </a:ext>
             </a:extLst>
           </p:cNvPr>
@@ -9245,7 +9245,7 @@
           <p:cNvPr id="3" name="">
             <a:extLst xmlns:a="http://schemas.openxmlformats.org/drawingml/2006/main">
               <a:ext uri="{FF2B5EF4-FFF2-40B4-BE49-F238E27FC236}">
-                <a16:creationId xmlns:a16="http://schemas.microsoft.com/office/drawing/2014/main" id="{271AD50F-790C-4B96-9FE1-F6D95EFEB15A}"/>
+                <a16:creationId xmlns:a16="http://schemas.microsoft.com/office/drawing/2014/main" id="{2AC9AB5A-DC51-4FBB-A368-B1B8159AE381}"/>
               </a:ext>
             </a:extLst>
           </p:cNvPr>
@@ -9295,7 +9295,7 @@
           <p:cNvPr id="4" name="">
             <a:extLst xmlns:a="http://schemas.openxmlformats.org/drawingml/2006/main">
               <a:ext uri="{FF2B5EF4-FFF2-40B4-BE49-F238E27FC236}">
-                <a16:creationId xmlns:a16="http://schemas.microsoft.com/office/drawing/2014/main" id="{77466ADC-8CC1-44BC-8016-BC9AFC494AEC}"/>
+                <a16:creationId xmlns:a16="http://schemas.microsoft.com/office/drawing/2014/main" id="{1DB83914-6EC0-4FAE-A1A4-422DB857F5E2}"/>
               </a:ext>
             </a:extLst>
           </p:cNvPr>
@@ -9345,7 +9345,7 @@
           <p:cNvPr id="5" name="">
             <a:extLst xmlns:a="http://schemas.openxmlformats.org/drawingml/2006/main">
               <a:ext uri="{FF2B5EF4-FFF2-40B4-BE49-F238E27FC236}">
-                <a16:creationId xmlns:a16="http://schemas.microsoft.com/office/drawing/2014/main" id="{5CDFA5BC-9353-45E8-AE6C-B61EEEB1F478}"/>
+                <a16:creationId xmlns:a16="http://schemas.microsoft.com/office/drawing/2014/main" id="{1438EBA8-4E5A-4EA2-B789-E91F7A5D9488}"/>
               </a:ext>
             </a:extLst>
           </p:cNvPr>
@@ -9395,7 +9395,7 @@
           <p:cNvPr id="6" name="">
             <a:extLst xmlns:a="http://schemas.openxmlformats.org/drawingml/2006/main">
               <a:ext uri="{FF2B5EF4-FFF2-40B4-BE49-F238E27FC236}">
-                <a16:creationId xmlns:a16="http://schemas.microsoft.com/office/drawing/2014/main" id="{F2FA2EE4-41C7-479A-86F8-3B13274ECF8D}"/>
+                <a16:creationId xmlns:a16="http://schemas.microsoft.com/office/drawing/2014/main" id="{F122C565-7BA9-47EC-85DD-B1F951311DAA}"/>
               </a:ext>
             </a:extLst>
           </p:cNvPr>
@@ -9428,7 +9428,7 @@
           <p:cNvPr id="7" name="">
             <a:extLst xmlns:a="http://schemas.openxmlformats.org/drawingml/2006/main">
               <a:ext uri="{FF2B5EF4-FFF2-40B4-BE49-F238E27FC236}">
-                <a16:creationId xmlns:a16="http://schemas.microsoft.com/office/drawing/2014/main" id="{3CB4D5F5-3541-4FCA-92FB-251187386F39}"/>
+                <a16:creationId xmlns:a16="http://schemas.microsoft.com/office/drawing/2014/main" id="{4257B1D0-A142-49D1-9B56-3A05264AD34F}"/>
               </a:ext>
             </a:extLst>
           </p:cNvPr>
@@ -9478,7 +9478,7 @@
           <p:cNvPr id="8" name="">
             <a:extLst xmlns:a="http://schemas.openxmlformats.org/drawingml/2006/main">
               <a:ext uri="{FF2B5EF4-FFF2-40B4-BE49-F238E27FC236}">
-                <a16:creationId xmlns:a16="http://schemas.microsoft.com/office/drawing/2014/main" id="{F2667237-73FC-4D2A-A0A4-4A9F465C1F47}"/>
+                <a16:creationId xmlns:a16="http://schemas.microsoft.com/office/drawing/2014/main" id="{732EB992-8096-4B8F-8AD1-75A13CDD9F65}"/>
               </a:ext>
             </a:extLst>
           </p:cNvPr>
@@ -9528,7 +9528,7 @@
           <p:cNvPr id="9" name="">
             <a:extLst xmlns:a="http://schemas.openxmlformats.org/drawingml/2006/main">
               <a:ext uri="{FF2B5EF4-FFF2-40B4-BE49-F238E27FC236}">
-                <a16:creationId xmlns:a16="http://schemas.microsoft.com/office/drawing/2014/main" id="{6EDB838E-7BAF-474B-B7DC-40090273F160}"/>
+                <a16:creationId xmlns:a16="http://schemas.microsoft.com/office/drawing/2014/main" id="{7F5AEFD1-749F-4593-87B6-23B27B12F771}"/>
               </a:ext>
             </a:extLst>
           </p:cNvPr>
@@ -9561,7 +9561,7 @@
           <p:cNvPr id="10" name="">
             <a:extLst xmlns:a="http://schemas.openxmlformats.org/drawingml/2006/main">
               <a:ext uri="{FF2B5EF4-FFF2-40B4-BE49-F238E27FC236}">
-                <a16:creationId xmlns:a16="http://schemas.microsoft.com/office/drawing/2014/main" id="{CCEDEE50-FE21-4C97-98C9-872BD5222A4B}"/>
+                <a16:creationId xmlns:a16="http://schemas.microsoft.com/office/drawing/2014/main" id="{04D0741E-60C0-42E6-9D58-F4D34C0438B8}"/>
               </a:ext>
             </a:extLst>
           </p:cNvPr>
@@ -9611,7 +9611,7 @@
           <p:cNvPr id="11" name="">
             <a:extLst xmlns:a="http://schemas.openxmlformats.org/drawingml/2006/main">
               <a:ext uri="{FF2B5EF4-FFF2-40B4-BE49-F238E27FC236}">
-                <a16:creationId xmlns:a16="http://schemas.microsoft.com/office/drawing/2014/main" id="{5D353601-55F7-4AC9-9DF7-1D83159171C5}"/>
+                <a16:creationId xmlns:a16="http://schemas.microsoft.com/office/drawing/2014/main" id="{6AF2B399-E607-4017-9777-ADBF054AF721}"/>
               </a:ext>
             </a:extLst>
           </p:cNvPr>
@@ -9661,7 +9661,7 @@
           <p:cNvPr id="12" name="">
             <a:extLst xmlns:a="http://schemas.openxmlformats.org/drawingml/2006/main">
               <a:ext uri="{FF2B5EF4-FFF2-40B4-BE49-F238E27FC236}">
-                <a16:creationId xmlns:a16="http://schemas.microsoft.com/office/drawing/2014/main" id="{AAB90624-F6AC-41B4-9440-34E6A7A1788A}"/>
+                <a16:creationId xmlns:a16="http://schemas.microsoft.com/office/drawing/2014/main" id="{4C221385-A5A3-444D-8779-0CABB1D9F352}"/>
               </a:ext>
             </a:extLst>
           </p:cNvPr>
@@ -9711,7 +9711,7 @@
           <p:cNvPr id="13" name="">
             <a:extLst xmlns:a="http://schemas.openxmlformats.org/drawingml/2006/main">
               <a:ext uri="{FF2B5EF4-FFF2-40B4-BE49-F238E27FC236}">
-                <a16:creationId xmlns:a16="http://schemas.microsoft.com/office/drawing/2014/main" id="{488A3E54-B851-4278-82B7-22D2287A9A9C}"/>
+                <a16:creationId xmlns:a16="http://schemas.microsoft.com/office/drawing/2014/main" id="{2BE06522-B663-459C-B389-0C6CABF43D47}"/>
               </a:ext>
             </a:extLst>
           </p:cNvPr>
@@ -9761,7 +9761,7 @@
           <p:cNvPr id="14" name="">
             <a:extLst xmlns:a="http://schemas.openxmlformats.org/drawingml/2006/main">
               <a:ext uri="{FF2B5EF4-FFF2-40B4-BE49-F238E27FC236}">
-                <a16:creationId xmlns:a16="http://schemas.microsoft.com/office/drawing/2014/main" id="{CEC3CF9A-51E3-45E0-A210-B52B551342AD}"/>
+                <a16:creationId xmlns:a16="http://schemas.microsoft.com/office/drawing/2014/main" id="{FC44FDA6-DB54-43D1-ABE7-B2396A89275F}"/>
               </a:ext>
             </a:extLst>
           </p:cNvPr>
@@ -9794,7 +9794,7 @@
           <p:cNvPr id="15" name="">
             <a:extLst xmlns:a="http://schemas.openxmlformats.org/drawingml/2006/main">
               <a:ext uri="{FF2B5EF4-FFF2-40B4-BE49-F238E27FC236}">
-                <a16:creationId xmlns:a16="http://schemas.microsoft.com/office/drawing/2014/main" id="{685DC9E9-0510-452D-A321-87CD52DB86E2}"/>
+                <a16:creationId xmlns:a16="http://schemas.microsoft.com/office/drawing/2014/main" id="{0CF718E0-A6AD-431E-876A-52180BE47489}"/>
               </a:ext>
             </a:extLst>
           </p:cNvPr>
@@ -9844,7 +9844,7 @@
           <p:cNvPr id="16" name="">
             <a:extLst xmlns:a="http://schemas.openxmlformats.org/drawingml/2006/main">
               <a:ext uri="{FF2B5EF4-FFF2-40B4-BE49-F238E27FC236}">
-                <a16:creationId xmlns:a16="http://schemas.microsoft.com/office/drawing/2014/main" id="{0CAE884C-FCAB-4EDF-B4AC-48FC60FB7419}"/>
+                <a16:creationId xmlns:a16="http://schemas.microsoft.com/office/drawing/2014/main" id="{50581FC1-F2D7-4B45-B912-85BE740A6FD0}"/>
               </a:ext>
             </a:extLst>
           </p:cNvPr>
@@ -9894,7 +9894,7 @@
           <p:cNvPr id="17" name="">
             <a:extLst xmlns:a="http://schemas.openxmlformats.org/drawingml/2006/main">
               <a:ext uri="{FF2B5EF4-FFF2-40B4-BE49-F238E27FC236}">
-                <a16:creationId xmlns:a16="http://schemas.microsoft.com/office/drawing/2014/main" id="{83266253-EED9-4630-BDFF-ED8F2E5A9C7F}"/>
+                <a16:creationId xmlns:a16="http://schemas.microsoft.com/office/drawing/2014/main" id="{174FA929-2818-4944-974A-2E29958F56F5}"/>
               </a:ext>
             </a:extLst>
           </p:cNvPr>
@@ -9944,7 +9944,7 @@
           <p:cNvPr id="18" name="">
             <a:extLst xmlns:a="http://schemas.openxmlformats.org/drawingml/2006/main">
               <a:ext uri="{FF2B5EF4-FFF2-40B4-BE49-F238E27FC236}">
-                <a16:creationId xmlns:a16="http://schemas.microsoft.com/office/drawing/2014/main" id="{215D306F-9609-4F6E-9934-EFC73322555C}"/>
+                <a16:creationId xmlns:a16="http://schemas.microsoft.com/office/drawing/2014/main" id="{4208C2BB-CB39-40CD-A296-4011A5F18466}"/>
               </a:ext>
             </a:extLst>
           </p:cNvPr>
@@ -9994,7 +9994,7 @@
           <p:cNvPr id="19" name="">
             <a:extLst xmlns:a="http://schemas.openxmlformats.org/drawingml/2006/main">
               <a:ext uri="{FF2B5EF4-FFF2-40B4-BE49-F238E27FC236}">
-                <a16:creationId xmlns:a16="http://schemas.microsoft.com/office/drawing/2014/main" id="{A0563167-3B05-4A77-BE84-30FD866F89A3}"/>
+                <a16:creationId xmlns:a16="http://schemas.microsoft.com/office/drawing/2014/main" id="{E70A139E-9C63-43AA-A5EE-42EAC9FFE45C}"/>
               </a:ext>
             </a:extLst>
           </p:cNvPr>
@@ -10027,7 +10027,7 @@
           <p:cNvPr id="20" name="">
             <a:extLst xmlns:a="http://schemas.openxmlformats.org/drawingml/2006/main">
               <a:ext uri="{FF2B5EF4-FFF2-40B4-BE49-F238E27FC236}">
-                <a16:creationId xmlns:a16="http://schemas.microsoft.com/office/drawing/2014/main" id="{F54CB499-40AD-47AB-80D8-4A84DE4FB7E1}"/>
+                <a16:creationId xmlns:a16="http://schemas.microsoft.com/office/drawing/2014/main" id="{A187756C-D077-4B63-8E75-AFE1FC591F23}"/>
               </a:ext>
             </a:extLst>
           </p:cNvPr>
@@ -10077,7 +10077,7 @@
           <p:cNvPr id="21" name="">
             <a:extLst xmlns:a="http://schemas.openxmlformats.org/drawingml/2006/main">
               <a:ext uri="{FF2B5EF4-FFF2-40B4-BE49-F238E27FC236}">
-                <a16:creationId xmlns:a16="http://schemas.microsoft.com/office/drawing/2014/main" id="{2DD811FF-E7EA-4A1E-A7D9-093B93FA3D27}"/>
+                <a16:creationId xmlns:a16="http://schemas.microsoft.com/office/drawing/2014/main" id="{FC93C249-61DE-4A78-89FC-CCEC666DA2AC}"/>
               </a:ext>
             </a:extLst>
           </p:cNvPr>
@@ -10127,7 +10127,7 @@
           <p:cNvPr id="22" name="">
             <a:extLst xmlns:a="http://schemas.openxmlformats.org/drawingml/2006/main">
               <a:ext uri="{FF2B5EF4-FFF2-40B4-BE49-F238E27FC236}">
-                <a16:creationId xmlns:a16="http://schemas.microsoft.com/office/drawing/2014/main" id="{9632DA6B-CCFB-45EB-B244-14EEA816E0DE}"/>
+                <a16:creationId xmlns:a16="http://schemas.microsoft.com/office/drawing/2014/main" id="{2417365B-7842-4E4A-9043-9E2B93AC9DFB}"/>
               </a:ext>
             </a:extLst>
           </p:cNvPr>
@@ -10160,7 +10160,7 @@
           <p:cNvPr id="23" name="">
             <a:extLst xmlns:a="http://schemas.openxmlformats.org/drawingml/2006/main">
               <a:ext uri="{FF2B5EF4-FFF2-40B4-BE49-F238E27FC236}">
-                <a16:creationId xmlns:a16="http://schemas.microsoft.com/office/drawing/2014/main" id="{838489CE-E5F4-4EC0-8227-86970DEBB0B3}"/>
+                <a16:creationId xmlns:a16="http://schemas.microsoft.com/office/drawing/2014/main" id="{39290CE9-C568-43FA-ADD2-8A36FDABCDB3}"/>
               </a:ext>
             </a:extLst>
           </p:cNvPr>
@@ -10210,7 +10210,7 @@
           <p:cNvPr id="24" name="">
             <a:extLst xmlns:a="http://schemas.openxmlformats.org/drawingml/2006/main">
               <a:ext uri="{FF2B5EF4-FFF2-40B4-BE49-F238E27FC236}">
-                <a16:creationId xmlns:a16="http://schemas.microsoft.com/office/drawing/2014/main" id="{E64AD291-AF38-49F4-80BF-18CA85D55A38}"/>
+                <a16:creationId xmlns:a16="http://schemas.microsoft.com/office/drawing/2014/main" id="{46C3659B-0C81-492B-88E5-C7840B8A05D7}"/>
               </a:ext>
             </a:extLst>
           </p:cNvPr>
@@ -10258,7 +10258,7 @@
     </p:spTree>
     <p:extLst>
       <p:ext uri="{BB962C8B-B14F-4D97-AF65-F5344CB8AC3E}">
-        <p14:creationId xmlns:p14="http://schemas.microsoft.com/office/powerpoint/2010/main" val="1893119621"/>
+        <p14:creationId xmlns:p14="http://schemas.microsoft.com/office/powerpoint/2010/main" val="1624036340"/>
       </p:ext>
     </p:extLst>
   </p:cSld>
@@ -10289,7 +10289,7 @@
           <p:cNvPr id="23" name="">
             <a:extLst xmlns:a="http://schemas.openxmlformats.org/drawingml/2006/main">
               <a:ext uri="{FF2B5EF4-FFF2-40B4-BE49-F238E27FC236}">
-                <a16:creationId xmlns:a16="http://schemas.microsoft.com/office/drawing/2014/main" id="{BF2E8771-C877-4F29-B6D4-9EA47F0E7A29}"/>
+                <a16:creationId xmlns:a16="http://schemas.microsoft.com/office/drawing/2014/main" id="{60E4D81D-D298-4196-8AAA-B3F5CDC13C51}"/>
               </a:ext>
             </a:extLst>
           </p:cNvPr>
@@ -10322,7 +10322,7 @@
           <p:cNvPr id="2" name="">
             <a:extLst xmlns:a="http://schemas.openxmlformats.org/drawingml/2006/main">
               <a:ext uri="{FF2B5EF4-FFF2-40B4-BE49-F238E27FC236}">
-                <a16:creationId xmlns:a16="http://schemas.microsoft.com/office/drawing/2014/main" id="{9061513F-386F-430C-B242-A8CF5DA713D6}"/>
+                <a16:creationId xmlns:a16="http://schemas.microsoft.com/office/drawing/2014/main" id="{7527F417-CA96-4E7F-8D03-186204C16EAB}"/>
               </a:ext>
             </a:extLst>
           </p:cNvPr>
@@ -10372,7 +10372,7 @@
           <p:cNvPr id="3" name="">
             <a:extLst xmlns:a="http://schemas.openxmlformats.org/drawingml/2006/main">
               <a:ext uri="{FF2B5EF4-FFF2-40B4-BE49-F238E27FC236}">
-                <a16:creationId xmlns:a16="http://schemas.microsoft.com/office/drawing/2014/main" id="{011512A9-50F6-424D-A859-CFAD220656F9}"/>
+                <a16:creationId xmlns:a16="http://schemas.microsoft.com/office/drawing/2014/main" id="{4C32F1A8-66FC-49CC-B74A-592924C97ABC}"/>
               </a:ext>
             </a:extLst>
           </p:cNvPr>
@@ -10422,7 +10422,7 @@
           <p:cNvPr id="4" name="">
             <a:extLst xmlns:a="http://schemas.openxmlformats.org/drawingml/2006/main">
               <a:ext uri="{FF2B5EF4-FFF2-40B4-BE49-F238E27FC236}">
-                <a16:creationId xmlns:a16="http://schemas.microsoft.com/office/drawing/2014/main" id="{F410E6C3-E2F7-4977-AA84-8315C76F5800}"/>
+                <a16:creationId xmlns:a16="http://schemas.microsoft.com/office/drawing/2014/main" id="{95389F71-B6DE-41C3-9DFC-AC9E9C46E0CA}"/>
               </a:ext>
             </a:extLst>
           </p:cNvPr>
@@ -10472,7 +10472,7 @@
           <p:cNvPr id="5" name="">
             <a:extLst xmlns:a="http://schemas.openxmlformats.org/drawingml/2006/main">
               <a:ext uri="{FF2B5EF4-FFF2-40B4-BE49-F238E27FC236}">
-                <a16:creationId xmlns:a16="http://schemas.microsoft.com/office/drawing/2014/main" id="{4A7A28A0-5707-4416-BB2C-2F5725D8F716}"/>
+                <a16:creationId xmlns:a16="http://schemas.microsoft.com/office/drawing/2014/main" id="{A5AC1786-DACA-4200-87F2-CEC13B1AD729}"/>
               </a:ext>
             </a:extLst>
           </p:cNvPr>
@@ -10522,7 +10522,7 @@
           <p:cNvPr id="6" name="">
             <a:extLst xmlns:a="http://schemas.openxmlformats.org/drawingml/2006/main">
               <a:ext uri="{FF2B5EF4-FFF2-40B4-BE49-F238E27FC236}">
-                <a16:creationId xmlns:a16="http://schemas.microsoft.com/office/drawing/2014/main" id="{372A179C-9774-4C56-AC44-7C859B05A035}"/>
+                <a16:creationId xmlns:a16="http://schemas.microsoft.com/office/drawing/2014/main" id="{C0D8C619-E02D-485E-8F6E-094F5B0B4499}"/>
               </a:ext>
             </a:extLst>
           </p:cNvPr>
@@ -10555,7 +10555,7 @@
           <p:cNvPr id="7" name="">
             <a:extLst xmlns:a="http://schemas.openxmlformats.org/drawingml/2006/main">
               <a:ext uri="{FF2B5EF4-FFF2-40B4-BE49-F238E27FC236}">
-                <a16:creationId xmlns:a16="http://schemas.microsoft.com/office/drawing/2014/main" id="{6A7040A6-C110-4CC8-B31B-A5CDB6270749}"/>
+                <a16:creationId xmlns:a16="http://schemas.microsoft.com/office/drawing/2014/main" id="{7BAA1E5F-A888-4E10-AA05-BF74AF890DAC}"/>
               </a:ext>
             </a:extLst>
           </p:cNvPr>
@@ -10605,7 +10605,7 @@
           <p:cNvPr id="8" name="">
             <a:extLst xmlns:a="http://schemas.openxmlformats.org/drawingml/2006/main">
               <a:ext uri="{FF2B5EF4-FFF2-40B4-BE49-F238E27FC236}">
-                <a16:creationId xmlns:a16="http://schemas.microsoft.com/office/drawing/2014/main" id="{94AEB9BB-53D1-4C12-A18C-AD96D2CA112F}"/>
+                <a16:creationId xmlns:a16="http://schemas.microsoft.com/office/drawing/2014/main" id="{5BF19736-FA04-40FB-AB24-E41C1136E6F4}"/>
               </a:ext>
             </a:extLst>
           </p:cNvPr>
@@ -10655,7 +10655,7 @@
           <p:cNvPr id="9" name="">
             <a:extLst xmlns:a="http://schemas.openxmlformats.org/drawingml/2006/main">
               <a:ext uri="{FF2B5EF4-FFF2-40B4-BE49-F238E27FC236}">
-                <a16:creationId xmlns:a16="http://schemas.microsoft.com/office/drawing/2014/main" id="{D8D2D240-4F3D-4727-AEAD-FEF6589CA1D6}"/>
+                <a16:creationId xmlns:a16="http://schemas.microsoft.com/office/drawing/2014/main" id="{D6C991AC-4E32-4634-B1A0-1E99BF155270}"/>
               </a:ext>
             </a:extLst>
           </p:cNvPr>
@@ -10705,7 +10705,7 @@
           <p:cNvPr id="10" name="">
             <a:extLst xmlns:a="http://schemas.openxmlformats.org/drawingml/2006/main">
               <a:ext uri="{FF2B5EF4-FFF2-40B4-BE49-F238E27FC236}">
-                <a16:creationId xmlns:a16="http://schemas.microsoft.com/office/drawing/2014/main" id="{817BE1A6-94CF-40AD-8202-A6DA161BA2CC}"/>
+                <a16:creationId xmlns:a16="http://schemas.microsoft.com/office/drawing/2014/main" id="{AAB5B48A-4EFE-41F1-B986-CB3868372BFA}"/>
               </a:ext>
             </a:extLst>
           </p:cNvPr>
@@ -10745,7 +10745,7 @@
                   <a:srgbClr val="FF3B12"/>
                 </a:solidFill>
               </a:rPr>
-              <a:t>25</a:t>
+              <a:t>23</a:t>
             </a:r>
           </a:p>
         </p:txBody>
@@ -10755,7 +10755,7 @@
           <p:cNvPr id="11" name="">
             <a:extLst xmlns:a="http://schemas.openxmlformats.org/drawingml/2006/main">
               <a:ext uri="{FF2B5EF4-FFF2-40B4-BE49-F238E27FC236}">
-                <a16:creationId xmlns:a16="http://schemas.microsoft.com/office/drawing/2014/main" id="{3D7F98B9-DFB4-4202-A9A9-CA7029201348}"/>
+                <a16:creationId xmlns:a16="http://schemas.microsoft.com/office/drawing/2014/main" id="{0332AA01-B0C5-454B-A268-49078806785F}"/>
               </a:ext>
             </a:extLst>
           </p:cNvPr>
@@ -10805,7 +10805,7 @@
           <p:cNvPr id="12" name="">
             <a:extLst xmlns:a="http://schemas.openxmlformats.org/drawingml/2006/main">
               <a:ext uri="{FF2B5EF4-FFF2-40B4-BE49-F238E27FC236}">
-                <a16:creationId xmlns:a16="http://schemas.microsoft.com/office/drawing/2014/main" id="{48434019-C4B9-41F5-AA20-164F7F4019CD}"/>
+                <a16:creationId xmlns:a16="http://schemas.microsoft.com/office/drawing/2014/main" id="{0950CC4D-F1F4-46DC-A751-28A51DE227F8}"/>
               </a:ext>
             </a:extLst>
           </p:cNvPr>
@@ -10855,7 +10855,7 @@
           <p:cNvPr id="13" name="">
             <a:extLst xmlns:a="http://schemas.openxmlformats.org/drawingml/2006/main">
               <a:ext uri="{FF2B5EF4-FFF2-40B4-BE49-F238E27FC236}">
-                <a16:creationId xmlns:a16="http://schemas.microsoft.com/office/drawing/2014/main" id="{4A5D4C14-2CDE-4E7D-B907-C6F94D8E2334}"/>
+                <a16:creationId xmlns:a16="http://schemas.microsoft.com/office/drawing/2014/main" id="{BF0DA801-2135-45E9-B182-384736256A6B}"/>
               </a:ext>
             </a:extLst>
           </p:cNvPr>
@@ -10905,7 +10905,7 @@
           <p:cNvPr id="14" name="">
             <a:extLst xmlns:a="http://schemas.openxmlformats.org/drawingml/2006/main">
               <a:ext uri="{FF2B5EF4-FFF2-40B4-BE49-F238E27FC236}">
-                <a16:creationId xmlns:a16="http://schemas.microsoft.com/office/drawing/2014/main" id="{A0789963-0048-4B4B-82B0-7100579FB7F8}"/>
+                <a16:creationId xmlns:a16="http://schemas.microsoft.com/office/drawing/2014/main" id="{F8432BF2-B9EA-484A-BFA0-D0AFBA8DC009}"/>
               </a:ext>
             </a:extLst>
           </p:cNvPr>
@@ -10955,7 +10955,7 @@
           <p:cNvPr id="15" name="">
             <a:extLst xmlns:a="http://schemas.openxmlformats.org/drawingml/2006/main">
               <a:ext uri="{FF2B5EF4-FFF2-40B4-BE49-F238E27FC236}">
-                <a16:creationId xmlns:a16="http://schemas.microsoft.com/office/drawing/2014/main" id="{2D0564D6-6D7D-4D73-B782-214DE2FDF745}"/>
+                <a16:creationId xmlns:a16="http://schemas.microsoft.com/office/drawing/2014/main" id="{E424AE3C-802B-404C-B5EA-DBBEDC34A63E}"/>
               </a:ext>
             </a:extLst>
           </p:cNvPr>
@@ -11005,7 +11005,7 @@
           <p:cNvPr id="16" name="">
             <a:extLst xmlns:a="http://schemas.openxmlformats.org/drawingml/2006/main">
               <a:ext uri="{FF2B5EF4-FFF2-40B4-BE49-F238E27FC236}">
-                <a16:creationId xmlns:a16="http://schemas.microsoft.com/office/drawing/2014/main" id="{E0889829-6322-4C79-A584-1DE8D696D92D}"/>
+                <a16:creationId xmlns:a16="http://schemas.microsoft.com/office/drawing/2014/main" id="{9FB32B19-D1B4-4BF5-9EDA-98BB12260C4D}"/>
               </a:ext>
             </a:extLst>
           </p:cNvPr>
@@ -11038,7 +11038,7 @@
           <p:cNvPr id="17" name="">
             <a:extLst xmlns:a="http://schemas.openxmlformats.org/drawingml/2006/main">
               <a:ext uri="{FF2B5EF4-FFF2-40B4-BE49-F238E27FC236}">
-                <a16:creationId xmlns:a16="http://schemas.microsoft.com/office/drawing/2014/main" id="{1EA80529-13A7-456E-AFEF-D1941B9A7CC3}"/>
+                <a16:creationId xmlns:a16="http://schemas.microsoft.com/office/drawing/2014/main" id="{58795940-B723-4ABB-B8E8-956DBC6345BB}"/>
               </a:ext>
             </a:extLst>
           </p:cNvPr>
@@ -11088,7 +11088,7 @@
           <p:cNvPr id="18" name="">
             <a:extLst xmlns:a="http://schemas.openxmlformats.org/drawingml/2006/main">
               <a:ext uri="{FF2B5EF4-FFF2-40B4-BE49-F238E27FC236}">
-                <a16:creationId xmlns:a16="http://schemas.microsoft.com/office/drawing/2014/main" id="{BAD9FCC7-7E92-44F8-A2A5-034508879731}"/>
+                <a16:creationId xmlns:a16="http://schemas.microsoft.com/office/drawing/2014/main" id="{AA9938A8-0C7D-4012-AEDC-2D9F9D37C02F}"/>
               </a:ext>
             </a:extLst>
           </p:cNvPr>
@@ -11138,7 +11138,7 @@
           <p:cNvPr id="19" name="">
             <a:extLst xmlns:a="http://schemas.openxmlformats.org/drawingml/2006/main">
               <a:ext uri="{FF2B5EF4-FFF2-40B4-BE49-F238E27FC236}">
-                <a16:creationId xmlns:a16="http://schemas.microsoft.com/office/drawing/2014/main" id="{422F6839-9BFA-40F4-8524-D68ADA9E0890}"/>
+                <a16:creationId xmlns:a16="http://schemas.microsoft.com/office/drawing/2014/main" id="{4C62ABC8-35FF-49FC-BBEE-A01104BE1183}"/>
               </a:ext>
             </a:extLst>
           </p:cNvPr>
@@ -11188,7 +11188,7 @@
           <p:cNvPr id="20" name="">
             <a:extLst xmlns:a="http://schemas.openxmlformats.org/drawingml/2006/main">
               <a:ext uri="{FF2B5EF4-FFF2-40B4-BE49-F238E27FC236}">
-                <a16:creationId xmlns:a16="http://schemas.microsoft.com/office/drawing/2014/main" id="{77BF4A48-7B0F-4FC9-BDB0-D46C4863DC9F}"/>
+                <a16:creationId xmlns:a16="http://schemas.microsoft.com/office/drawing/2014/main" id="{790CB20E-15EB-46DD-BBFE-4859985C7D64}"/>
               </a:ext>
             </a:extLst>
           </p:cNvPr>
@@ -11221,7 +11221,7 @@
           <p:cNvPr id="21" name="">
             <a:extLst xmlns:a="http://schemas.openxmlformats.org/drawingml/2006/main">
               <a:ext uri="{FF2B5EF4-FFF2-40B4-BE49-F238E27FC236}">
-                <a16:creationId xmlns:a16="http://schemas.microsoft.com/office/drawing/2014/main" id="{CED09014-C7E6-4ADD-8520-7E573A10F08F}"/>
+                <a16:creationId xmlns:a16="http://schemas.microsoft.com/office/drawing/2014/main" id="{94D70AC3-0FD9-4659-B3EC-1F2D25E4107E}"/>
               </a:ext>
             </a:extLst>
           </p:cNvPr>
@@ -11271,7 +11271,7 @@
           <p:cNvPr id="22" name="">
             <a:extLst xmlns:a="http://schemas.openxmlformats.org/drawingml/2006/main">
               <a:ext uri="{FF2B5EF4-FFF2-40B4-BE49-F238E27FC236}">
-                <a16:creationId xmlns:a16="http://schemas.microsoft.com/office/drawing/2014/main" id="{1522C18C-1B78-4C5A-922D-99A4E777C4B8}"/>
+                <a16:creationId xmlns:a16="http://schemas.microsoft.com/office/drawing/2014/main" id="{7997F51C-3080-4DF1-90D6-5F08EB435920}"/>
               </a:ext>
             </a:extLst>
           </p:cNvPr>
@@ -11319,7 +11319,7 @@
     </p:spTree>
     <p:extLst>
       <p:ext uri="{BB962C8B-B14F-4D97-AF65-F5344CB8AC3E}">
-        <p14:creationId xmlns:p14="http://schemas.microsoft.com/office/powerpoint/2010/main" val="1048968028"/>
+        <p14:creationId xmlns:p14="http://schemas.microsoft.com/office/powerpoint/2010/main" val="1311345588"/>
       </p:ext>
     </p:extLst>
   </p:cSld>
@@ -11350,7 +11350,7 @@
           <p:cNvPr id="40" name="">
             <a:extLst xmlns:a="http://schemas.openxmlformats.org/drawingml/2006/main">
               <a:ext uri="{FF2B5EF4-FFF2-40B4-BE49-F238E27FC236}">
-                <a16:creationId xmlns:a16="http://schemas.microsoft.com/office/drawing/2014/main" id="{85B113AB-3D2A-4DBA-B2B9-B1915E0183DE}"/>
+                <a16:creationId xmlns:a16="http://schemas.microsoft.com/office/drawing/2014/main" id="{B1E9162A-55DE-414C-8D3A-E0781691068E}"/>
               </a:ext>
             </a:extLst>
           </p:cNvPr>
@@ -11383,7 +11383,7 @@
           <p:cNvPr id="2" name="">
             <a:extLst xmlns:a="http://schemas.openxmlformats.org/drawingml/2006/main">
               <a:ext uri="{FF2B5EF4-FFF2-40B4-BE49-F238E27FC236}">
-                <a16:creationId xmlns:a16="http://schemas.microsoft.com/office/drawing/2014/main" id="{2B8E1A86-40CB-4887-A4C9-691CDA914D70}"/>
+                <a16:creationId xmlns:a16="http://schemas.microsoft.com/office/drawing/2014/main" id="{A40FC083-E564-467C-8B67-2E8624CF1842}"/>
               </a:ext>
             </a:extLst>
           </p:cNvPr>
@@ -11433,7 +11433,7 @@
           <p:cNvPr id="3" name="">
             <a:extLst xmlns:a="http://schemas.openxmlformats.org/drawingml/2006/main">
               <a:ext uri="{FF2B5EF4-FFF2-40B4-BE49-F238E27FC236}">
-                <a16:creationId xmlns:a16="http://schemas.microsoft.com/office/drawing/2014/main" id="{8FD4B7A0-C6E5-420A-B4AA-05F1356F8710}"/>
+                <a16:creationId xmlns:a16="http://schemas.microsoft.com/office/drawing/2014/main" id="{8263149D-CFAA-4EEE-96AF-3A8B5DA75C40}"/>
               </a:ext>
             </a:extLst>
           </p:cNvPr>
@@ -11483,7 +11483,7 @@
           <p:cNvPr id="4" name="">
             <a:extLst xmlns:a="http://schemas.openxmlformats.org/drawingml/2006/main">
               <a:ext uri="{FF2B5EF4-FFF2-40B4-BE49-F238E27FC236}">
-                <a16:creationId xmlns:a16="http://schemas.microsoft.com/office/drawing/2014/main" id="{D99789BB-9D11-408B-B235-27FB0FA2D29D}"/>
+                <a16:creationId xmlns:a16="http://schemas.microsoft.com/office/drawing/2014/main" id="{C55C1178-1828-403E-B147-A193A65F6AC9}"/>
               </a:ext>
             </a:extLst>
           </p:cNvPr>
@@ -11533,7 +11533,7 @@
           <p:cNvPr id="5" name="">
             <a:extLst xmlns:a="http://schemas.openxmlformats.org/drawingml/2006/main">
               <a:ext uri="{FF2B5EF4-FFF2-40B4-BE49-F238E27FC236}">
-                <a16:creationId xmlns:a16="http://schemas.microsoft.com/office/drawing/2014/main" id="{F16BD9B7-98DC-4D73-883A-D5549E87B350}"/>
+                <a16:creationId xmlns:a16="http://schemas.microsoft.com/office/drawing/2014/main" id="{ADF119A7-A7F6-4C4D-90FC-C315649C3FD6}"/>
               </a:ext>
             </a:extLst>
           </p:cNvPr>
@@ -11583,7 +11583,7 @@
           <p:cNvPr id="6" name="">
             <a:extLst xmlns:a="http://schemas.openxmlformats.org/drawingml/2006/main">
               <a:ext uri="{FF2B5EF4-FFF2-40B4-BE49-F238E27FC236}">
-                <a16:creationId xmlns:a16="http://schemas.microsoft.com/office/drawing/2014/main" id="{DC2DD417-5307-4897-B547-1BE01685A57E}"/>
+                <a16:creationId xmlns:a16="http://schemas.microsoft.com/office/drawing/2014/main" id="{23C8ED18-D32A-49D0-A40D-9EA27F1F1582}"/>
               </a:ext>
             </a:extLst>
           </p:cNvPr>
@@ -11616,7 +11616,7 @@
           <p:cNvPr id="7" name="">
             <a:extLst xmlns:a="http://schemas.openxmlformats.org/drawingml/2006/main">
               <a:ext uri="{FF2B5EF4-FFF2-40B4-BE49-F238E27FC236}">
-                <a16:creationId xmlns:a16="http://schemas.microsoft.com/office/drawing/2014/main" id="{A1796E9C-358B-4DC6-B41C-C983BF65A21E}"/>
+                <a16:creationId xmlns:a16="http://schemas.microsoft.com/office/drawing/2014/main" id="{94C54D53-D904-4C2A-B5F6-38AD711D628A}"/>
               </a:ext>
             </a:extLst>
           </p:cNvPr>
@@ -11651,7 +11651,7 @@
           <p:cNvPr id="8" name="">
             <a:extLst xmlns:a="http://schemas.openxmlformats.org/drawingml/2006/main">
               <a:ext uri="{FF2B5EF4-FFF2-40B4-BE49-F238E27FC236}">
-                <a16:creationId xmlns:a16="http://schemas.microsoft.com/office/drawing/2014/main" id="{F0B07911-1D64-41A0-9237-24E5AD25DB99}"/>
+                <a16:creationId xmlns:a16="http://schemas.microsoft.com/office/drawing/2014/main" id="{F9DF6B69-0DD6-4F99-9E17-8A9235E0DF1F}"/>
               </a:ext>
             </a:extLst>
           </p:cNvPr>
@@ -11684,7 +11684,7 @@
           <p:cNvPr id="9" name="">
             <a:extLst xmlns:a="http://schemas.openxmlformats.org/drawingml/2006/main">
               <a:ext uri="{FF2B5EF4-FFF2-40B4-BE49-F238E27FC236}">
-                <a16:creationId xmlns:a16="http://schemas.microsoft.com/office/drawing/2014/main" id="{D2E3A75C-7411-4D58-BEBE-5454A8ED5B8B}"/>
+                <a16:creationId xmlns:a16="http://schemas.microsoft.com/office/drawing/2014/main" id="{0F899A62-86DE-4150-B248-ECF52EFFCF7A}"/>
               </a:ext>
             </a:extLst>
           </p:cNvPr>
@@ -11734,7 +11734,7 @@
           <p:cNvPr id="10" name="">
             <a:extLst xmlns:a="http://schemas.openxmlformats.org/drawingml/2006/main">
               <a:ext uri="{FF2B5EF4-FFF2-40B4-BE49-F238E27FC236}">
-                <a16:creationId xmlns:a16="http://schemas.microsoft.com/office/drawing/2014/main" id="{48420039-D766-4004-BC3E-A8DB7145EFA6}"/>
+                <a16:creationId xmlns:a16="http://schemas.microsoft.com/office/drawing/2014/main" id="{DFF58E3E-A40E-4A02-B8E8-1CBF50D12A99}"/>
               </a:ext>
             </a:extLst>
           </p:cNvPr>
@@ -11784,7 +11784,7 @@
           <p:cNvPr id="11" name="">
             <a:extLst xmlns:a="http://schemas.openxmlformats.org/drawingml/2006/main">
               <a:ext uri="{FF2B5EF4-FFF2-40B4-BE49-F238E27FC236}">
-                <a16:creationId xmlns:a16="http://schemas.microsoft.com/office/drawing/2014/main" id="{8C668C0A-4F0F-4ADC-B6CF-800C7AD2DE92}"/>
+                <a16:creationId xmlns:a16="http://schemas.microsoft.com/office/drawing/2014/main" id="{A54D843C-075F-4D65-9A58-3406AB3AC813}"/>
               </a:ext>
             </a:extLst>
           </p:cNvPr>
@@ -11834,7 +11834,7 @@
           <p:cNvPr id="12" name="">
             <a:extLst xmlns:a="http://schemas.openxmlformats.org/drawingml/2006/main">
               <a:ext uri="{FF2B5EF4-FFF2-40B4-BE49-F238E27FC236}">
-                <a16:creationId xmlns:a16="http://schemas.microsoft.com/office/drawing/2014/main" id="{118C455F-8101-4A6D-8027-3BC6945CC45C}"/>
+                <a16:creationId xmlns:a16="http://schemas.microsoft.com/office/drawing/2014/main" id="{628EEC44-4171-4D44-9438-5777BF0D89E4}"/>
               </a:ext>
             </a:extLst>
           </p:cNvPr>
@@ -11884,7 +11884,7 @@
           <p:cNvPr id="13" name="">
             <a:extLst xmlns:a="http://schemas.openxmlformats.org/drawingml/2006/main">
               <a:ext uri="{FF2B5EF4-FFF2-40B4-BE49-F238E27FC236}">
-                <a16:creationId xmlns:a16="http://schemas.microsoft.com/office/drawing/2014/main" id="{C3833AD9-30BD-44AC-A3CE-4B86DFE22A2D}"/>
+                <a16:creationId xmlns:a16="http://schemas.microsoft.com/office/drawing/2014/main" id="{0998CBA4-59CA-468F-A8FD-49F70F51E4A2}"/>
               </a:ext>
             </a:extLst>
           </p:cNvPr>
@@ -11919,7 +11919,7 @@
           <p:cNvPr id="14" name="">
             <a:extLst xmlns:a="http://schemas.openxmlformats.org/drawingml/2006/main">
               <a:ext uri="{FF2B5EF4-FFF2-40B4-BE49-F238E27FC236}">
-                <a16:creationId xmlns:a16="http://schemas.microsoft.com/office/drawing/2014/main" id="{D871D2CA-12FB-44D8-B808-9629863158CE}"/>
+                <a16:creationId xmlns:a16="http://schemas.microsoft.com/office/drawing/2014/main" id="{AA942EF9-3DB5-4CA9-BEC7-50D739AD7918}"/>
               </a:ext>
             </a:extLst>
           </p:cNvPr>
@@ -11952,7 +11952,7 @@
           <p:cNvPr id="15" name="">
             <a:extLst xmlns:a="http://schemas.openxmlformats.org/drawingml/2006/main">
               <a:ext uri="{FF2B5EF4-FFF2-40B4-BE49-F238E27FC236}">
-                <a16:creationId xmlns:a16="http://schemas.microsoft.com/office/drawing/2014/main" id="{F0C9777D-3B24-4A0E-BC35-EEBB02CE2298}"/>
+                <a16:creationId xmlns:a16="http://schemas.microsoft.com/office/drawing/2014/main" id="{1653CF83-FD79-425D-9A2A-F01B7E22C501}"/>
               </a:ext>
             </a:extLst>
           </p:cNvPr>
@@ -12002,7 +12002,7 @@
           <p:cNvPr id="16" name="">
             <a:extLst xmlns:a="http://schemas.openxmlformats.org/drawingml/2006/main">
               <a:ext uri="{FF2B5EF4-FFF2-40B4-BE49-F238E27FC236}">
-                <a16:creationId xmlns:a16="http://schemas.microsoft.com/office/drawing/2014/main" id="{D14BDD46-E299-4028-9352-077BBBF06795}"/>
+                <a16:creationId xmlns:a16="http://schemas.microsoft.com/office/drawing/2014/main" id="{8B5B97DC-9183-4ED4-96E5-2D47159F4D18}"/>
               </a:ext>
             </a:extLst>
           </p:cNvPr>
@@ -12052,7 +12052,7 @@
           <p:cNvPr id="17" name="">
             <a:extLst xmlns:a="http://schemas.openxmlformats.org/drawingml/2006/main">
               <a:ext uri="{FF2B5EF4-FFF2-40B4-BE49-F238E27FC236}">
-                <a16:creationId xmlns:a16="http://schemas.microsoft.com/office/drawing/2014/main" id="{FC9C5DAB-72A6-428B-AEEC-30BF228E711F}"/>
+                <a16:creationId xmlns:a16="http://schemas.microsoft.com/office/drawing/2014/main" id="{509CC462-A29E-4A22-88FF-F65070B76F15}"/>
               </a:ext>
             </a:extLst>
           </p:cNvPr>
@@ -12102,7 +12102,7 @@
           <p:cNvPr id="18" name="">
             <a:extLst xmlns:a="http://schemas.openxmlformats.org/drawingml/2006/main">
               <a:ext uri="{FF2B5EF4-FFF2-40B4-BE49-F238E27FC236}">
-                <a16:creationId xmlns:a16="http://schemas.microsoft.com/office/drawing/2014/main" id="{8171C375-7039-4439-AA02-1B09F992ACA5}"/>
+                <a16:creationId xmlns:a16="http://schemas.microsoft.com/office/drawing/2014/main" id="{12B728EB-ED9C-4EFB-A086-C9493BAE168F}"/>
               </a:ext>
             </a:extLst>
           </p:cNvPr>
@@ -12152,7 +12152,7 @@
           <p:cNvPr id="19" name="">
             <a:extLst xmlns:a="http://schemas.openxmlformats.org/drawingml/2006/main">
               <a:ext uri="{FF2B5EF4-FFF2-40B4-BE49-F238E27FC236}">
-                <a16:creationId xmlns:a16="http://schemas.microsoft.com/office/drawing/2014/main" id="{0FD985E4-DC6F-4F94-A6AE-AD81C3D3DDE2}"/>
+                <a16:creationId xmlns:a16="http://schemas.microsoft.com/office/drawing/2014/main" id="{D5DAC80F-0BB5-44EE-BE8A-84318A32DFA8}"/>
               </a:ext>
             </a:extLst>
           </p:cNvPr>
@@ -12185,7 +12185,7 @@
           <p:cNvPr id="20" name="">
             <a:extLst xmlns:a="http://schemas.openxmlformats.org/drawingml/2006/main">
               <a:ext uri="{FF2B5EF4-FFF2-40B4-BE49-F238E27FC236}">
-                <a16:creationId xmlns:a16="http://schemas.microsoft.com/office/drawing/2014/main" id="{0C60284D-1ED0-40FB-8C4B-414559B5FFDB}"/>
+                <a16:creationId xmlns:a16="http://schemas.microsoft.com/office/drawing/2014/main" id="{71657365-5AD2-48D0-87C7-F16741DBB3CF}"/>
               </a:ext>
             </a:extLst>
           </p:cNvPr>
@@ -12235,7 +12235,7 @@
           <p:cNvPr id="21" name="">
             <a:extLst xmlns:a="http://schemas.openxmlformats.org/drawingml/2006/main">
               <a:ext uri="{FF2B5EF4-FFF2-40B4-BE49-F238E27FC236}">
-                <a16:creationId xmlns:a16="http://schemas.microsoft.com/office/drawing/2014/main" id="{D9D44161-A260-423F-8F05-CEB90980110D}"/>
+                <a16:creationId xmlns:a16="http://schemas.microsoft.com/office/drawing/2014/main" id="{FFC43F63-E353-4E7F-A8DA-0B504305AFA7}"/>
               </a:ext>
             </a:extLst>
           </p:cNvPr>
@@ -12285,7 +12285,7 @@
           <p:cNvPr id="22" name="">
             <a:extLst xmlns:a="http://schemas.openxmlformats.org/drawingml/2006/main">
               <a:ext uri="{FF2B5EF4-FFF2-40B4-BE49-F238E27FC236}">
-                <a16:creationId xmlns:a16="http://schemas.microsoft.com/office/drawing/2014/main" id="{01996393-5B08-4D9C-B207-4278255AC1E7}"/>
+                <a16:creationId xmlns:a16="http://schemas.microsoft.com/office/drawing/2014/main" id="{66FBF702-BB67-4A47-A3EC-64617C0FB49A}"/>
               </a:ext>
             </a:extLst>
           </p:cNvPr>
@@ -12320,7 +12320,7 @@
           <p:cNvPr id="23" name="">
             <a:extLst xmlns:a="http://schemas.openxmlformats.org/drawingml/2006/main">
               <a:ext uri="{FF2B5EF4-FFF2-40B4-BE49-F238E27FC236}">
-                <a16:creationId xmlns:a16="http://schemas.microsoft.com/office/drawing/2014/main" id="{9CBB55DB-75ED-4978-A66E-73601088508A}"/>
+                <a16:creationId xmlns:a16="http://schemas.microsoft.com/office/drawing/2014/main" id="{B248DF51-AA9E-469A-AFFA-5DA2743B1392}"/>
               </a:ext>
             </a:extLst>
           </p:cNvPr>
@@ -12353,7 +12353,7 @@
           <p:cNvPr id="24" name="">
             <a:extLst xmlns:a="http://schemas.openxmlformats.org/drawingml/2006/main">
               <a:ext uri="{FF2B5EF4-FFF2-40B4-BE49-F238E27FC236}">
-                <a16:creationId xmlns:a16="http://schemas.microsoft.com/office/drawing/2014/main" id="{A138349D-96FE-49F7-BB11-EA0BD4424403}"/>
+                <a16:creationId xmlns:a16="http://schemas.microsoft.com/office/drawing/2014/main" id="{0A89C34E-8D65-4D93-9BA9-87ADE25ADEB8}"/>
               </a:ext>
             </a:extLst>
           </p:cNvPr>
@@ -12403,7 +12403,7 @@
           <p:cNvPr id="25" name="">
             <a:extLst xmlns:a="http://schemas.openxmlformats.org/drawingml/2006/main">
               <a:ext uri="{FF2B5EF4-FFF2-40B4-BE49-F238E27FC236}">
-                <a16:creationId xmlns:a16="http://schemas.microsoft.com/office/drawing/2014/main" id="{12050301-4052-4CDA-9936-1C4CB9607511}"/>
+                <a16:creationId xmlns:a16="http://schemas.microsoft.com/office/drawing/2014/main" id="{FE3EB707-C225-4B0C-B514-61DBD182C3BE}"/>
               </a:ext>
             </a:extLst>
           </p:cNvPr>
@@ -12453,7 +12453,7 @@
           <p:cNvPr id="26" name="">
             <a:extLst xmlns:a="http://schemas.openxmlformats.org/drawingml/2006/main">
               <a:ext uri="{FF2B5EF4-FFF2-40B4-BE49-F238E27FC236}">
-                <a16:creationId xmlns:a16="http://schemas.microsoft.com/office/drawing/2014/main" id="{58AD6C1B-B481-4540-9A0E-774F5AB75C9F}"/>
+                <a16:creationId xmlns:a16="http://schemas.microsoft.com/office/drawing/2014/main" id="{1BDFD593-7D8A-412A-8B4D-7DF62B3DC509}"/>
               </a:ext>
             </a:extLst>
           </p:cNvPr>
@@ -12503,7 +12503,7 @@
           <p:cNvPr id="27" name="">
             <a:extLst xmlns:a="http://schemas.openxmlformats.org/drawingml/2006/main">
               <a:ext uri="{FF2B5EF4-FFF2-40B4-BE49-F238E27FC236}">
-                <a16:creationId xmlns:a16="http://schemas.microsoft.com/office/drawing/2014/main" id="{E1F7A4EE-AE3B-49CD-A7AB-9300FAA54128}"/>
+                <a16:creationId xmlns:a16="http://schemas.microsoft.com/office/drawing/2014/main" id="{64073CDE-D2F9-4D51-B105-EAD40C6348CB}"/>
               </a:ext>
             </a:extLst>
           </p:cNvPr>
@@ -12553,7 +12553,7 @@
           <p:cNvPr id="28" name="">
             <a:extLst xmlns:a="http://schemas.openxmlformats.org/drawingml/2006/main">
               <a:ext uri="{FF2B5EF4-FFF2-40B4-BE49-F238E27FC236}">
-                <a16:creationId xmlns:a16="http://schemas.microsoft.com/office/drawing/2014/main" id="{94FE3B91-8CB2-4251-95E8-AD14F3759859}"/>
+                <a16:creationId xmlns:a16="http://schemas.microsoft.com/office/drawing/2014/main" id="{564D760A-CD27-4A62-8F1F-7162279CB269}"/>
               </a:ext>
             </a:extLst>
           </p:cNvPr>
@@ -12586,7 +12586,7 @@
           <p:cNvPr id="29" name="">
             <a:extLst xmlns:a="http://schemas.openxmlformats.org/drawingml/2006/main">
               <a:ext uri="{FF2B5EF4-FFF2-40B4-BE49-F238E27FC236}">
-                <a16:creationId xmlns:a16="http://schemas.microsoft.com/office/drawing/2014/main" id="{B05BBBC7-6277-42C2-A41A-D0F96B486D18}"/>
+                <a16:creationId xmlns:a16="http://schemas.microsoft.com/office/drawing/2014/main" id="{2250E852-2611-4146-9C46-543B8790F449}"/>
               </a:ext>
             </a:extLst>
           </p:cNvPr>
@@ -12636,7 +12636,7 @@
           <p:cNvPr id="30" name="">
             <a:extLst xmlns:a="http://schemas.openxmlformats.org/drawingml/2006/main">
               <a:ext uri="{FF2B5EF4-FFF2-40B4-BE49-F238E27FC236}">
-                <a16:creationId xmlns:a16="http://schemas.microsoft.com/office/drawing/2014/main" id="{06E533D7-101D-434A-B967-64CCE10C6AEB}"/>
+                <a16:creationId xmlns:a16="http://schemas.microsoft.com/office/drawing/2014/main" id="{D862D2CB-5E39-4679-9E9E-9B53C619155C}"/>
               </a:ext>
             </a:extLst>
           </p:cNvPr>
@@ -12686,7 +12686,7 @@
           <p:cNvPr id="31" name="">
             <a:extLst xmlns:a="http://schemas.openxmlformats.org/drawingml/2006/main">
               <a:ext uri="{FF2B5EF4-FFF2-40B4-BE49-F238E27FC236}">
-                <a16:creationId xmlns:a16="http://schemas.microsoft.com/office/drawing/2014/main" id="{40F38747-61B0-4777-ABDA-99EE1C55F044}"/>
+                <a16:creationId xmlns:a16="http://schemas.microsoft.com/office/drawing/2014/main" id="{AF8B6C81-3233-4DE9-94BD-CD2895C7911B}"/>
               </a:ext>
             </a:extLst>
           </p:cNvPr>
@@ -12721,7 +12721,7 @@
           <p:cNvPr id="32" name="">
             <a:extLst xmlns:a="http://schemas.openxmlformats.org/drawingml/2006/main">
               <a:ext uri="{FF2B5EF4-FFF2-40B4-BE49-F238E27FC236}">
-                <a16:creationId xmlns:a16="http://schemas.microsoft.com/office/drawing/2014/main" id="{B3835AB1-EFCA-4FAC-9017-05B9B2C29C3C}"/>
+                <a16:creationId xmlns:a16="http://schemas.microsoft.com/office/drawing/2014/main" id="{02A5D4EF-4CDE-485B-B5AE-D47B28EFB2F0}"/>
               </a:ext>
             </a:extLst>
           </p:cNvPr>
@@ -12754,7 +12754,7 @@
           <p:cNvPr id="33" name="">
             <a:extLst xmlns:a="http://schemas.openxmlformats.org/drawingml/2006/main">
               <a:ext uri="{FF2B5EF4-FFF2-40B4-BE49-F238E27FC236}">
-                <a16:creationId xmlns:a16="http://schemas.microsoft.com/office/drawing/2014/main" id="{BC39866F-6841-417C-ABA8-64BD33C47905}"/>
+                <a16:creationId xmlns:a16="http://schemas.microsoft.com/office/drawing/2014/main" id="{2ED8B9CD-3E26-4CBA-BA37-4DA91D4A8A90}"/>
               </a:ext>
             </a:extLst>
           </p:cNvPr>
@@ -12804,7 +12804,7 @@
           <p:cNvPr id="34" name="">
             <a:extLst xmlns:a="http://schemas.openxmlformats.org/drawingml/2006/main">
               <a:ext uri="{FF2B5EF4-FFF2-40B4-BE49-F238E27FC236}">
-                <a16:creationId xmlns:a16="http://schemas.microsoft.com/office/drawing/2014/main" id="{4EAE5000-0523-4785-B929-DA1C423F3131}"/>
+                <a16:creationId xmlns:a16="http://schemas.microsoft.com/office/drawing/2014/main" id="{A83C7E2E-DB9F-42BD-831C-AE41582E4E9C}"/>
               </a:ext>
             </a:extLst>
           </p:cNvPr>
@@ -12854,7 +12854,7 @@
           <p:cNvPr id="35" name="">
             <a:extLst xmlns:a="http://schemas.openxmlformats.org/drawingml/2006/main">
               <a:ext uri="{FF2B5EF4-FFF2-40B4-BE49-F238E27FC236}">
-                <a16:creationId xmlns:a16="http://schemas.microsoft.com/office/drawing/2014/main" id="{2DDE1D72-65A3-4BF0-98AA-BC957D7C326B}"/>
+                <a16:creationId xmlns:a16="http://schemas.microsoft.com/office/drawing/2014/main" id="{4B35280E-A21C-4713-A3AB-8110366D33ED}"/>
               </a:ext>
             </a:extLst>
           </p:cNvPr>
@@ -12904,7 +12904,7 @@
           <p:cNvPr id="36" name="">
             <a:extLst xmlns:a="http://schemas.openxmlformats.org/drawingml/2006/main">
               <a:ext uri="{FF2B5EF4-FFF2-40B4-BE49-F238E27FC236}">
-                <a16:creationId xmlns:a16="http://schemas.microsoft.com/office/drawing/2014/main" id="{F164FB0A-579A-4028-BD54-A38376EA6980}"/>
+                <a16:creationId xmlns:a16="http://schemas.microsoft.com/office/drawing/2014/main" id="{FFB862D9-92CA-4F17-8D7E-9012C3ACC1D6}"/>
               </a:ext>
             </a:extLst>
           </p:cNvPr>
@@ -12954,7 +12954,7 @@
           <p:cNvPr id="37" name="">
             <a:extLst xmlns:a="http://schemas.openxmlformats.org/drawingml/2006/main">
               <a:ext uri="{FF2B5EF4-FFF2-40B4-BE49-F238E27FC236}">
-                <a16:creationId xmlns:a16="http://schemas.microsoft.com/office/drawing/2014/main" id="{88410A1B-D6C0-4EE5-A110-F2D258729898}"/>
+                <a16:creationId xmlns:a16="http://schemas.microsoft.com/office/drawing/2014/main" id="{B8F7309A-157D-4866-B1A4-882A4272D0DF}"/>
               </a:ext>
             </a:extLst>
           </p:cNvPr>
@@ -12987,7 +12987,7 @@
           <p:cNvPr id="38" name="">
             <a:extLst xmlns:a="http://schemas.openxmlformats.org/drawingml/2006/main">
               <a:ext uri="{FF2B5EF4-FFF2-40B4-BE49-F238E27FC236}">
-                <a16:creationId xmlns:a16="http://schemas.microsoft.com/office/drawing/2014/main" id="{F189BCDE-CDA1-4F1F-B1A6-E061D4755258}"/>
+                <a16:creationId xmlns:a16="http://schemas.microsoft.com/office/drawing/2014/main" id="{540FE2F0-56DE-4FEC-8666-F226D2E5F51A}"/>
               </a:ext>
             </a:extLst>
           </p:cNvPr>
@@ -13037,7 +13037,7 @@
           <p:cNvPr id="39" name="">
             <a:extLst xmlns:a="http://schemas.openxmlformats.org/drawingml/2006/main">
               <a:ext uri="{FF2B5EF4-FFF2-40B4-BE49-F238E27FC236}">
-                <a16:creationId xmlns:a16="http://schemas.microsoft.com/office/drawing/2014/main" id="{8BD19CC0-6D21-4B1B-BF08-5E1BB5F84CD4}"/>
+                <a16:creationId xmlns:a16="http://schemas.microsoft.com/office/drawing/2014/main" id="{20758CBD-6313-46D2-8C06-2EFA44227D62}"/>
               </a:ext>
             </a:extLst>
           </p:cNvPr>
@@ -13085,7 +13085,7 @@
     </p:spTree>
     <p:extLst>
       <p:ext uri="{BB962C8B-B14F-4D97-AF65-F5344CB8AC3E}">
-        <p14:creationId xmlns:p14="http://schemas.microsoft.com/office/powerpoint/2010/main" val="76120923"/>
+        <p14:creationId xmlns:p14="http://schemas.microsoft.com/office/powerpoint/2010/main" val="1604947651"/>
       </p:ext>
     </p:extLst>
   </p:cSld>
@@ -13116,7 +13116,7 @@
           <p:cNvPr id="31" name="">
             <a:extLst xmlns:a="http://schemas.openxmlformats.org/drawingml/2006/main">
               <a:ext uri="{FF2B5EF4-FFF2-40B4-BE49-F238E27FC236}">
-                <a16:creationId xmlns:a16="http://schemas.microsoft.com/office/drawing/2014/main" id="{3F377E14-B993-4369-8979-6D099967296A}"/>
+                <a16:creationId xmlns:a16="http://schemas.microsoft.com/office/drawing/2014/main" id="{E5AE2502-CC68-458D-B206-643AF917968C}"/>
               </a:ext>
             </a:extLst>
           </p:cNvPr>
@@ -13149,7 +13149,7 @@
           <p:cNvPr id="2" name="">
             <a:extLst xmlns:a="http://schemas.openxmlformats.org/drawingml/2006/main">
               <a:ext uri="{FF2B5EF4-FFF2-40B4-BE49-F238E27FC236}">
-                <a16:creationId xmlns:a16="http://schemas.microsoft.com/office/drawing/2014/main" id="{53112953-18C5-4BDF-A58E-EC6CF9D4F6D6}"/>
+                <a16:creationId xmlns:a16="http://schemas.microsoft.com/office/drawing/2014/main" id="{DB1AA8C4-1A7F-40AC-A061-A55289867EA3}"/>
               </a:ext>
             </a:extLst>
           </p:cNvPr>
@@ -13199,7 +13199,7 @@
           <p:cNvPr id="3" name="">
             <a:extLst xmlns:a="http://schemas.openxmlformats.org/drawingml/2006/main">
               <a:ext uri="{FF2B5EF4-FFF2-40B4-BE49-F238E27FC236}">
-                <a16:creationId xmlns:a16="http://schemas.microsoft.com/office/drawing/2014/main" id="{0E11A829-5482-4363-8F49-00A7436C76F7}"/>
+                <a16:creationId xmlns:a16="http://schemas.microsoft.com/office/drawing/2014/main" id="{C422CFE2-27A5-456F-82F0-06EE4C8F688B}"/>
               </a:ext>
             </a:extLst>
           </p:cNvPr>
@@ -13249,7 +13249,7 @@
           <p:cNvPr id="4" name="">
             <a:extLst xmlns:a="http://schemas.openxmlformats.org/drawingml/2006/main">
               <a:ext uri="{FF2B5EF4-FFF2-40B4-BE49-F238E27FC236}">
-                <a16:creationId xmlns:a16="http://schemas.microsoft.com/office/drawing/2014/main" id="{34A7418B-DD90-4F68-8DE9-A4013B821394}"/>
+                <a16:creationId xmlns:a16="http://schemas.microsoft.com/office/drawing/2014/main" id="{E4843842-45A2-4E2E-BA90-EC60DAED1619}"/>
               </a:ext>
             </a:extLst>
           </p:cNvPr>
@@ -13299,7 +13299,7 @@
           <p:cNvPr id="5" name="">
             <a:extLst xmlns:a="http://schemas.openxmlformats.org/drawingml/2006/main">
               <a:ext uri="{FF2B5EF4-FFF2-40B4-BE49-F238E27FC236}">
-                <a16:creationId xmlns:a16="http://schemas.microsoft.com/office/drawing/2014/main" id="{D693827F-685F-4222-993E-42C94BB54781}"/>
+                <a16:creationId xmlns:a16="http://schemas.microsoft.com/office/drawing/2014/main" id="{3719F6BF-6CB8-42A2-8B95-94AC76EA7433}"/>
               </a:ext>
             </a:extLst>
           </p:cNvPr>
@@ -13349,7 +13349,7 @@
           <p:cNvPr id="6" name="">
             <a:extLst xmlns:a="http://schemas.openxmlformats.org/drawingml/2006/main">
               <a:ext uri="{FF2B5EF4-FFF2-40B4-BE49-F238E27FC236}">
-                <a16:creationId xmlns:a16="http://schemas.microsoft.com/office/drawing/2014/main" id="{E739E7E5-FDDA-4174-9FF7-7A459DE118E3}"/>
+                <a16:creationId xmlns:a16="http://schemas.microsoft.com/office/drawing/2014/main" id="{5707DDA7-6594-42B5-BA0D-19DEACB619A0}"/>
               </a:ext>
             </a:extLst>
           </p:cNvPr>
@@ -13382,7 +13382,7 @@
           <p:cNvPr id="7" name="">
             <a:extLst xmlns:a="http://schemas.openxmlformats.org/drawingml/2006/main">
               <a:ext uri="{FF2B5EF4-FFF2-40B4-BE49-F238E27FC236}">
-                <a16:creationId xmlns:a16="http://schemas.microsoft.com/office/drawing/2014/main" id="{26BC4921-F039-4277-B6FD-1BF8D44E92D6}"/>
+                <a16:creationId xmlns:a16="http://schemas.microsoft.com/office/drawing/2014/main" id="{5556E8E8-F69F-42BB-989C-27200C50AC27}"/>
               </a:ext>
             </a:extLst>
           </p:cNvPr>
@@ -13417,7 +13417,7 @@
           <p:cNvPr id="8" name="">
             <a:extLst xmlns:a="http://schemas.openxmlformats.org/drawingml/2006/main">
               <a:ext uri="{FF2B5EF4-FFF2-40B4-BE49-F238E27FC236}">
-                <a16:creationId xmlns:a16="http://schemas.microsoft.com/office/drawing/2014/main" id="{1146A07D-C8FC-400D-A085-06686895F69B}"/>
+                <a16:creationId xmlns:a16="http://schemas.microsoft.com/office/drawing/2014/main" id="{FE4F9D42-E242-41B7-9D63-F01FC63E4334}"/>
               </a:ext>
             </a:extLst>
           </p:cNvPr>
@@ -13450,7 +13450,7 @@
           <p:cNvPr id="9" name="">
             <a:extLst xmlns:a="http://schemas.openxmlformats.org/drawingml/2006/main">
               <a:ext uri="{FF2B5EF4-FFF2-40B4-BE49-F238E27FC236}">
-                <a16:creationId xmlns:a16="http://schemas.microsoft.com/office/drawing/2014/main" id="{B0189812-F164-4837-8C14-A96CD97590D4}"/>
+                <a16:creationId xmlns:a16="http://schemas.microsoft.com/office/drawing/2014/main" id="{8AE68E94-B585-4C23-AB98-BC42D604A118}"/>
               </a:ext>
             </a:extLst>
           </p:cNvPr>
@@ -13500,7 +13500,7 @@
           <p:cNvPr id="10" name="">
             <a:extLst xmlns:a="http://schemas.openxmlformats.org/drawingml/2006/main">
               <a:ext uri="{FF2B5EF4-FFF2-40B4-BE49-F238E27FC236}">
-                <a16:creationId xmlns:a16="http://schemas.microsoft.com/office/drawing/2014/main" id="{9995D63B-8FCE-44DB-8A50-4E67FC973AC8}"/>
+                <a16:creationId xmlns:a16="http://schemas.microsoft.com/office/drawing/2014/main" id="{ABCF2D1C-CB89-4C4C-8965-369425579968}"/>
               </a:ext>
             </a:extLst>
           </p:cNvPr>
@@ -13550,7 +13550,7 @@
           <p:cNvPr id="11" name="">
             <a:extLst xmlns:a="http://schemas.openxmlformats.org/drawingml/2006/main">
               <a:ext uri="{FF2B5EF4-FFF2-40B4-BE49-F238E27FC236}">
-                <a16:creationId xmlns:a16="http://schemas.microsoft.com/office/drawing/2014/main" id="{5290DBD5-33BD-41D3-B2A6-910F527CCE94}"/>
+                <a16:creationId xmlns:a16="http://schemas.microsoft.com/office/drawing/2014/main" id="{D6BA5F7D-EE33-48E8-A1A7-4E13DC23C0D7}"/>
               </a:ext>
             </a:extLst>
           </p:cNvPr>
@@ -13600,7 +13600,7 @@
           <p:cNvPr id="12" name="">
             <a:extLst xmlns:a="http://schemas.openxmlformats.org/drawingml/2006/main">
               <a:ext uri="{FF2B5EF4-FFF2-40B4-BE49-F238E27FC236}">
-                <a16:creationId xmlns:a16="http://schemas.microsoft.com/office/drawing/2014/main" id="{5E772562-AEBB-424C-A238-DEB6FF7A9671}"/>
+                <a16:creationId xmlns:a16="http://schemas.microsoft.com/office/drawing/2014/main" id="{E3924470-8467-4CDC-8896-C6ACDF806321}"/>
               </a:ext>
             </a:extLst>
           </p:cNvPr>
@@ -13650,7 +13650,7 @@
           <p:cNvPr id="13" name="">
             <a:extLst xmlns:a="http://schemas.openxmlformats.org/drawingml/2006/main">
               <a:ext uri="{FF2B5EF4-FFF2-40B4-BE49-F238E27FC236}">
-                <a16:creationId xmlns:a16="http://schemas.microsoft.com/office/drawing/2014/main" id="{3CF8A2CC-8104-461C-AD44-1C7F4F5078CA}"/>
+                <a16:creationId xmlns:a16="http://schemas.microsoft.com/office/drawing/2014/main" id="{EEF0A2B4-36A3-47E2-BD0B-C684C18D782D}"/>
               </a:ext>
             </a:extLst>
           </p:cNvPr>
@@ -13685,7 +13685,7 @@
           <p:cNvPr id="14" name="">
             <a:extLst xmlns:a="http://schemas.openxmlformats.org/drawingml/2006/main">
               <a:ext uri="{FF2B5EF4-FFF2-40B4-BE49-F238E27FC236}">
-                <a16:creationId xmlns:a16="http://schemas.microsoft.com/office/drawing/2014/main" id="{811FDE4F-014A-4251-BB65-56914F35158E}"/>
+                <a16:creationId xmlns:a16="http://schemas.microsoft.com/office/drawing/2014/main" id="{156B3C2E-E5AB-4791-B9F6-E64E1FCD92D8}"/>
               </a:ext>
             </a:extLst>
           </p:cNvPr>
@@ -13718,7 +13718,7 @@
           <p:cNvPr id="15" name="">
             <a:extLst xmlns:a="http://schemas.openxmlformats.org/drawingml/2006/main">
               <a:ext uri="{FF2B5EF4-FFF2-40B4-BE49-F238E27FC236}">
-                <a16:creationId xmlns:a16="http://schemas.microsoft.com/office/drawing/2014/main" id="{A0846609-55D8-4039-BA51-21B8EE0EDE42}"/>
+                <a16:creationId xmlns:a16="http://schemas.microsoft.com/office/drawing/2014/main" id="{8946B6A8-8FE2-4094-9921-D5440AA46C36}"/>
               </a:ext>
             </a:extLst>
           </p:cNvPr>
@@ -13768,7 +13768,7 @@
           <p:cNvPr id="16" name="">
             <a:extLst xmlns:a="http://schemas.openxmlformats.org/drawingml/2006/main">
               <a:ext uri="{FF2B5EF4-FFF2-40B4-BE49-F238E27FC236}">
-                <a16:creationId xmlns:a16="http://schemas.microsoft.com/office/drawing/2014/main" id="{607ECFBA-48A3-4D1A-B222-CFE8418C7B3E}"/>
+                <a16:creationId xmlns:a16="http://schemas.microsoft.com/office/drawing/2014/main" id="{9F96F6D1-390B-4C2D-A367-5CFAAAE39BBA}"/>
               </a:ext>
             </a:extLst>
           </p:cNvPr>
@@ -13818,7 +13818,7 @@
           <p:cNvPr id="17" name="">
             <a:extLst xmlns:a="http://schemas.openxmlformats.org/drawingml/2006/main">
               <a:ext uri="{FF2B5EF4-FFF2-40B4-BE49-F238E27FC236}">
-                <a16:creationId xmlns:a16="http://schemas.microsoft.com/office/drawing/2014/main" id="{FCEF64CC-E5A6-4504-B435-3DFC7C72A873}"/>
+                <a16:creationId xmlns:a16="http://schemas.microsoft.com/office/drawing/2014/main" id="{174E3123-41E5-4527-B0EF-A91294CE4F95}"/>
               </a:ext>
             </a:extLst>
           </p:cNvPr>
@@ -13868,7 +13868,7 @@
           <p:cNvPr id="18" name="">
             <a:extLst xmlns:a="http://schemas.openxmlformats.org/drawingml/2006/main">
               <a:ext uri="{FF2B5EF4-FFF2-40B4-BE49-F238E27FC236}">
-                <a16:creationId xmlns:a16="http://schemas.microsoft.com/office/drawing/2014/main" id="{FAED4489-D0B7-4CD4-9D2D-D50F39BDB3B6}"/>
+                <a16:creationId xmlns:a16="http://schemas.microsoft.com/office/drawing/2014/main" id="{69FEC8EF-073E-4C40-B7CD-EA600AFE0509}"/>
               </a:ext>
             </a:extLst>
           </p:cNvPr>
@@ -13918,7 +13918,7 @@
           <p:cNvPr id="19" name="">
             <a:extLst xmlns:a="http://schemas.openxmlformats.org/drawingml/2006/main">
               <a:ext uri="{FF2B5EF4-FFF2-40B4-BE49-F238E27FC236}">
-                <a16:creationId xmlns:a16="http://schemas.microsoft.com/office/drawing/2014/main" id="{8F921339-2B67-43CE-92F4-BA06D1661A93}"/>
+                <a16:creationId xmlns:a16="http://schemas.microsoft.com/office/drawing/2014/main" id="{0B133063-F385-4DF8-985A-3991551AEB25}"/>
               </a:ext>
             </a:extLst>
           </p:cNvPr>
@@ -13951,7 +13951,7 @@
           <p:cNvPr id="20" name="">
             <a:extLst xmlns:a="http://schemas.openxmlformats.org/drawingml/2006/main">
               <a:ext uri="{FF2B5EF4-FFF2-40B4-BE49-F238E27FC236}">
-                <a16:creationId xmlns:a16="http://schemas.microsoft.com/office/drawing/2014/main" id="{C9837655-A60D-4C42-AA49-A76539A63DDA}"/>
+                <a16:creationId xmlns:a16="http://schemas.microsoft.com/office/drawing/2014/main" id="{75592E7F-3060-49C7-A72F-CA513EB3C746}"/>
               </a:ext>
             </a:extLst>
           </p:cNvPr>
@@ -14001,7 +14001,7 @@
           <p:cNvPr id="21" name="">
             <a:extLst xmlns:a="http://schemas.openxmlformats.org/drawingml/2006/main">
               <a:ext uri="{FF2B5EF4-FFF2-40B4-BE49-F238E27FC236}">
-                <a16:creationId xmlns:a16="http://schemas.microsoft.com/office/drawing/2014/main" id="{8AC3B6B1-F1D1-41D5-B7D1-663D1B4D4C8D}"/>
+                <a16:creationId xmlns:a16="http://schemas.microsoft.com/office/drawing/2014/main" id="{D6DD38A6-CD38-4473-83FB-2EB2CEF6D95A}"/>
               </a:ext>
             </a:extLst>
           </p:cNvPr>
@@ -14051,7 +14051,7 @@
           <p:cNvPr id="22" name="">
             <a:extLst xmlns:a="http://schemas.openxmlformats.org/drawingml/2006/main">
               <a:ext uri="{FF2B5EF4-FFF2-40B4-BE49-F238E27FC236}">
-                <a16:creationId xmlns:a16="http://schemas.microsoft.com/office/drawing/2014/main" id="{EA85A0DB-CE2A-44A7-89B6-A6085A54DDD6}"/>
+                <a16:creationId xmlns:a16="http://schemas.microsoft.com/office/drawing/2014/main" id="{CDA0398F-283A-4F65-8A56-B72249F87F81}"/>
               </a:ext>
             </a:extLst>
           </p:cNvPr>
@@ -14086,7 +14086,7 @@
           <p:cNvPr id="23" name="">
             <a:extLst xmlns:a="http://schemas.openxmlformats.org/drawingml/2006/main">
               <a:ext uri="{FF2B5EF4-FFF2-40B4-BE49-F238E27FC236}">
-                <a16:creationId xmlns:a16="http://schemas.microsoft.com/office/drawing/2014/main" id="{96A61404-D31D-4570-96C2-4EDCFF26C2DF}"/>
+                <a16:creationId xmlns:a16="http://schemas.microsoft.com/office/drawing/2014/main" id="{2CC8DACC-28F4-4D7C-975F-D5521A4B13DB}"/>
               </a:ext>
             </a:extLst>
           </p:cNvPr>
@@ -14119,7 +14119,7 @@
           <p:cNvPr id="24" name="">
             <a:extLst xmlns:a="http://schemas.openxmlformats.org/drawingml/2006/main">
               <a:ext uri="{FF2B5EF4-FFF2-40B4-BE49-F238E27FC236}">
-                <a16:creationId xmlns:a16="http://schemas.microsoft.com/office/drawing/2014/main" id="{6A52AF7D-8C3F-4EEF-B2B3-476381668547}"/>
+                <a16:creationId xmlns:a16="http://schemas.microsoft.com/office/drawing/2014/main" id="{A5841CBB-F490-4163-8011-B045926ACEEB}"/>
               </a:ext>
             </a:extLst>
           </p:cNvPr>
@@ -14169,7 +14169,7 @@
           <p:cNvPr id="25" name="">
             <a:extLst xmlns:a="http://schemas.openxmlformats.org/drawingml/2006/main">
               <a:ext uri="{FF2B5EF4-FFF2-40B4-BE49-F238E27FC236}">
-                <a16:creationId xmlns:a16="http://schemas.microsoft.com/office/drawing/2014/main" id="{4F6BEA53-2763-4EB0-9AE1-3C51528FF846}"/>
+                <a16:creationId xmlns:a16="http://schemas.microsoft.com/office/drawing/2014/main" id="{13401042-C587-497B-B9DE-E92C17E433CB}"/>
               </a:ext>
             </a:extLst>
           </p:cNvPr>
@@ -14219,7 +14219,7 @@
           <p:cNvPr id="26" name="">
             <a:extLst xmlns:a="http://schemas.openxmlformats.org/drawingml/2006/main">
               <a:ext uri="{FF2B5EF4-FFF2-40B4-BE49-F238E27FC236}">
-                <a16:creationId xmlns:a16="http://schemas.microsoft.com/office/drawing/2014/main" id="{98118AA0-5D41-46B2-B2F8-2179549126F5}"/>
+                <a16:creationId xmlns:a16="http://schemas.microsoft.com/office/drawing/2014/main" id="{CE92BA35-044F-4A38-B8ED-598BFA8C3D03}"/>
               </a:ext>
             </a:extLst>
           </p:cNvPr>
@@ -14269,7 +14269,7 @@
           <p:cNvPr id="27" name="">
             <a:extLst xmlns:a="http://schemas.openxmlformats.org/drawingml/2006/main">
               <a:ext uri="{FF2B5EF4-FFF2-40B4-BE49-F238E27FC236}">
-                <a16:creationId xmlns:a16="http://schemas.microsoft.com/office/drawing/2014/main" id="{89AEDE0C-0CE4-4703-B794-F25885A778A6}"/>
+                <a16:creationId xmlns:a16="http://schemas.microsoft.com/office/drawing/2014/main" id="{86AFA489-986B-44CC-BF03-B1B859D16A30}"/>
               </a:ext>
             </a:extLst>
           </p:cNvPr>
@@ -14319,7 +14319,7 @@
           <p:cNvPr id="28" name="">
             <a:extLst xmlns:a="http://schemas.openxmlformats.org/drawingml/2006/main">
               <a:ext uri="{FF2B5EF4-FFF2-40B4-BE49-F238E27FC236}">
-                <a16:creationId xmlns:a16="http://schemas.microsoft.com/office/drawing/2014/main" id="{90835475-C654-4A35-95A5-23D3EC18BC97}"/>
+                <a16:creationId xmlns:a16="http://schemas.microsoft.com/office/drawing/2014/main" id="{09B6F790-28F7-4CD2-A307-8262B22EF1B2}"/>
               </a:ext>
             </a:extLst>
           </p:cNvPr>
@@ -14352,7 +14352,7 @@
           <p:cNvPr id="29" name="">
             <a:extLst xmlns:a="http://schemas.openxmlformats.org/drawingml/2006/main">
               <a:ext uri="{FF2B5EF4-FFF2-40B4-BE49-F238E27FC236}">
-                <a16:creationId xmlns:a16="http://schemas.microsoft.com/office/drawing/2014/main" id="{C02D7EEF-C9F7-40A2-B503-93714A6C1190}"/>
+                <a16:creationId xmlns:a16="http://schemas.microsoft.com/office/drawing/2014/main" id="{CD0D7413-CDDF-4F27-A531-A51DF1DB1A14}"/>
               </a:ext>
             </a:extLst>
           </p:cNvPr>
@@ -14402,7 +14402,7 @@
           <p:cNvPr id="30" name="">
             <a:extLst xmlns:a="http://schemas.openxmlformats.org/drawingml/2006/main">
               <a:ext uri="{FF2B5EF4-FFF2-40B4-BE49-F238E27FC236}">
-                <a16:creationId xmlns:a16="http://schemas.microsoft.com/office/drawing/2014/main" id="{22C0DFE8-465F-4534-9A4D-8AF34DD4DA36}"/>
+                <a16:creationId xmlns:a16="http://schemas.microsoft.com/office/drawing/2014/main" id="{2AC9F577-D6D3-43D6-AC6E-AC4767C24E55}"/>
               </a:ext>
             </a:extLst>
           </p:cNvPr>
@@ -14450,7 +14450,7 @@
     </p:spTree>
     <p:extLst>
       <p:ext uri="{BB962C8B-B14F-4D97-AF65-F5344CB8AC3E}">
-        <p14:creationId xmlns:p14="http://schemas.microsoft.com/office/powerpoint/2010/main" val="938081051"/>
+        <p14:creationId xmlns:p14="http://schemas.microsoft.com/office/powerpoint/2010/main" val="343663371"/>
       </p:ext>
     </p:extLst>
   </p:cSld>
@@ -14481,7 +14481,7 @@
           <p:cNvPr id="25" name="">
             <a:extLst xmlns:a="http://schemas.openxmlformats.org/drawingml/2006/main">
               <a:ext uri="{FF2B5EF4-FFF2-40B4-BE49-F238E27FC236}">
-                <a16:creationId xmlns:a16="http://schemas.microsoft.com/office/drawing/2014/main" id="{1D5753D9-0435-44DB-ADD3-8E2DD9515D0C}"/>
+                <a16:creationId xmlns:a16="http://schemas.microsoft.com/office/drawing/2014/main" id="{6513BC36-6B92-47AB-B965-7AF78B0E058A}"/>
               </a:ext>
             </a:extLst>
           </p:cNvPr>
@@ -14514,7 +14514,7 @@
           <p:cNvPr id="2" name="">
             <a:extLst xmlns:a="http://schemas.openxmlformats.org/drawingml/2006/main">
               <a:ext uri="{FF2B5EF4-FFF2-40B4-BE49-F238E27FC236}">
-                <a16:creationId xmlns:a16="http://schemas.microsoft.com/office/drawing/2014/main" id="{917CEE30-DB0B-42F7-9164-9702E1D74656}"/>
+                <a16:creationId xmlns:a16="http://schemas.microsoft.com/office/drawing/2014/main" id="{E8091F99-066E-487E-BF8E-367247B64C62}"/>
               </a:ext>
             </a:extLst>
           </p:cNvPr>
@@ -14564,7 +14564,7 @@
           <p:cNvPr id="3" name="">
             <a:extLst xmlns:a="http://schemas.openxmlformats.org/drawingml/2006/main">
               <a:ext uri="{FF2B5EF4-FFF2-40B4-BE49-F238E27FC236}">
-                <a16:creationId xmlns:a16="http://schemas.microsoft.com/office/drawing/2014/main" id="{62122FFA-953E-4856-B64B-6EC52EDA7C19}"/>
+                <a16:creationId xmlns:a16="http://schemas.microsoft.com/office/drawing/2014/main" id="{CA1BE3E3-F3AF-4D36-A831-851CA5EE0BBB}"/>
               </a:ext>
             </a:extLst>
           </p:cNvPr>
@@ -14614,7 +14614,7 @@
           <p:cNvPr id="4" name="">
             <a:extLst xmlns:a="http://schemas.openxmlformats.org/drawingml/2006/main">
               <a:ext uri="{FF2B5EF4-FFF2-40B4-BE49-F238E27FC236}">
-                <a16:creationId xmlns:a16="http://schemas.microsoft.com/office/drawing/2014/main" id="{3D3993A3-687F-4DE9-B1A2-5DD565F89C10}"/>
+                <a16:creationId xmlns:a16="http://schemas.microsoft.com/office/drawing/2014/main" id="{21400B41-6818-4D09-A026-943CF269BA8E}"/>
               </a:ext>
             </a:extLst>
           </p:cNvPr>
@@ -14664,7 +14664,7 @@
           <p:cNvPr id="5" name="">
             <a:extLst xmlns:a="http://schemas.openxmlformats.org/drawingml/2006/main">
               <a:ext uri="{FF2B5EF4-FFF2-40B4-BE49-F238E27FC236}">
-                <a16:creationId xmlns:a16="http://schemas.microsoft.com/office/drawing/2014/main" id="{13B5699E-CB43-4B2B-A11F-B080E1A80C3C}"/>
+                <a16:creationId xmlns:a16="http://schemas.microsoft.com/office/drawing/2014/main" id="{F021CCB0-30EF-465F-B1E2-1409CE439A1A}"/>
               </a:ext>
             </a:extLst>
           </p:cNvPr>
@@ -14714,7 +14714,7 @@
           <p:cNvPr id="6" name="">
             <a:extLst xmlns:a="http://schemas.openxmlformats.org/drawingml/2006/main">
               <a:ext uri="{FF2B5EF4-FFF2-40B4-BE49-F238E27FC236}">
-                <a16:creationId xmlns:a16="http://schemas.microsoft.com/office/drawing/2014/main" id="{EAD98531-71BA-44F4-AABB-B2B7067FA59F}"/>
+                <a16:creationId xmlns:a16="http://schemas.microsoft.com/office/drawing/2014/main" id="{12D45C11-65F6-4C78-9AE3-4402C87D0338}"/>
               </a:ext>
             </a:extLst>
           </p:cNvPr>
@@ -14747,7 +14747,7 @@
           <p:cNvPr id="7" name="">
             <a:extLst xmlns:a="http://schemas.openxmlformats.org/drawingml/2006/main">
               <a:ext uri="{FF2B5EF4-FFF2-40B4-BE49-F238E27FC236}">
-                <a16:creationId xmlns:a16="http://schemas.microsoft.com/office/drawing/2014/main" id="{5CB77616-450B-4821-B421-E02D816DF31A}"/>
+                <a16:creationId xmlns:a16="http://schemas.microsoft.com/office/drawing/2014/main" id="{88C96801-666D-4F58-83E4-82C773999632}"/>
               </a:ext>
             </a:extLst>
           </p:cNvPr>
@@ -14782,7 +14782,7 @@
           <p:cNvPr id="8" name="">
             <a:extLst xmlns:a="http://schemas.openxmlformats.org/drawingml/2006/main">
               <a:ext uri="{FF2B5EF4-FFF2-40B4-BE49-F238E27FC236}">
-                <a16:creationId xmlns:a16="http://schemas.microsoft.com/office/drawing/2014/main" id="{9F335DAF-3D1D-4540-B37C-31FFF6BA9F44}"/>
+                <a16:creationId xmlns:a16="http://schemas.microsoft.com/office/drawing/2014/main" id="{40FC60C0-77D8-4F46-954B-7C390AB09F64}"/>
               </a:ext>
             </a:extLst>
           </p:cNvPr>
@@ -14815,7 +14815,7 @@
           <p:cNvPr id="9" name="">
             <a:extLst xmlns:a="http://schemas.openxmlformats.org/drawingml/2006/main">
               <a:ext uri="{FF2B5EF4-FFF2-40B4-BE49-F238E27FC236}">
-                <a16:creationId xmlns:a16="http://schemas.microsoft.com/office/drawing/2014/main" id="{304F93DA-9763-4AF2-B4D0-D66DB1066425}"/>
+                <a16:creationId xmlns:a16="http://schemas.microsoft.com/office/drawing/2014/main" id="{34EE20C7-B388-4788-9E03-90398F6F6B6F}"/>
               </a:ext>
             </a:extLst>
           </p:cNvPr>
@@ -14865,7 +14865,7 @@
           <p:cNvPr id="10" name="">
             <a:extLst xmlns:a="http://schemas.openxmlformats.org/drawingml/2006/main">
               <a:ext uri="{FF2B5EF4-FFF2-40B4-BE49-F238E27FC236}">
-                <a16:creationId xmlns:a16="http://schemas.microsoft.com/office/drawing/2014/main" id="{959342E6-8785-4B1D-B3D0-1AD639308C6C}"/>
+                <a16:creationId xmlns:a16="http://schemas.microsoft.com/office/drawing/2014/main" id="{2B7D14CA-88A1-4E95-98F3-06A40B7B91AE}"/>
               </a:ext>
             </a:extLst>
           </p:cNvPr>
@@ -14915,7 +14915,7 @@
           <p:cNvPr id="11" name="">
             <a:extLst xmlns:a="http://schemas.openxmlformats.org/drawingml/2006/main">
               <a:ext uri="{FF2B5EF4-FFF2-40B4-BE49-F238E27FC236}">
-                <a16:creationId xmlns:a16="http://schemas.microsoft.com/office/drawing/2014/main" id="{177D0D2F-E299-4D4A-A1AD-661323A8AB51}"/>
+                <a16:creationId xmlns:a16="http://schemas.microsoft.com/office/drawing/2014/main" id="{FA1B9893-A86A-43D2-AD97-1108FF2F421C}"/>
               </a:ext>
             </a:extLst>
           </p:cNvPr>
@@ -14965,7 +14965,7 @@
           <p:cNvPr id="12" name="">
             <a:extLst xmlns:a="http://schemas.openxmlformats.org/drawingml/2006/main">
               <a:ext uri="{FF2B5EF4-FFF2-40B4-BE49-F238E27FC236}">
-                <a16:creationId xmlns:a16="http://schemas.microsoft.com/office/drawing/2014/main" id="{61CA42D7-F366-4670-BC29-ECF89CD4F1CF}"/>
+                <a16:creationId xmlns:a16="http://schemas.microsoft.com/office/drawing/2014/main" id="{A82ADF7B-ABBF-48BB-844C-E71FD5E07ACF}"/>
               </a:ext>
             </a:extLst>
           </p:cNvPr>
@@ -15015,7 +15015,7 @@
           <p:cNvPr id="13" name="">
             <a:extLst xmlns:a="http://schemas.openxmlformats.org/drawingml/2006/main">
               <a:ext uri="{FF2B5EF4-FFF2-40B4-BE49-F238E27FC236}">
-                <a16:creationId xmlns:a16="http://schemas.microsoft.com/office/drawing/2014/main" id="{B6A1C762-1A99-44D5-B5D1-58D0F88B8521}"/>
+                <a16:creationId xmlns:a16="http://schemas.microsoft.com/office/drawing/2014/main" id="{E34508D3-111A-476E-9529-C44B1F6EC0C6}"/>
               </a:ext>
             </a:extLst>
           </p:cNvPr>
@@ -15048,7 +15048,7 @@
           <p:cNvPr id="14" name="">
             <a:extLst xmlns:a="http://schemas.openxmlformats.org/drawingml/2006/main">
               <a:ext uri="{FF2B5EF4-FFF2-40B4-BE49-F238E27FC236}">
-                <a16:creationId xmlns:a16="http://schemas.microsoft.com/office/drawing/2014/main" id="{E34AD081-524A-4F9F-A45E-5910FE880222}"/>
+                <a16:creationId xmlns:a16="http://schemas.microsoft.com/office/drawing/2014/main" id="{3943DD70-9A1C-4C73-B79D-9E01E154E872}"/>
               </a:ext>
             </a:extLst>
           </p:cNvPr>
@@ -15098,7 +15098,7 @@
           <p:cNvPr id="15" name="">
             <a:extLst xmlns:a="http://schemas.openxmlformats.org/drawingml/2006/main">
               <a:ext uri="{FF2B5EF4-FFF2-40B4-BE49-F238E27FC236}">
-                <a16:creationId xmlns:a16="http://schemas.microsoft.com/office/drawing/2014/main" id="{CE8069BA-4F6F-40E3-83D3-5E1CCC8E8789}"/>
+                <a16:creationId xmlns:a16="http://schemas.microsoft.com/office/drawing/2014/main" id="{49230BBE-2188-47AC-AEB9-573B24A817ED}"/>
               </a:ext>
             </a:extLst>
           </p:cNvPr>
@@ -15148,7 +15148,7 @@
           <p:cNvPr id="16" name="">
             <a:extLst xmlns:a="http://schemas.openxmlformats.org/drawingml/2006/main">
               <a:ext uri="{FF2B5EF4-FFF2-40B4-BE49-F238E27FC236}">
-                <a16:creationId xmlns:a16="http://schemas.microsoft.com/office/drawing/2014/main" id="{0E89B6E0-181B-46FF-855E-630B3C943B91}"/>
+                <a16:creationId xmlns:a16="http://schemas.microsoft.com/office/drawing/2014/main" id="{ABE55602-328D-42EC-8349-484C6DFCF4E5}"/>
               </a:ext>
             </a:extLst>
           </p:cNvPr>
@@ -15183,7 +15183,7 @@
           <p:cNvPr id="17" name="">
             <a:extLst xmlns:a="http://schemas.openxmlformats.org/drawingml/2006/main">
               <a:ext uri="{FF2B5EF4-FFF2-40B4-BE49-F238E27FC236}">
-                <a16:creationId xmlns:a16="http://schemas.microsoft.com/office/drawing/2014/main" id="{05A8B717-09D2-42BE-8829-958616D2C137}"/>
+                <a16:creationId xmlns:a16="http://schemas.microsoft.com/office/drawing/2014/main" id="{42C66889-5889-4BD6-9692-20D25EAA3F48}"/>
               </a:ext>
             </a:extLst>
           </p:cNvPr>
@@ -15216,7 +15216,7 @@
           <p:cNvPr id="18" name="">
             <a:extLst xmlns:a="http://schemas.openxmlformats.org/drawingml/2006/main">
               <a:ext uri="{FF2B5EF4-FFF2-40B4-BE49-F238E27FC236}">
-                <a16:creationId xmlns:a16="http://schemas.microsoft.com/office/drawing/2014/main" id="{F2671260-7118-48A8-A5A8-25037D1B8521}"/>
+                <a16:creationId xmlns:a16="http://schemas.microsoft.com/office/drawing/2014/main" id="{E1D209F4-3B09-448E-ABC6-1F921B636219}"/>
               </a:ext>
             </a:extLst>
           </p:cNvPr>
@@ -15266,7 +15266,7 @@
           <p:cNvPr id="19" name="">
             <a:extLst xmlns:a="http://schemas.openxmlformats.org/drawingml/2006/main">
               <a:ext uri="{FF2B5EF4-FFF2-40B4-BE49-F238E27FC236}">
-                <a16:creationId xmlns:a16="http://schemas.microsoft.com/office/drawing/2014/main" id="{697E3500-4115-4D26-93A7-4D3E5DE1F950}"/>
+                <a16:creationId xmlns:a16="http://schemas.microsoft.com/office/drawing/2014/main" id="{C6B96B25-D439-4768-B0F1-FA9026979EC8}"/>
               </a:ext>
             </a:extLst>
           </p:cNvPr>
@@ -15316,7 +15316,7 @@
           <p:cNvPr id="20" name="">
             <a:extLst xmlns:a="http://schemas.openxmlformats.org/drawingml/2006/main">
               <a:ext uri="{FF2B5EF4-FFF2-40B4-BE49-F238E27FC236}">
-                <a16:creationId xmlns:a16="http://schemas.microsoft.com/office/drawing/2014/main" id="{49D01CEA-D3A0-463F-BCC2-9D2B8262B85A}"/>
+                <a16:creationId xmlns:a16="http://schemas.microsoft.com/office/drawing/2014/main" id="{CE0E21A5-8C62-4F3F-A8CB-D7D19A70D581}"/>
               </a:ext>
             </a:extLst>
           </p:cNvPr>
@@ -15366,7 +15366,7 @@
           <p:cNvPr id="21" name="">
             <a:extLst xmlns:a="http://schemas.openxmlformats.org/drawingml/2006/main">
               <a:ext uri="{FF2B5EF4-FFF2-40B4-BE49-F238E27FC236}">
-                <a16:creationId xmlns:a16="http://schemas.microsoft.com/office/drawing/2014/main" id="{74401AC9-1495-4B16-A422-297BC2984478}"/>
+                <a16:creationId xmlns:a16="http://schemas.microsoft.com/office/drawing/2014/main" id="{DDE85BFC-1612-4443-8086-6628AFBDFB4F}"/>
               </a:ext>
             </a:extLst>
           </p:cNvPr>
@@ -15416,7 +15416,7 @@
           <p:cNvPr id="22" name="">
             <a:extLst xmlns:a="http://schemas.openxmlformats.org/drawingml/2006/main">
               <a:ext uri="{FF2B5EF4-FFF2-40B4-BE49-F238E27FC236}">
-                <a16:creationId xmlns:a16="http://schemas.microsoft.com/office/drawing/2014/main" id="{49C9DC8F-9FE1-4887-8FEF-34CE2860ED78}"/>
+                <a16:creationId xmlns:a16="http://schemas.microsoft.com/office/drawing/2014/main" id="{2945B1C0-0BC9-4E19-A223-55497B0685F1}"/>
               </a:ext>
             </a:extLst>
           </p:cNvPr>
@@ -15449,7 +15449,7 @@
           <p:cNvPr id="23" name="">
             <a:extLst xmlns:a="http://schemas.openxmlformats.org/drawingml/2006/main">
               <a:ext uri="{FF2B5EF4-FFF2-40B4-BE49-F238E27FC236}">
-                <a16:creationId xmlns:a16="http://schemas.microsoft.com/office/drawing/2014/main" id="{2AA3499D-007E-4B6C-A02F-C9D738675D1A}"/>
+                <a16:creationId xmlns:a16="http://schemas.microsoft.com/office/drawing/2014/main" id="{29174442-C903-4E4C-8B3C-F62781C2641B}"/>
               </a:ext>
             </a:extLst>
           </p:cNvPr>
@@ -15499,7 +15499,7 @@
           <p:cNvPr id="24" name="">
             <a:extLst xmlns:a="http://schemas.openxmlformats.org/drawingml/2006/main">
               <a:ext uri="{FF2B5EF4-FFF2-40B4-BE49-F238E27FC236}">
-                <a16:creationId xmlns:a16="http://schemas.microsoft.com/office/drawing/2014/main" id="{6406267F-5570-47C8-B42F-27D180B35C19}"/>
+                <a16:creationId xmlns:a16="http://schemas.microsoft.com/office/drawing/2014/main" id="{72825FCB-F0C3-4AED-A60A-3DC2AF43A9A6}"/>
               </a:ext>
             </a:extLst>
           </p:cNvPr>
@@ -15547,7 +15547,7 @@
     </p:spTree>
     <p:extLst>
       <p:ext uri="{BB962C8B-B14F-4D97-AF65-F5344CB8AC3E}">
-        <p14:creationId xmlns:p14="http://schemas.microsoft.com/office/powerpoint/2010/main" val="652850730"/>
+        <p14:creationId xmlns:p14="http://schemas.microsoft.com/office/powerpoint/2010/main" val="151124613"/>
       </p:ext>
     </p:extLst>
   </p:cSld>
@@ -15578,7 +15578,7 @@
           <p:cNvPr id="43" name="">
             <a:extLst xmlns:a="http://schemas.openxmlformats.org/drawingml/2006/main">
               <a:ext uri="{FF2B5EF4-FFF2-40B4-BE49-F238E27FC236}">
-                <a16:creationId xmlns:a16="http://schemas.microsoft.com/office/drawing/2014/main" id="{601A9912-B3C4-498C-BD65-6B35C36E8823}"/>
+                <a16:creationId xmlns:a16="http://schemas.microsoft.com/office/drawing/2014/main" id="{684322A6-D7A5-4693-A8E3-CFD6E24D2CE1}"/>
               </a:ext>
             </a:extLst>
           </p:cNvPr>
@@ -15611,7 +15611,7 @@
           <p:cNvPr id="2" name="">
             <a:extLst xmlns:a="http://schemas.openxmlformats.org/drawingml/2006/main">
               <a:ext uri="{FF2B5EF4-FFF2-40B4-BE49-F238E27FC236}">
-                <a16:creationId xmlns:a16="http://schemas.microsoft.com/office/drawing/2014/main" id="{F9996689-B916-49AB-ADA7-F0B1F3C478D9}"/>
+                <a16:creationId xmlns:a16="http://schemas.microsoft.com/office/drawing/2014/main" id="{A366EE30-BEC1-4152-93C7-356E7D8A989A}"/>
               </a:ext>
             </a:extLst>
           </p:cNvPr>
@@ -15661,7 +15661,7 @@
           <p:cNvPr id="3" name="">
             <a:extLst xmlns:a="http://schemas.openxmlformats.org/drawingml/2006/main">
               <a:ext uri="{FF2B5EF4-FFF2-40B4-BE49-F238E27FC236}">
-                <a16:creationId xmlns:a16="http://schemas.microsoft.com/office/drawing/2014/main" id="{EAC31FCE-55F5-4BF6-A956-6812A8103356}"/>
+                <a16:creationId xmlns:a16="http://schemas.microsoft.com/office/drawing/2014/main" id="{4B1D7434-1FE0-4E99-AF19-792DD7251165}"/>
               </a:ext>
             </a:extLst>
           </p:cNvPr>
@@ -15711,7 +15711,7 @@
           <p:cNvPr id="4" name="">
             <a:extLst xmlns:a="http://schemas.openxmlformats.org/drawingml/2006/main">
               <a:ext uri="{FF2B5EF4-FFF2-40B4-BE49-F238E27FC236}">
-                <a16:creationId xmlns:a16="http://schemas.microsoft.com/office/drawing/2014/main" id="{84702787-E73E-481D-A417-819A43060B14}"/>
+                <a16:creationId xmlns:a16="http://schemas.microsoft.com/office/drawing/2014/main" id="{6AF34211-D443-4E0E-945A-EF1C69973963}"/>
               </a:ext>
             </a:extLst>
           </p:cNvPr>
@@ -15761,7 +15761,7 @@
           <p:cNvPr id="5" name="">
             <a:extLst xmlns:a="http://schemas.openxmlformats.org/drawingml/2006/main">
               <a:ext uri="{FF2B5EF4-FFF2-40B4-BE49-F238E27FC236}">
-                <a16:creationId xmlns:a16="http://schemas.microsoft.com/office/drawing/2014/main" id="{786EDCDA-4338-4F31-A1B9-BD0D5C2E5985}"/>
+                <a16:creationId xmlns:a16="http://schemas.microsoft.com/office/drawing/2014/main" id="{CD5565DE-1362-45BD-9939-7E31CCF9D89F}"/>
               </a:ext>
             </a:extLst>
           </p:cNvPr>
@@ -15811,7 +15811,7 @@
           <p:cNvPr id="6" name="">
             <a:extLst xmlns:a="http://schemas.openxmlformats.org/drawingml/2006/main">
               <a:ext uri="{FF2B5EF4-FFF2-40B4-BE49-F238E27FC236}">
-                <a16:creationId xmlns:a16="http://schemas.microsoft.com/office/drawing/2014/main" id="{699C74E2-9EA2-4726-8FD1-F6C2265C4620}"/>
+                <a16:creationId xmlns:a16="http://schemas.microsoft.com/office/drawing/2014/main" id="{883C293F-C37A-49F1-9391-0B32CE67A356}"/>
               </a:ext>
             </a:extLst>
           </p:cNvPr>
@@ -15844,7 +15844,7 @@
           <p:cNvPr id="7" name="">
             <a:extLst xmlns:a="http://schemas.openxmlformats.org/drawingml/2006/main">
               <a:ext uri="{FF2B5EF4-FFF2-40B4-BE49-F238E27FC236}">
-                <a16:creationId xmlns:a16="http://schemas.microsoft.com/office/drawing/2014/main" id="{57FB99E6-AF4B-46C8-B4F5-7D2CBD479062}"/>
+                <a16:creationId xmlns:a16="http://schemas.microsoft.com/office/drawing/2014/main" id="{6C6ADD0C-D9B8-4231-B622-CD5BC4049CDB}"/>
               </a:ext>
             </a:extLst>
           </p:cNvPr>
@@ -15879,7 +15879,7 @@
           <p:cNvPr id="8" name="">
             <a:extLst xmlns:a="http://schemas.openxmlformats.org/drawingml/2006/main">
               <a:ext uri="{FF2B5EF4-FFF2-40B4-BE49-F238E27FC236}">
-                <a16:creationId xmlns:a16="http://schemas.microsoft.com/office/drawing/2014/main" id="{DD0831B9-5CFD-4C14-A604-48BEB660F41A}"/>
+                <a16:creationId xmlns:a16="http://schemas.microsoft.com/office/drawing/2014/main" id="{969CFCB9-CDC9-4832-BFCB-B0C5F88DA46E}"/>
               </a:ext>
             </a:extLst>
           </p:cNvPr>
@@ -15912,7 +15912,7 @@
           <p:cNvPr id="9" name="">
             <a:extLst xmlns:a="http://schemas.openxmlformats.org/drawingml/2006/main">
               <a:ext uri="{FF2B5EF4-FFF2-40B4-BE49-F238E27FC236}">
-                <a16:creationId xmlns:a16="http://schemas.microsoft.com/office/drawing/2014/main" id="{CDEFBCE7-E9BC-464E-B697-EBF93A74340F}"/>
+                <a16:creationId xmlns:a16="http://schemas.microsoft.com/office/drawing/2014/main" id="{9540A7CB-CE51-4A6D-B062-96F63B00DA17}"/>
               </a:ext>
             </a:extLst>
           </p:cNvPr>
@@ -15962,7 +15962,7 @@
           <p:cNvPr id="10" name="">
             <a:extLst xmlns:a="http://schemas.openxmlformats.org/drawingml/2006/main">
               <a:ext uri="{FF2B5EF4-FFF2-40B4-BE49-F238E27FC236}">
-                <a16:creationId xmlns:a16="http://schemas.microsoft.com/office/drawing/2014/main" id="{6F207B9B-5243-43AB-8895-7E67C230A53C}"/>
+                <a16:creationId xmlns:a16="http://schemas.microsoft.com/office/drawing/2014/main" id="{6ECBC354-F7B5-4DFD-8793-9FDF4BB3110A}"/>
               </a:ext>
             </a:extLst>
           </p:cNvPr>
@@ -16012,7 +16012,7 @@
           <p:cNvPr id="11" name="">
             <a:extLst xmlns:a="http://schemas.openxmlformats.org/drawingml/2006/main">
               <a:ext uri="{FF2B5EF4-FFF2-40B4-BE49-F238E27FC236}">
-                <a16:creationId xmlns:a16="http://schemas.microsoft.com/office/drawing/2014/main" id="{7950F4D5-1228-42AB-8BEF-C639E486ECF1}"/>
+                <a16:creationId xmlns:a16="http://schemas.microsoft.com/office/drawing/2014/main" id="{3A094A99-F28B-436B-B469-A47E71D52E64}"/>
               </a:ext>
             </a:extLst>
           </p:cNvPr>
@@ -16062,7 +16062,7 @@
           <p:cNvPr id="12" name="">
             <a:extLst xmlns:a="http://schemas.openxmlformats.org/drawingml/2006/main">
               <a:ext uri="{FF2B5EF4-FFF2-40B4-BE49-F238E27FC236}">
-                <a16:creationId xmlns:a16="http://schemas.microsoft.com/office/drawing/2014/main" id="{C7D3D840-620D-4948-81E6-5C877E148EAD}"/>
+                <a16:creationId xmlns:a16="http://schemas.microsoft.com/office/drawing/2014/main" id="{4B8508E1-6EFE-4CC8-834F-CA2E8AA9154B}"/>
               </a:ext>
             </a:extLst>
           </p:cNvPr>
@@ -16112,7 +16112,7 @@
           <p:cNvPr id="13" name="">
             <a:extLst xmlns:a="http://schemas.openxmlformats.org/drawingml/2006/main">
               <a:ext uri="{FF2B5EF4-FFF2-40B4-BE49-F238E27FC236}">
-                <a16:creationId xmlns:a16="http://schemas.microsoft.com/office/drawing/2014/main" id="{3F027925-6459-4137-95C2-B584FFDD3D78}"/>
+                <a16:creationId xmlns:a16="http://schemas.microsoft.com/office/drawing/2014/main" id="{D0DCD83B-61F6-4E7C-9D85-30AA0AD54DF3}"/>
               </a:ext>
             </a:extLst>
           </p:cNvPr>
@@ -16145,7 +16145,7 @@
           <p:cNvPr id="14" name="">
             <a:extLst xmlns:a="http://schemas.openxmlformats.org/drawingml/2006/main">
               <a:ext uri="{FF2B5EF4-FFF2-40B4-BE49-F238E27FC236}">
-                <a16:creationId xmlns:a16="http://schemas.microsoft.com/office/drawing/2014/main" id="{5C840F78-6752-4226-AAE7-C6DDA578BD4A}"/>
+                <a16:creationId xmlns:a16="http://schemas.microsoft.com/office/drawing/2014/main" id="{EA0E0B02-7CC8-487D-9CE3-77AE945DC145}"/>
               </a:ext>
             </a:extLst>
           </p:cNvPr>
@@ -16195,7 +16195,7 @@
           <p:cNvPr id="15" name="">
             <a:extLst xmlns:a="http://schemas.openxmlformats.org/drawingml/2006/main">
               <a:ext uri="{FF2B5EF4-FFF2-40B4-BE49-F238E27FC236}">
-                <a16:creationId xmlns:a16="http://schemas.microsoft.com/office/drawing/2014/main" id="{2051DB5B-1781-472B-86BF-EF92D3C1FCDA}"/>
+                <a16:creationId xmlns:a16="http://schemas.microsoft.com/office/drawing/2014/main" id="{24B3D718-87A0-4EC7-9259-ED8BF2571304}"/>
               </a:ext>
             </a:extLst>
           </p:cNvPr>
@@ -16245,7 +16245,7 @@
           <p:cNvPr id="16" name="">
             <a:extLst xmlns:a="http://schemas.openxmlformats.org/drawingml/2006/main">
               <a:ext uri="{FF2B5EF4-FFF2-40B4-BE49-F238E27FC236}">
-                <a16:creationId xmlns:a16="http://schemas.microsoft.com/office/drawing/2014/main" id="{E6E554FD-CCA6-4368-B935-1BD5CCD83F22}"/>
+                <a16:creationId xmlns:a16="http://schemas.microsoft.com/office/drawing/2014/main" id="{90FDB9E4-07EA-49E1-9D56-7B5045C7FBFF}"/>
               </a:ext>
             </a:extLst>
           </p:cNvPr>
@@ -16280,7 +16280,7 @@
           <p:cNvPr id="17" name="">
             <a:extLst xmlns:a="http://schemas.openxmlformats.org/drawingml/2006/main">
               <a:ext uri="{FF2B5EF4-FFF2-40B4-BE49-F238E27FC236}">
-                <a16:creationId xmlns:a16="http://schemas.microsoft.com/office/drawing/2014/main" id="{3AEAFC72-F0C6-4A0C-8B9F-D72E86C07A8B}"/>
+                <a16:creationId xmlns:a16="http://schemas.microsoft.com/office/drawing/2014/main" id="{55305DDE-A281-4DBC-B149-78294B6F085C}"/>
               </a:ext>
             </a:extLst>
           </p:cNvPr>
@@ -16313,7 +16313,7 @@
           <p:cNvPr id="18" name="">
             <a:extLst xmlns:a="http://schemas.openxmlformats.org/drawingml/2006/main">
               <a:ext uri="{FF2B5EF4-FFF2-40B4-BE49-F238E27FC236}">
-                <a16:creationId xmlns:a16="http://schemas.microsoft.com/office/drawing/2014/main" id="{269CADAE-D7BA-4D4E-BEFB-F2A311092B83}"/>
+                <a16:creationId xmlns:a16="http://schemas.microsoft.com/office/drawing/2014/main" id="{FFC07CA3-0910-4655-BDB8-13BC55AB618B}"/>
               </a:ext>
             </a:extLst>
           </p:cNvPr>
@@ -16363,7 +16363,7 @@
           <p:cNvPr id="19" name="">
             <a:extLst xmlns:a="http://schemas.openxmlformats.org/drawingml/2006/main">
               <a:ext uri="{FF2B5EF4-FFF2-40B4-BE49-F238E27FC236}">
-                <a16:creationId xmlns:a16="http://schemas.microsoft.com/office/drawing/2014/main" id="{1459A459-D6F4-48BD-A57C-4F032FB4D7B3}"/>
+                <a16:creationId xmlns:a16="http://schemas.microsoft.com/office/drawing/2014/main" id="{AF66E2C2-B2BB-4A08-821D-E97C9CC636B1}"/>
               </a:ext>
             </a:extLst>
           </p:cNvPr>
@@ -16413,7 +16413,7 @@
           <p:cNvPr id="20" name="">
             <a:extLst xmlns:a="http://schemas.openxmlformats.org/drawingml/2006/main">
               <a:ext uri="{FF2B5EF4-FFF2-40B4-BE49-F238E27FC236}">
-                <a16:creationId xmlns:a16="http://schemas.microsoft.com/office/drawing/2014/main" id="{3C3E7538-D08C-46B0-BF04-6B18B85311A6}"/>
+                <a16:creationId xmlns:a16="http://schemas.microsoft.com/office/drawing/2014/main" id="{2F2EDCD6-088C-4FDD-8247-29D2979C15D3}"/>
               </a:ext>
             </a:extLst>
           </p:cNvPr>
@@ -16463,7 +16463,7 @@
           <p:cNvPr id="21" name="">
             <a:extLst xmlns:a="http://schemas.openxmlformats.org/drawingml/2006/main">
               <a:ext uri="{FF2B5EF4-FFF2-40B4-BE49-F238E27FC236}">
-                <a16:creationId xmlns:a16="http://schemas.microsoft.com/office/drawing/2014/main" id="{90D96775-D484-45BB-ACFD-E6FCDE639803}"/>
+                <a16:creationId xmlns:a16="http://schemas.microsoft.com/office/drawing/2014/main" id="{4448872E-A9BF-4B94-B144-CE230A108D85}"/>
               </a:ext>
             </a:extLst>
           </p:cNvPr>
@@ -16513,7 +16513,7 @@
           <p:cNvPr id="22" name="">
             <a:extLst xmlns:a="http://schemas.openxmlformats.org/drawingml/2006/main">
               <a:ext uri="{FF2B5EF4-FFF2-40B4-BE49-F238E27FC236}">
-                <a16:creationId xmlns:a16="http://schemas.microsoft.com/office/drawing/2014/main" id="{FEC07C4A-B3F3-4C4D-92CE-0A56AC155494}"/>
+                <a16:creationId xmlns:a16="http://schemas.microsoft.com/office/drawing/2014/main" id="{9E72519D-5393-47CC-A004-6CEACAA4753F}"/>
               </a:ext>
             </a:extLst>
           </p:cNvPr>
@@ -16548,7 +16548,7 @@
           <p:cNvPr id="23" name="">
             <a:extLst xmlns:a="http://schemas.openxmlformats.org/drawingml/2006/main">
               <a:ext uri="{FF2B5EF4-FFF2-40B4-BE49-F238E27FC236}">
-                <a16:creationId xmlns:a16="http://schemas.microsoft.com/office/drawing/2014/main" id="{95E39000-F689-471E-9711-91DDC32F9C58}"/>
+                <a16:creationId xmlns:a16="http://schemas.microsoft.com/office/drawing/2014/main" id="{83BC4ABF-08F7-4F42-B16E-B3EECDF4801E}"/>
               </a:ext>
             </a:extLst>
           </p:cNvPr>
@@ -16581,7 +16581,7 @@
           <p:cNvPr id="24" name="">
             <a:extLst xmlns:a="http://schemas.openxmlformats.org/drawingml/2006/main">
               <a:ext uri="{FF2B5EF4-FFF2-40B4-BE49-F238E27FC236}">
-                <a16:creationId xmlns:a16="http://schemas.microsoft.com/office/drawing/2014/main" id="{C29120D4-7925-4788-AEA9-E99155705C4B}"/>
+                <a16:creationId xmlns:a16="http://schemas.microsoft.com/office/drawing/2014/main" id="{9B12737C-DD30-484A-9CE5-98949672E16C}"/>
               </a:ext>
             </a:extLst>
           </p:cNvPr>
@@ -16631,7 +16631,7 @@
           <p:cNvPr id="25" name="">
             <a:extLst xmlns:a="http://schemas.openxmlformats.org/drawingml/2006/main">
               <a:ext uri="{FF2B5EF4-FFF2-40B4-BE49-F238E27FC236}">
-                <a16:creationId xmlns:a16="http://schemas.microsoft.com/office/drawing/2014/main" id="{15A22781-A6CC-4152-B4E8-D6781D14E810}"/>
+                <a16:creationId xmlns:a16="http://schemas.microsoft.com/office/drawing/2014/main" id="{7D77B758-3D3E-4F42-B820-844FC9880F7E}"/>
               </a:ext>
             </a:extLst>
           </p:cNvPr>
@@ -16681,7 +16681,7 @@
           <p:cNvPr id="26" name="">
             <a:extLst xmlns:a="http://schemas.openxmlformats.org/drawingml/2006/main">
               <a:ext uri="{FF2B5EF4-FFF2-40B4-BE49-F238E27FC236}">
-                <a16:creationId xmlns:a16="http://schemas.microsoft.com/office/drawing/2014/main" id="{2E873CBB-E344-4ED0-A3AA-492D6E7E08E8}"/>
+                <a16:creationId xmlns:a16="http://schemas.microsoft.com/office/drawing/2014/main" id="{2F5855E4-E884-4765-A9C6-F52833DB0093}"/>
               </a:ext>
             </a:extLst>
           </p:cNvPr>
@@ -16731,7 +16731,7 @@
           <p:cNvPr id="27" name="">
             <a:extLst xmlns:a="http://schemas.openxmlformats.org/drawingml/2006/main">
               <a:ext uri="{FF2B5EF4-FFF2-40B4-BE49-F238E27FC236}">
-                <a16:creationId xmlns:a16="http://schemas.microsoft.com/office/drawing/2014/main" id="{D468B613-4674-476A-B47D-AC27F8082876}"/>
+                <a16:creationId xmlns:a16="http://schemas.microsoft.com/office/drawing/2014/main" id="{9DC0D35C-C6B3-4C4A-AC27-852BB7C21906}"/>
               </a:ext>
             </a:extLst>
           </p:cNvPr>
@@ -16781,7 +16781,7 @@
           <p:cNvPr id="28" name="">
             <a:extLst xmlns:a="http://schemas.openxmlformats.org/drawingml/2006/main">
               <a:ext uri="{FF2B5EF4-FFF2-40B4-BE49-F238E27FC236}">
-                <a16:creationId xmlns:a16="http://schemas.microsoft.com/office/drawing/2014/main" id="{9A31070D-6E72-4696-8D17-6D4E1738E3A7}"/>
+                <a16:creationId xmlns:a16="http://schemas.microsoft.com/office/drawing/2014/main" id="{394627F2-C2EE-4BD8-99E2-382978005935}"/>
               </a:ext>
             </a:extLst>
           </p:cNvPr>
@@ -16814,7 +16814,7 @@
           <p:cNvPr id="29" name="">
             <a:extLst xmlns:a="http://schemas.openxmlformats.org/drawingml/2006/main">
               <a:ext uri="{FF2B5EF4-FFF2-40B4-BE49-F238E27FC236}">
-                <a16:creationId xmlns:a16="http://schemas.microsoft.com/office/drawing/2014/main" id="{7130AA6B-80DB-4493-AF6E-C6B37D7BDC5E}"/>
+                <a16:creationId xmlns:a16="http://schemas.microsoft.com/office/drawing/2014/main" id="{7362C640-A2DA-443F-AF4A-DF704EFE829A}"/>
               </a:ext>
             </a:extLst>
           </p:cNvPr>
@@ -16864,7 +16864,7 @@
           <p:cNvPr id="30" name="">
             <a:extLst xmlns:a="http://schemas.openxmlformats.org/drawingml/2006/main">
               <a:ext uri="{FF2B5EF4-FFF2-40B4-BE49-F238E27FC236}">
-                <a16:creationId xmlns:a16="http://schemas.microsoft.com/office/drawing/2014/main" id="{E8E16E81-57F8-4E64-851B-B28834E38C8C}"/>
+                <a16:creationId xmlns:a16="http://schemas.microsoft.com/office/drawing/2014/main" id="{78E8ABF6-FA76-420B-841B-C35474C0E232}"/>
               </a:ext>
             </a:extLst>
           </p:cNvPr>
@@ -16914,7 +16914,7 @@
           <p:cNvPr id="31" name="">
             <a:extLst xmlns:a="http://schemas.openxmlformats.org/drawingml/2006/main">
               <a:ext uri="{FF2B5EF4-FFF2-40B4-BE49-F238E27FC236}">
-                <a16:creationId xmlns:a16="http://schemas.microsoft.com/office/drawing/2014/main" id="{993AFCCC-48A6-4200-890E-3276C76877AB}"/>
+                <a16:creationId xmlns:a16="http://schemas.microsoft.com/office/drawing/2014/main" id="{8CB200E8-87CE-4AF4-AB88-1B7874D658AE}"/>
               </a:ext>
             </a:extLst>
           </p:cNvPr>
@@ -16949,7 +16949,7 @@
           <p:cNvPr id="32" name="">
             <a:extLst xmlns:a="http://schemas.openxmlformats.org/drawingml/2006/main">
               <a:ext uri="{FF2B5EF4-FFF2-40B4-BE49-F238E27FC236}">
-                <a16:creationId xmlns:a16="http://schemas.microsoft.com/office/drawing/2014/main" id="{2D355297-FFBC-4C8C-8BA1-2D93CD3D0D53}"/>
+                <a16:creationId xmlns:a16="http://schemas.microsoft.com/office/drawing/2014/main" id="{6239A5A9-8F46-47D9-BD44-5F3B03C0511C}"/>
               </a:ext>
             </a:extLst>
           </p:cNvPr>
@@ -16982,7 +16982,7 @@
           <p:cNvPr id="33" name="">
             <a:extLst xmlns:a="http://schemas.openxmlformats.org/drawingml/2006/main">
               <a:ext uri="{FF2B5EF4-FFF2-40B4-BE49-F238E27FC236}">
-                <a16:creationId xmlns:a16="http://schemas.microsoft.com/office/drawing/2014/main" id="{8FAF4F7A-D67D-449E-B38F-83A0B0CFBFC4}"/>
+                <a16:creationId xmlns:a16="http://schemas.microsoft.com/office/drawing/2014/main" id="{5A03A819-432D-48FE-885C-3A2E486E3091}"/>
               </a:ext>
             </a:extLst>
           </p:cNvPr>
@@ -17032,7 +17032,7 @@
           <p:cNvPr id="34" name="">
             <a:extLst xmlns:a="http://schemas.openxmlformats.org/drawingml/2006/main">
               <a:ext uri="{FF2B5EF4-FFF2-40B4-BE49-F238E27FC236}">
-                <a16:creationId xmlns:a16="http://schemas.microsoft.com/office/drawing/2014/main" id="{8B3502FE-F736-4E30-AE6D-1201C81EEC07}"/>
+                <a16:creationId xmlns:a16="http://schemas.microsoft.com/office/drawing/2014/main" id="{4362AC99-0853-442E-8EE0-548E31C56A06}"/>
               </a:ext>
             </a:extLst>
           </p:cNvPr>
@@ -17082,7 +17082,7 @@
           <p:cNvPr id="35" name="">
             <a:extLst xmlns:a="http://schemas.openxmlformats.org/drawingml/2006/main">
               <a:ext uri="{FF2B5EF4-FFF2-40B4-BE49-F238E27FC236}">
-                <a16:creationId xmlns:a16="http://schemas.microsoft.com/office/drawing/2014/main" id="{91691797-DEF1-42B9-B732-FBBB1739B32D}"/>
+                <a16:creationId xmlns:a16="http://schemas.microsoft.com/office/drawing/2014/main" id="{B7228CA7-A9BB-4FDB-B80A-DD1B54FABDF1}"/>
               </a:ext>
             </a:extLst>
           </p:cNvPr>
@@ -17132,7 +17132,7 @@
           <p:cNvPr id="36" name="">
             <a:extLst xmlns:a="http://schemas.openxmlformats.org/drawingml/2006/main">
               <a:ext uri="{FF2B5EF4-FFF2-40B4-BE49-F238E27FC236}">
-                <a16:creationId xmlns:a16="http://schemas.microsoft.com/office/drawing/2014/main" id="{88ED3015-532E-44D2-A810-C818EE311D7B}"/>
+                <a16:creationId xmlns:a16="http://schemas.microsoft.com/office/drawing/2014/main" id="{06C53C51-CE5A-42B9-B212-DE74DEDED884}"/>
               </a:ext>
             </a:extLst>
           </p:cNvPr>
@@ -17182,7 +17182,7 @@
           <p:cNvPr id="37" name="">
             <a:extLst xmlns:a="http://schemas.openxmlformats.org/drawingml/2006/main">
               <a:ext uri="{FF2B5EF4-FFF2-40B4-BE49-F238E27FC236}">
-                <a16:creationId xmlns:a16="http://schemas.microsoft.com/office/drawing/2014/main" id="{A34842EB-3F03-4979-807F-D7D56EDF5BF2}"/>
+                <a16:creationId xmlns:a16="http://schemas.microsoft.com/office/drawing/2014/main" id="{A3103E8D-E169-4910-AB05-17613ADDA2B0}"/>
               </a:ext>
             </a:extLst>
           </p:cNvPr>
@@ -17215,7 +17215,7 @@
           <p:cNvPr id="38" name="">
             <a:extLst xmlns:a="http://schemas.openxmlformats.org/drawingml/2006/main">
               <a:ext uri="{FF2B5EF4-FFF2-40B4-BE49-F238E27FC236}">
-                <a16:creationId xmlns:a16="http://schemas.microsoft.com/office/drawing/2014/main" id="{D4CF08CF-6260-47A1-AC11-86C954C432A7}"/>
+                <a16:creationId xmlns:a16="http://schemas.microsoft.com/office/drawing/2014/main" id="{432C482E-ECEF-452C-8E79-E70F70B56691}"/>
               </a:ext>
             </a:extLst>
           </p:cNvPr>
@@ -17265,7 +17265,7 @@
           <p:cNvPr id="39" name="">
             <a:extLst xmlns:a="http://schemas.openxmlformats.org/drawingml/2006/main">
               <a:ext uri="{FF2B5EF4-FFF2-40B4-BE49-F238E27FC236}">
-                <a16:creationId xmlns:a16="http://schemas.microsoft.com/office/drawing/2014/main" id="{72A4F051-5A34-4876-B9CA-5F9453D9E8EE}"/>
+                <a16:creationId xmlns:a16="http://schemas.microsoft.com/office/drawing/2014/main" id="{5E6532F3-7E78-4E1A-ADB7-0D396D6473A2}"/>
               </a:ext>
             </a:extLst>
           </p:cNvPr>
@@ -17315,7 +17315,7 @@
           <p:cNvPr id="40" name="">
             <a:extLst xmlns:a="http://schemas.openxmlformats.org/drawingml/2006/main">
               <a:ext uri="{FF2B5EF4-FFF2-40B4-BE49-F238E27FC236}">
-                <a16:creationId xmlns:a16="http://schemas.microsoft.com/office/drawing/2014/main" id="{3BA7177A-D63D-402C-B141-F3EC43B0F99C}"/>
+                <a16:creationId xmlns:a16="http://schemas.microsoft.com/office/drawing/2014/main" id="{677B1D5B-96C4-4D25-B43C-F857574C0885}"/>
               </a:ext>
             </a:extLst>
           </p:cNvPr>
@@ -17348,7 +17348,7 @@
           <p:cNvPr id="41" name="">
             <a:extLst xmlns:a="http://schemas.openxmlformats.org/drawingml/2006/main">
               <a:ext uri="{FF2B5EF4-FFF2-40B4-BE49-F238E27FC236}">
-                <a16:creationId xmlns:a16="http://schemas.microsoft.com/office/drawing/2014/main" id="{7B0A9BF6-9D89-4B3E-8140-25C8843EA540}"/>
+                <a16:creationId xmlns:a16="http://schemas.microsoft.com/office/drawing/2014/main" id="{4A8C29BE-7C6B-4E58-93E1-187E7B08586A}"/>
               </a:ext>
             </a:extLst>
           </p:cNvPr>
@@ -17398,7 +17398,7 @@
           <p:cNvPr id="42" name="">
             <a:extLst xmlns:a="http://schemas.openxmlformats.org/drawingml/2006/main">
               <a:ext uri="{FF2B5EF4-FFF2-40B4-BE49-F238E27FC236}">
-                <a16:creationId xmlns:a16="http://schemas.microsoft.com/office/drawing/2014/main" id="{A1426B72-D048-4AC2-84F1-EBDAC555F4D0}"/>
+                <a16:creationId xmlns:a16="http://schemas.microsoft.com/office/drawing/2014/main" id="{2EC99A31-0B06-47C7-8228-A277A4DCF9EE}"/>
               </a:ext>
             </a:extLst>
           </p:cNvPr>
@@ -17446,7 +17446,7 @@
     </p:spTree>
     <p:extLst>
       <p:ext uri="{BB962C8B-B14F-4D97-AF65-F5344CB8AC3E}">
-        <p14:creationId xmlns:p14="http://schemas.microsoft.com/office/powerpoint/2010/main" val="1633187039"/>
+        <p14:creationId xmlns:p14="http://schemas.microsoft.com/office/powerpoint/2010/main" val="188201004"/>
       </p:ext>
     </p:extLst>
   </p:cSld>
@@ -17477,7 +17477,7 @@
           <p:cNvPr id="37" name="">
             <a:extLst xmlns:a="http://schemas.openxmlformats.org/drawingml/2006/main">
               <a:ext uri="{FF2B5EF4-FFF2-40B4-BE49-F238E27FC236}">
-                <a16:creationId xmlns:a16="http://schemas.microsoft.com/office/drawing/2014/main" id="{EFCF52C8-78FF-4B76-A0A4-076FF4601DE5}"/>
+                <a16:creationId xmlns:a16="http://schemas.microsoft.com/office/drawing/2014/main" id="{66DC610A-C06E-4138-9176-5737B2028F28}"/>
               </a:ext>
             </a:extLst>
           </p:cNvPr>
@@ -17510,7 +17510,7 @@
           <p:cNvPr id="2" name="">
             <a:extLst xmlns:a="http://schemas.openxmlformats.org/drawingml/2006/main">
               <a:ext uri="{FF2B5EF4-FFF2-40B4-BE49-F238E27FC236}">
-                <a16:creationId xmlns:a16="http://schemas.microsoft.com/office/drawing/2014/main" id="{1FAB3865-72FF-4C28-83FF-2B6D7C69C303}"/>
+                <a16:creationId xmlns:a16="http://schemas.microsoft.com/office/drawing/2014/main" id="{97330966-E86E-4C14-A72C-B31A4A4ACA1A}"/>
               </a:ext>
             </a:extLst>
           </p:cNvPr>
@@ -17560,7 +17560,7 @@
           <p:cNvPr id="3" name="">
             <a:extLst xmlns:a="http://schemas.openxmlformats.org/drawingml/2006/main">
               <a:ext uri="{FF2B5EF4-FFF2-40B4-BE49-F238E27FC236}">
-                <a16:creationId xmlns:a16="http://schemas.microsoft.com/office/drawing/2014/main" id="{5BF9387D-1C49-45E1-9BBB-48969A995787}"/>
+                <a16:creationId xmlns:a16="http://schemas.microsoft.com/office/drawing/2014/main" id="{2C5A6D6C-6965-4E5D-9F96-5AD15FF6FB5E}"/>
               </a:ext>
             </a:extLst>
           </p:cNvPr>
@@ -17610,7 +17610,7 @@
           <p:cNvPr id="4" name="">
             <a:extLst xmlns:a="http://schemas.openxmlformats.org/drawingml/2006/main">
               <a:ext uri="{FF2B5EF4-FFF2-40B4-BE49-F238E27FC236}">
-                <a16:creationId xmlns:a16="http://schemas.microsoft.com/office/drawing/2014/main" id="{2A41BD34-E453-4213-BC4E-9DC3E7A6D634}"/>
+                <a16:creationId xmlns:a16="http://schemas.microsoft.com/office/drawing/2014/main" id="{2653EB70-9396-41B0-B647-CDA81F5DDE64}"/>
               </a:ext>
             </a:extLst>
           </p:cNvPr>
@@ -17660,7 +17660,7 @@
           <p:cNvPr id="5" name="">
             <a:extLst xmlns:a="http://schemas.openxmlformats.org/drawingml/2006/main">
               <a:ext uri="{FF2B5EF4-FFF2-40B4-BE49-F238E27FC236}">
-                <a16:creationId xmlns:a16="http://schemas.microsoft.com/office/drawing/2014/main" id="{23A67876-930A-41DB-9A4F-7D820FC586A7}"/>
+                <a16:creationId xmlns:a16="http://schemas.microsoft.com/office/drawing/2014/main" id="{CFF82FC9-4D88-4377-8136-AE29D25AE8AF}"/>
               </a:ext>
             </a:extLst>
           </p:cNvPr>
@@ -17710,7 +17710,7 @@
           <p:cNvPr id="6" name="">
             <a:extLst xmlns:a="http://schemas.openxmlformats.org/drawingml/2006/main">
               <a:ext uri="{FF2B5EF4-FFF2-40B4-BE49-F238E27FC236}">
-                <a16:creationId xmlns:a16="http://schemas.microsoft.com/office/drawing/2014/main" id="{1EC634FA-8E57-4F4E-9F44-97E7DA855DAC}"/>
+                <a16:creationId xmlns:a16="http://schemas.microsoft.com/office/drawing/2014/main" id="{D72E3013-F1DA-499B-A353-6BDBE8CBFBE3}"/>
               </a:ext>
             </a:extLst>
           </p:cNvPr>
@@ -17743,7 +17743,7 @@
           <p:cNvPr id="7" name="">
             <a:extLst xmlns:a="http://schemas.openxmlformats.org/drawingml/2006/main">
               <a:ext uri="{FF2B5EF4-FFF2-40B4-BE49-F238E27FC236}">
-                <a16:creationId xmlns:a16="http://schemas.microsoft.com/office/drawing/2014/main" id="{46190CF2-6153-43F7-936D-FC5C7900FD4D}"/>
+                <a16:creationId xmlns:a16="http://schemas.microsoft.com/office/drawing/2014/main" id="{565448AE-C21A-4E86-8E29-B59B907772B7}"/>
               </a:ext>
             </a:extLst>
           </p:cNvPr>
@@ -17778,7 +17778,7 @@
           <p:cNvPr id="8" name="">
             <a:extLst xmlns:a="http://schemas.openxmlformats.org/drawingml/2006/main">
               <a:ext uri="{FF2B5EF4-FFF2-40B4-BE49-F238E27FC236}">
-                <a16:creationId xmlns:a16="http://schemas.microsoft.com/office/drawing/2014/main" id="{78E2E20A-DDDB-4A24-AA9E-04D1848AC45C}"/>
+                <a16:creationId xmlns:a16="http://schemas.microsoft.com/office/drawing/2014/main" id="{D054EBE2-F338-4845-BD25-4321B815B14B}"/>
               </a:ext>
             </a:extLst>
           </p:cNvPr>
@@ -17811,7 +17811,7 @@
           <p:cNvPr id="9" name="">
             <a:extLst xmlns:a="http://schemas.openxmlformats.org/drawingml/2006/main">
               <a:ext uri="{FF2B5EF4-FFF2-40B4-BE49-F238E27FC236}">
-                <a16:creationId xmlns:a16="http://schemas.microsoft.com/office/drawing/2014/main" id="{A06244D1-1A26-47DC-A267-0CB5078AA0E3}"/>
+                <a16:creationId xmlns:a16="http://schemas.microsoft.com/office/drawing/2014/main" id="{13E9080C-C230-4838-82FF-AA5DB3790D62}"/>
               </a:ext>
             </a:extLst>
           </p:cNvPr>
@@ -17861,7 +17861,7 @@
           <p:cNvPr id="10" name="">
             <a:extLst xmlns:a="http://schemas.openxmlformats.org/drawingml/2006/main">
               <a:ext uri="{FF2B5EF4-FFF2-40B4-BE49-F238E27FC236}">
-                <a16:creationId xmlns:a16="http://schemas.microsoft.com/office/drawing/2014/main" id="{BF783DF4-FD4F-4EE2-802D-5D008D4A9364}"/>
+                <a16:creationId xmlns:a16="http://schemas.microsoft.com/office/drawing/2014/main" id="{786255E7-B6FF-475A-B342-E333576C1875}"/>
               </a:ext>
             </a:extLst>
           </p:cNvPr>
@@ -17911,7 +17911,7 @@
           <p:cNvPr id="11" name="">
             <a:extLst xmlns:a="http://schemas.openxmlformats.org/drawingml/2006/main">
               <a:ext uri="{FF2B5EF4-FFF2-40B4-BE49-F238E27FC236}">
-                <a16:creationId xmlns:a16="http://schemas.microsoft.com/office/drawing/2014/main" id="{53047BA0-8B12-4AD1-9066-08E6CA6A7022}"/>
+                <a16:creationId xmlns:a16="http://schemas.microsoft.com/office/drawing/2014/main" id="{44824CE5-8530-4425-B44D-A923B527F8AE}"/>
               </a:ext>
             </a:extLst>
           </p:cNvPr>
@@ -17961,7 +17961,7 @@
           <p:cNvPr id="12" name="">
             <a:extLst xmlns:a="http://schemas.openxmlformats.org/drawingml/2006/main">
               <a:ext uri="{FF2B5EF4-FFF2-40B4-BE49-F238E27FC236}">
-                <a16:creationId xmlns:a16="http://schemas.microsoft.com/office/drawing/2014/main" id="{945995C6-9ACA-4B8B-943E-C5C39475E2F6}"/>
+                <a16:creationId xmlns:a16="http://schemas.microsoft.com/office/drawing/2014/main" id="{A065DF34-C2C1-4B11-8F75-D539306E6806}"/>
               </a:ext>
             </a:extLst>
           </p:cNvPr>
@@ -18011,7 +18011,7 @@
           <p:cNvPr id="13" name="">
             <a:extLst xmlns:a="http://schemas.openxmlformats.org/drawingml/2006/main">
               <a:ext uri="{FF2B5EF4-FFF2-40B4-BE49-F238E27FC236}">
-                <a16:creationId xmlns:a16="http://schemas.microsoft.com/office/drawing/2014/main" id="{FE85F4F3-0F93-4D56-BBF3-E1F445E3A252}"/>
+                <a16:creationId xmlns:a16="http://schemas.microsoft.com/office/drawing/2014/main" id="{42747B7C-0879-42C5-ADC2-577BBF5D55B4}"/>
               </a:ext>
             </a:extLst>
           </p:cNvPr>
@@ -18044,7 +18044,7 @@
           <p:cNvPr id="14" name="">
             <a:extLst xmlns:a="http://schemas.openxmlformats.org/drawingml/2006/main">
               <a:ext uri="{FF2B5EF4-FFF2-40B4-BE49-F238E27FC236}">
-                <a16:creationId xmlns:a16="http://schemas.microsoft.com/office/drawing/2014/main" id="{38401E69-EEE3-47A0-A8E9-247F373033F1}"/>
+                <a16:creationId xmlns:a16="http://schemas.microsoft.com/office/drawing/2014/main" id="{26407FD9-AD80-43D5-8C2C-5D3C676342A8}"/>
               </a:ext>
             </a:extLst>
           </p:cNvPr>
@@ -18094,7 +18094,7 @@
           <p:cNvPr id="15" name="">
             <a:extLst xmlns:a="http://schemas.openxmlformats.org/drawingml/2006/main">
               <a:ext uri="{FF2B5EF4-FFF2-40B4-BE49-F238E27FC236}">
-                <a16:creationId xmlns:a16="http://schemas.microsoft.com/office/drawing/2014/main" id="{A0352935-00D1-4849-A6A9-119C863950F0}"/>
+                <a16:creationId xmlns:a16="http://schemas.microsoft.com/office/drawing/2014/main" id="{2A423FDC-A79F-41D9-BF37-FCECB3E48F06}"/>
               </a:ext>
             </a:extLst>
           </p:cNvPr>
@@ -18144,7 +18144,7 @@
           <p:cNvPr id="16" name="">
             <a:extLst xmlns:a="http://schemas.openxmlformats.org/drawingml/2006/main">
               <a:ext uri="{FF2B5EF4-FFF2-40B4-BE49-F238E27FC236}">
-                <a16:creationId xmlns:a16="http://schemas.microsoft.com/office/drawing/2014/main" id="{3A3C37A8-93E7-401F-9AC1-D3BE21046A65}"/>
+                <a16:creationId xmlns:a16="http://schemas.microsoft.com/office/drawing/2014/main" id="{A0AFF69E-042C-4867-B4A0-1A26F89C3537}"/>
               </a:ext>
             </a:extLst>
           </p:cNvPr>
@@ -18179,7 +18179,7 @@
           <p:cNvPr id="17" name="">
             <a:extLst xmlns:a="http://schemas.openxmlformats.org/drawingml/2006/main">
               <a:ext uri="{FF2B5EF4-FFF2-40B4-BE49-F238E27FC236}">
-                <a16:creationId xmlns:a16="http://schemas.microsoft.com/office/drawing/2014/main" id="{07AC7A93-33F4-4896-A4AA-78A067161C10}"/>
+                <a16:creationId xmlns:a16="http://schemas.microsoft.com/office/drawing/2014/main" id="{32093A72-2DA8-4AEA-A79A-B189E4A7C571}"/>
               </a:ext>
             </a:extLst>
           </p:cNvPr>
@@ -18212,7 +18212,7 @@
           <p:cNvPr id="18" name="">
             <a:extLst xmlns:a="http://schemas.openxmlformats.org/drawingml/2006/main">
               <a:ext uri="{FF2B5EF4-FFF2-40B4-BE49-F238E27FC236}">
-                <a16:creationId xmlns:a16="http://schemas.microsoft.com/office/drawing/2014/main" id="{8C41CB2B-183C-4837-B99A-CE3982A301FA}"/>
+                <a16:creationId xmlns:a16="http://schemas.microsoft.com/office/drawing/2014/main" id="{65DD21C6-5C5B-4F17-8410-EBF7DF5AF66E}"/>
               </a:ext>
             </a:extLst>
           </p:cNvPr>
@@ -18262,7 +18262,7 @@
           <p:cNvPr id="19" name="">
             <a:extLst xmlns:a="http://schemas.openxmlformats.org/drawingml/2006/main">
               <a:ext uri="{FF2B5EF4-FFF2-40B4-BE49-F238E27FC236}">
-                <a16:creationId xmlns:a16="http://schemas.microsoft.com/office/drawing/2014/main" id="{A123CA6A-E7D1-481B-AA09-E03CBC847DE3}"/>
+                <a16:creationId xmlns:a16="http://schemas.microsoft.com/office/drawing/2014/main" id="{786FFD5A-E8E5-4BBD-8422-112ED3E2276E}"/>
               </a:ext>
             </a:extLst>
           </p:cNvPr>
@@ -18312,7 +18312,7 @@
           <p:cNvPr id="20" name="">
             <a:extLst xmlns:a="http://schemas.openxmlformats.org/drawingml/2006/main">
               <a:ext uri="{FF2B5EF4-FFF2-40B4-BE49-F238E27FC236}">
-                <a16:creationId xmlns:a16="http://schemas.microsoft.com/office/drawing/2014/main" id="{758B4D5B-DEC8-48AD-9838-DEBCB616B7AD}"/>
+                <a16:creationId xmlns:a16="http://schemas.microsoft.com/office/drawing/2014/main" id="{EAC322EB-8CBD-40B8-85F6-DA793A115B38}"/>
               </a:ext>
             </a:extLst>
           </p:cNvPr>
@@ -18362,7 +18362,7 @@
           <p:cNvPr id="21" name="">
             <a:extLst xmlns:a="http://schemas.openxmlformats.org/drawingml/2006/main">
               <a:ext uri="{FF2B5EF4-FFF2-40B4-BE49-F238E27FC236}">
-                <a16:creationId xmlns:a16="http://schemas.microsoft.com/office/drawing/2014/main" id="{A7195BC3-BBC0-422C-9893-2C57F6FF880B}"/>
+                <a16:creationId xmlns:a16="http://schemas.microsoft.com/office/drawing/2014/main" id="{4BDA1EAF-A9D1-4FF1-AA43-9C72633F8C15}"/>
               </a:ext>
             </a:extLst>
           </p:cNvPr>
@@ -18412,7 +18412,7 @@
           <p:cNvPr id="22" name="">
             <a:extLst xmlns:a="http://schemas.openxmlformats.org/drawingml/2006/main">
               <a:ext uri="{FF2B5EF4-FFF2-40B4-BE49-F238E27FC236}">
-                <a16:creationId xmlns:a16="http://schemas.microsoft.com/office/drawing/2014/main" id="{F765CAB0-1AC8-4319-B20F-C080854DB3F1}"/>
+                <a16:creationId xmlns:a16="http://schemas.microsoft.com/office/drawing/2014/main" id="{21EFFF45-0BC4-4C0C-8F78-3F5D6764EFCF}"/>
               </a:ext>
             </a:extLst>
           </p:cNvPr>
@@ -18445,7 +18445,7 @@
           <p:cNvPr id="23" name="">
             <a:extLst xmlns:a="http://schemas.openxmlformats.org/drawingml/2006/main">
               <a:ext uri="{FF2B5EF4-FFF2-40B4-BE49-F238E27FC236}">
-                <a16:creationId xmlns:a16="http://schemas.microsoft.com/office/drawing/2014/main" id="{005769BE-6BF9-4BA9-98D8-283E5F014474}"/>
+                <a16:creationId xmlns:a16="http://schemas.microsoft.com/office/drawing/2014/main" id="{17739AB7-881C-4393-A583-46BC055669A4}"/>
               </a:ext>
             </a:extLst>
           </p:cNvPr>
@@ -18495,7 +18495,7 @@
           <p:cNvPr id="24" name="">
             <a:extLst xmlns:a="http://schemas.openxmlformats.org/drawingml/2006/main">
               <a:ext uri="{FF2B5EF4-FFF2-40B4-BE49-F238E27FC236}">
-                <a16:creationId xmlns:a16="http://schemas.microsoft.com/office/drawing/2014/main" id="{304FCF19-7F9D-4A4B-9452-C7ADB999B568}"/>
+                <a16:creationId xmlns:a16="http://schemas.microsoft.com/office/drawing/2014/main" id="{E1B1B978-FEE7-414B-8426-49B23A14E0FD}"/>
               </a:ext>
             </a:extLst>
           </p:cNvPr>
@@ -18545,7 +18545,7 @@
           <p:cNvPr id="25" name="">
             <a:extLst xmlns:a="http://schemas.openxmlformats.org/drawingml/2006/main">
               <a:ext uri="{FF2B5EF4-FFF2-40B4-BE49-F238E27FC236}">
-                <a16:creationId xmlns:a16="http://schemas.microsoft.com/office/drawing/2014/main" id="{811F1C83-CBE0-4BDF-A496-CE75C11E6CF0}"/>
+                <a16:creationId xmlns:a16="http://schemas.microsoft.com/office/drawing/2014/main" id="{BFE29678-3F73-4960-9DEC-95100F393A31}"/>
               </a:ext>
             </a:extLst>
           </p:cNvPr>
@@ -18580,7 +18580,7 @@
           <p:cNvPr id="26" name="">
             <a:extLst xmlns:a="http://schemas.openxmlformats.org/drawingml/2006/main">
               <a:ext uri="{FF2B5EF4-FFF2-40B4-BE49-F238E27FC236}">
-                <a16:creationId xmlns:a16="http://schemas.microsoft.com/office/drawing/2014/main" id="{C6AA18D9-C8D9-44A7-8B71-C7781527C04B}"/>
+                <a16:creationId xmlns:a16="http://schemas.microsoft.com/office/drawing/2014/main" id="{EB4A9C41-C70B-4E31-AAFC-23D691A5F1B8}"/>
               </a:ext>
             </a:extLst>
           </p:cNvPr>
@@ -18613,7 +18613,7 @@
           <p:cNvPr id="27" name="">
             <a:extLst xmlns:a="http://schemas.openxmlformats.org/drawingml/2006/main">
               <a:ext uri="{FF2B5EF4-FFF2-40B4-BE49-F238E27FC236}">
-                <a16:creationId xmlns:a16="http://schemas.microsoft.com/office/drawing/2014/main" id="{06C2A7CB-2F99-4132-B6E8-7184B3417426}"/>
+                <a16:creationId xmlns:a16="http://schemas.microsoft.com/office/drawing/2014/main" id="{F31A470E-808A-484C-B7A5-2788F569A6E0}"/>
               </a:ext>
             </a:extLst>
           </p:cNvPr>
@@ -18663,7 +18663,7 @@
           <p:cNvPr id="28" name="">
             <a:extLst xmlns:a="http://schemas.openxmlformats.org/drawingml/2006/main">
               <a:ext uri="{FF2B5EF4-FFF2-40B4-BE49-F238E27FC236}">
-                <a16:creationId xmlns:a16="http://schemas.microsoft.com/office/drawing/2014/main" id="{DBE710B0-556C-4FA6-A6BA-24A6B29F61CA}"/>
+                <a16:creationId xmlns:a16="http://schemas.microsoft.com/office/drawing/2014/main" id="{56054A8A-8089-400C-9B9E-7316E17F6052}"/>
               </a:ext>
             </a:extLst>
           </p:cNvPr>
@@ -18713,7 +18713,7 @@
           <p:cNvPr id="29" name="">
             <a:extLst xmlns:a="http://schemas.openxmlformats.org/drawingml/2006/main">
               <a:ext uri="{FF2B5EF4-FFF2-40B4-BE49-F238E27FC236}">
-                <a16:creationId xmlns:a16="http://schemas.microsoft.com/office/drawing/2014/main" id="{7FE0BAFC-19AB-48B1-88E3-12DDA2428E8E}"/>
+                <a16:creationId xmlns:a16="http://schemas.microsoft.com/office/drawing/2014/main" id="{2752497E-CEDF-44BC-BBAB-01B93DF92664}"/>
               </a:ext>
             </a:extLst>
           </p:cNvPr>
@@ -18763,7 +18763,7 @@
           <p:cNvPr id="30" name="">
             <a:extLst xmlns:a="http://schemas.openxmlformats.org/drawingml/2006/main">
               <a:ext uri="{FF2B5EF4-FFF2-40B4-BE49-F238E27FC236}">
-                <a16:creationId xmlns:a16="http://schemas.microsoft.com/office/drawing/2014/main" id="{FB2166AC-B381-48F0-9410-DE38446A6443}"/>
+                <a16:creationId xmlns:a16="http://schemas.microsoft.com/office/drawing/2014/main" id="{0B79109A-CC2B-4CAE-A937-C6A4FF9612CB}"/>
               </a:ext>
             </a:extLst>
           </p:cNvPr>
@@ -18813,7 +18813,7 @@
           <p:cNvPr id="31" name="">
             <a:extLst xmlns:a="http://schemas.openxmlformats.org/drawingml/2006/main">
               <a:ext uri="{FF2B5EF4-FFF2-40B4-BE49-F238E27FC236}">
-                <a16:creationId xmlns:a16="http://schemas.microsoft.com/office/drawing/2014/main" id="{41DF2934-3744-4236-B479-E5CE67CEA26C}"/>
+                <a16:creationId xmlns:a16="http://schemas.microsoft.com/office/drawing/2014/main" id="{78FF332A-50A7-4860-A56B-DDBCEE0A2B84}"/>
               </a:ext>
             </a:extLst>
           </p:cNvPr>
@@ -18846,7 +18846,7 @@
           <p:cNvPr id="32" name="">
             <a:extLst xmlns:a="http://schemas.openxmlformats.org/drawingml/2006/main">
               <a:ext uri="{FF2B5EF4-FFF2-40B4-BE49-F238E27FC236}">
-                <a16:creationId xmlns:a16="http://schemas.microsoft.com/office/drawing/2014/main" id="{89AA938A-81DA-4BAB-B4A0-79E5AAADB512}"/>
+                <a16:creationId xmlns:a16="http://schemas.microsoft.com/office/drawing/2014/main" id="{D2C00612-6081-4FFC-8594-FE0075D116DC}"/>
               </a:ext>
             </a:extLst>
           </p:cNvPr>
@@ -18896,7 +18896,7 @@
           <p:cNvPr id="33" name="">
             <a:extLst xmlns:a="http://schemas.openxmlformats.org/drawingml/2006/main">
               <a:ext uri="{FF2B5EF4-FFF2-40B4-BE49-F238E27FC236}">
-                <a16:creationId xmlns:a16="http://schemas.microsoft.com/office/drawing/2014/main" id="{DDE14952-CD4F-41FB-BBB9-9916C9DA2B78}"/>
+                <a16:creationId xmlns:a16="http://schemas.microsoft.com/office/drawing/2014/main" id="{BDB857CE-1CE7-4E46-ADA9-A839166F6C38}"/>
               </a:ext>
             </a:extLst>
           </p:cNvPr>
@@ -18946,7 +18946,7 @@
           <p:cNvPr id="34" name="">
             <a:extLst xmlns:a="http://schemas.openxmlformats.org/drawingml/2006/main">
               <a:ext uri="{FF2B5EF4-FFF2-40B4-BE49-F238E27FC236}">
-                <a16:creationId xmlns:a16="http://schemas.microsoft.com/office/drawing/2014/main" id="{5D132D9A-2242-4BDA-AD73-A129C25D8246}"/>
+                <a16:creationId xmlns:a16="http://schemas.microsoft.com/office/drawing/2014/main" id="{75F67414-7F42-4E00-87C1-4E1EAE271B9C}"/>
               </a:ext>
             </a:extLst>
           </p:cNvPr>
@@ -18979,7 +18979,7 @@
           <p:cNvPr id="35" name="">
             <a:extLst xmlns:a="http://schemas.openxmlformats.org/drawingml/2006/main">
               <a:ext uri="{FF2B5EF4-FFF2-40B4-BE49-F238E27FC236}">
-                <a16:creationId xmlns:a16="http://schemas.microsoft.com/office/drawing/2014/main" id="{42F47DEF-05E3-49A4-9118-569CAE6216E5}"/>
+                <a16:creationId xmlns:a16="http://schemas.microsoft.com/office/drawing/2014/main" id="{49E2728C-FA74-4053-B407-0A089620811A}"/>
               </a:ext>
             </a:extLst>
           </p:cNvPr>
@@ -19029,7 +19029,7 @@
           <p:cNvPr id="36" name="">
             <a:extLst xmlns:a="http://schemas.openxmlformats.org/drawingml/2006/main">
               <a:ext uri="{FF2B5EF4-FFF2-40B4-BE49-F238E27FC236}">
-                <a16:creationId xmlns:a16="http://schemas.microsoft.com/office/drawing/2014/main" id="{58FAACCF-824C-4317-BF9E-E90B1D93AB97}"/>
+                <a16:creationId xmlns:a16="http://schemas.microsoft.com/office/drawing/2014/main" id="{A3222084-970C-403A-8286-17D2E26EA9B9}"/>
               </a:ext>
             </a:extLst>
           </p:cNvPr>
@@ -19077,7 +19077,7 @@
     </p:spTree>
     <p:extLst>
       <p:ext uri="{BB962C8B-B14F-4D97-AF65-F5344CB8AC3E}">
-        <p14:creationId xmlns:p14="http://schemas.microsoft.com/office/powerpoint/2010/main" val="723979224"/>
+        <p14:creationId xmlns:p14="http://schemas.microsoft.com/office/powerpoint/2010/main" val="522544441"/>
       </p:ext>
     </p:extLst>
   </p:cSld>
@@ -19108,7 +19108,7 @@
           <p:cNvPr id="19" name="">
             <a:extLst xmlns:a="http://schemas.openxmlformats.org/drawingml/2006/main">
               <a:ext uri="{FF2B5EF4-FFF2-40B4-BE49-F238E27FC236}">
-                <a16:creationId xmlns:a16="http://schemas.microsoft.com/office/drawing/2014/main" id="{B7B4957E-D23A-4124-8ED4-A593164E0065}"/>
+                <a16:creationId xmlns:a16="http://schemas.microsoft.com/office/drawing/2014/main" id="{8E6DDA19-F0B2-4D05-8475-B125F4376D43}"/>
               </a:ext>
             </a:extLst>
           </p:cNvPr>
@@ -19141,7 +19141,7 @@
           <p:cNvPr id="2" name="">
             <a:extLst xmlns:a="http://schemas.openxmlformats.org/drawingml/2006/main">
               <a:ext uri="{FF2B5EF4-FFF2-40B4-BE49-F238E27FC236}">
-                <a16:creationId xmlns:a16="http://schemas.microsoft.com/office/drawing/2014/main" id="{FC85D794-328E-405A-8E3B-39B92DCC4C97}"/>
+                <a16:creationId xmlns:a16="http://schemas.microsoft.com/office/drawing/2014/main" id="{94B6B4DF-BB9A-4CB4-A522-9B6BF177E55B}"/>
               </a:ext>
             </a:extLst>
           </p:cNvPr>
@@ -19191,7 +19191,7 @@
           <p:cNvPr id="3" name="">
             <a:extLst xmlns:a="http://schemas.openxmlformats.org/drawingml/2006/main">
               <a:ext uri="{FF2B5EF4-FFF2-40B4-BE49-F238E27FC236}">
-                <a16:creationId xmlns:a16="http://schemas.microsoft.com/office/drawing/2014/main" id="{A4257F3D-3CFF-4205-81D2-C59BFFDF935A}"/>
+                <a16:creationId xmlns:a16="http://schemas.microsoft.com/office/drawing/2014/main" id="{CE76A107-D5EF-4842-958A-DD95C44A2CAD}"/>
               </a:ext>
             </a:extLst>
           </p:cNvPr>
@@ -19241,7 +19241,7 @@
           <p:cNvPr id="4" name="">
             <a:extLst xmlns:a="http://schemas.openxmlformats.org/drawingml/2006/main">
               <a:ext uri="{FF2B5EF4-FFF2-40B4-BE49-F238E27FC236}">
-                <a16:creationId xmlns:a16="http://schemas.microsoft.com/office/drawing/2014/main" id="{48DE19D6-B925-4C4A-ABFF-02119B8C940E}"/>
+                <a16:creationId xmlns:a16="http://schemas.microsoft.com/office/drawing/2014/main" id="{06C76D72-5863-4020-B595-A061BBD1A2F5}"/>
               </a:ext>
             </a:extLst>
           </p:cNvPr>
@@ -19291,7 +19291,7 @@
           <p:cNvPr id="5" name="">
             <a:extLst xmlns:a="http://schemas.openxmlformats.org/drawingml/2006/main">
               <a:ext uri="{FF2B5EF4-FFF2-40B4-BE49-F238E27FC236}">
-                <a16:creationId xmlns:a16="http://schemas.microsoft.com/office/drawing/2014/main" id="{E1655C1E-02B9-4821-A247-3D4776F8AFF7}"/>
+                <a16:creationId xmlns:a16="http://schemas.microsoft.com/office/drawing/2014/main" id="{B7536E11-36C9-4060-93B6-DDC074CC2B0F}"/>
               </a:ext>
             </a:extLst>
           </p:cNvPr>
@@ -19341,7 +19341,7 @@
           <p:cNvPr id="6" name="">
             <a:extLst xmlns:a="http://schemas.openxmlformats.org/drawingml/2006/main">
               <a:ext uri="{FF2B5EF4-FFF2-40B4-BE49-F238E27FC236}">
-                <a16:creationId xmlns:a16="http://schemas.microsoft.com/office/drawing/2014/main" id="{C5FD1979-DFB4-4A41-BE3F-0B0FCD7F8A39}"/>
+                <a16:creationId xmlns:a16="http://schemas.microsoft.com/office/drawing/2014/main" id="{53F53342-85D4-4CA4-B486-2241A84F42A8}"/>
               </a:ext>
             </a:extLst>
           </p:cNvPr>
@@ -19374,7 +19374,7 @@
           <p:cNvPr id="7" name="">
             <a:extLst xmlns:a="http://schemas.openxmlformats.org/drawingml/2006/main">
               <a:ext uri="{FF2B5EF4-FFF2-40B4-BE49-F238E27FC236}">
-                <a16:creationId xmlns:a16="http://schemas.microsoft.com/office/drawing/2014/main" id="{F45F5B8C-855F-40E8-AE9F-5FBD626E755B}"/>
+                <a16:creationId xmlns:a16="http://schemas.microsoft.com/office/drawing/2014/main" id="{B0975DE4-E99C-4CE7-8774-6F12E96EF672}"/>
               </a:ext>
             </a:extLst>
           </p:cNvPr>
@@ -19409,7 +19409,7 @@
           <p:cNvPr id="8" name="">
             <a:extLst xmlns:a="http://schemas.openxmlformats.org/drawingml/2006/main">
               <a:ext uri="{FF2B5EF4-FFF2-40B4-BE49-F238E27FC236}">
-                <a16:creationId xmlns:a16="http://schemas.microsoft.com/office/drawing/2014/main" id="{4A8186C1-499B-4531-A57F-AD4CF64CD9A5}"/>
+                <a16:creationId xmlns:a16="http://schemas.microsoft.com/office/drawing/2014/main" id="{CF191595-B607-4A13-86EE-9274F4CF16B2}"/>
               </a:ext>
             </a:extLst>
           </p:cNvPr>
@@ -19442,7 +19442,7 @@
           <p:cNvPr id="9" name="">
             <a:extLst xmlns:a="http://schemas.openxmlformats.org/drawingml/2006/main">
               <a:ext uri="{FF2B5EF4-FFF2-40B4-BE49-F238E27FC236}">
-                <a16:creationId xmlns:a16="http://schemas.microsoft.com/office/drawing/2014/main" id="{333970B4-1DE1-4892-B02B-9BC909FEFAB5}"/>
+                <a16:creationId xmlns:a16="http://schemas.microsoft.com/office/drawing/2014/main" id="{67075A2F-BF47-436A-A97D-B20695665EF7}"/>
               </a:ext>
             </a:extLst>
           </p:cNvPr>
@@ -19492,7 +19492,7 @@
           <p:cNvPr id="10" name="">
             <a:extLst xmlns:a="http://schemas.openxmlformats.org/drawingml/2006/main">
               <a:ext uri="{FF2B5EF4-FFF2-40B4-BE49-F238E27FC236}">
-                <a16:creationId xmlns:a16="http://schemas.microsoft.com/office/drawing/2014/main" id="{E9DDC3CE-40E0-4B64-A438-B4BC3C8DEC3A}"/>
+                <a16:creationId xmlns:a16="http://schemas.microsoft.com/office/drawing/2014/main" id="{13AB0E00-7185-4595-BD55-E8A08ADEA7B8}"/>
               </a:ext>
             </a:extLst>
           </p:cNvPr>
@@ -19542,7 +19542,7 @@
           <p:cNvPr id="11" name="">
             <a:extLst xmlns:a="http://schemas.openxmlformats.org/drawingml/2006/main">
               <a:ext uri="{FF2B5EF4-FFF2-40B4-BE49-F238E27FC236}">
-                <a16:creationId xmlns:a16="http://schemas.microsoft.com/office/drawing/2014/main" id="{67C281CF-4563-42C6-A542-349F4BD7C00D}"/>
+                <a16:creationId xmlns:a16="http://schemas.microsoft.com/office/drawing/2014/main" id="{85FE1C06-3429-437B-AE6C-83ABF601FCE2}"/>
               </a:ext>
             </a:extLst>
           </p:cNvPr>
@@ -19592,7 +19592,7 @@
           <p:cNvPr id="12" name="">
             <a:extLst xmlns:a="http://schemas.openxmlformats.org/drawingml/2006/main">
               <a:ext uri="{FF2B5EF4-FFF2-40B4-BE49-F238E27FC236}">
-                <a16:creationId xmlns:a16="http://schemas.microsoft.com/office/drawing/2014/main" id="{6A91C4CD-5B72-452B-B391-B85BBE1C3979}"/>
+                <a16:creationId xmlns:a16="http://schemas.microsoft.com/office/drawing/2014/main" id="{B23CAC53-AFA5-4BAC-8382-B0609EACCF3F}"/>
               </a:ext>
             </a:extLst>
           </p:cNvPr>
@@ -19642,7 +19642,7 @@
           <p:cNvPr id="13" name="">
             <a:extLst xmlns:a="http://schemas.openxmlformats.org/drawingml/2006/main">
               <a:ext uri="{FF2B5EF4-FFF2-40B4-BE49-F238E27FC236}">
-                <a16:creationId xmlns:a16="http://schemas.microsoft.com/office/drawing/2014/main" id="{7B2C728D-ED60-4F66-A889-2E7ADEA7FC4D}"/>
+                <a16:creationId xmlns:a16="http://schemas.microsoft.com/office/drawing/2014/main" id="{047B0A94-476C-4498-9287-FDDEEDE9AE85}"/>
               </a:ext>
             </a:extLst>
           </p:cNvPr>
@@ -19675,7 +19675,7 @@
           <p:cNvPr id="14" name="">
             <a:extLst xmlns:a="http://schemas.openxmlformats.org/drawingml/2006/main">
               <a:ext uri="{FF2B5EF4-FFF2-40B4-BE49-F238E27FC236}">
-                <a16:creationId xmlns:a16="http://schemas.microsoft.com/office/drawing/2014/main" id="{8F088269-0F85-440C-9D76-DB14A950041F}"/>
+                <a16:creationId xmlns:a16="http://schemas.microsoft.com/office/drawing/2014/main" id="{E5BE6F13-1B9C-4E2C-95D6-B837AFB61F11}"/>
               </a:ext>
             </a:extLst>
           </p:cNvPr>
@@ -19725,7 +19725,7 @@
           <p:cNvPr id="15" name="">
             <a:extLst xmlns:a="http://schemas.openxmlformats.org/drawingml/2006/main">
               <a:ext uri="{FF2B5EF4-FFF2-40B4-BE49-F238E27FC236}">
-                <a16:creationId xmlns:a16="http://schemas.microsoft.com/office/drawing/2014/main" id="{7C81F812-ECD3-4B58-8E6F-7E24C5691AF8}"/>
+                <a16:creationId xmlns:a16="http://schemas.microsoft.com/office/drawing/2014/main" id="{07320461-EEB8-4FA8-8E18-5A2DDCDAC534}"/>
               </a:ext>
             </a:extLst>
           </p:cNvPr>
@@ -19775,7 +19775,7 @@
           <p:cNvPr id="16" name="">
             <a:extLst xmlns:a="http://schemas.openxmlformats.org/drawingml/2006/main">
               <a:ext uri="{FF2B5EF4-FFF2-40B4-BE49-F238E27FC236}">
-                <a16:creationId xmlns:a16="http://schemas.microsoft.com/office/drawing/2014/main" id="{CDFE24A9-8900-4032-9E4C-5CDBCFE235D8}"/>
+                <a16:creationId xmlns:a16="http://schemas.microsoft.com/office/drawing/2014/main" id="{5F31EEF2-2B7B-456A-AB28-DB6073B4FF56}"/>
               </a:ext>
             </a:extLst>
           </p:cNvPr>
@@ -19808,7 +19808,7 @@
           <p:cNvPr id="17" name="">
             <a:extLst xmlns:a="http://schemas.openxmlformats.org/drawingml/2006/main">
               <a:ext uri="{FF2B5EF4-FFF2-40B4-BE49-F238E27FC236}">
-                <a16:creationId xmlns:a16="http://schemas.microsoft.com/office/drawing/2014/main" id="{5B3FC31A-273E-4DE0-9191-BF157C85AF8C}"/>
+                <a16:creationId xmlns:a16="http://schemas.microsoft.com/office/drawing/2014/main" id="{40EE6A4B-20FC-4C18-AE8D-F069BD5D6E83}"/>
               </a:ext>
             </a:extLst>
           </p:cNvPr>
@@ -19858,7 +19858,7 @@
           <p:cNvPr id="18" name="">
             <a:extLst xmlns:a="http://schemas.openxmlformats.org/drawingml/2006/main">
               <a:ext uri="{FF2B5EF4-FFF2-40B4-BE49-F238E27FC236}">
-                <a16:creationId xmlns:a16="http://schemas.microsoft.com/office/drawing/2014/main" id="{CA936C2A-FD47-4537-91FE-9C8E835618E2}"/>
+                <a16:creationId xmlns:a16="http://schemas.microsoft.com/office/drawing/2014/main" id="{3C0C3A28-7790-4C5B-A448-B9145672FBB0}"/>
               </a:ext>
             </a:extLst>
           </p:cNvPr>
@@ -19906,7 +19906,7 @@
     </p:spTree>
     <p:extLst>
       <p:ext uri="{BB962C8B-B14F-4D97-AF65-F5344CB8AC3E}">
-        <p14:creationId xmlns:p14="http://schemas.microsoft.com/office/powerpoint/2010/main" val="726868930"/>
+        <p14:creationId xmlns:p14="http://schemas.microsoft.com/office/powerpoint/2010/main" val="66892847"/>
       </p:ext>
     </p:extLst>
   </p:cSld>
@@ -19937,7 +19937,7 @@
           <p:cNvPr id="34" name="">
             <a:extLst xmlns:a="http://schemas.openxmlformats.org/drawingml/2006/main">
               <a:ext uri="{FF2B5EF4-FFF2-40B4-BE49-F238E27FC236}">
-                <a16:creationId xmlns:a16="http://schemas.microsoft.com/office/drawing/2014/main" id="{5EF7D30F-ACBF-409B-83A6-7033831E8371}"/>
+                <a16:creationId xmlns:a16="http://schemas.microsoft.com/office/drawing/2014/main" id="{AD5D299B-7BC5-41ED-B53C-05C14D94C527}"/>
               </a:ext>
             </a:extLst>
           </p:cNvPr>
@@ -19970,7 +19970,7 @@
           <p:cNvPr id="2" name="">
             <a:extLst xmlns:a="http://schemas.openxmlformats.org/drawingml/2006/main">
               <a:ext uri="{FF2B5EF4-FFF2-40B4-BE49-F238E27FC236}">
-                <a16:creationId xmlns:a16="http://schemas.microsoft.com/office/drawing/2014/main" id="{D58D6595-0502-4463-B35E-D4047192E3FF}"/>
+                <a16:creationId xmlns:a16="http://schemas.microsoft.com/office/drawing/2014/main" id="{B3B5624A-7BEA-42D8-8E4D-8EC096FF8C9F}"/>
               </a:ext>
             </a:extLst>
           </p:cNvPr>
@@ -20020,7 +20020,7 @@
           <p:cNvPr id="3" name="">
             <a:extLst xmlns:a="http://schemas.openxmlformats.org/drawingml/2006/main">
               <a:ext uri="{FF2B5EF4-FFF2-40B4-BE49-F238E27FC236}">
-                <a16:creationId xmlns:a16="http://schemas.microsoft.com/office/drawing/2014/main" id="{A9DC5AD1-AD5F-4027-BB6B-351D77F8062A}"/>
+                <a16:creationId xmlns:a16="http://schemas.microsoft.com/office/drawing/2014/main" id="{BDAD8A44-6B06-4514-A878-BEFFAA379F1C}"/>
               </a:ext>
             </a:extLst>
           </p:cNvPr>
@@ -20070,7 +20070,7 @@
           <p:cNvPr id="4" name="">
             <a:extLst xmlns:a="http://schemas.openxmlformats.org/drawingml/2006/main">
               <a:ext uri="{FF2B5EF4-FFF2-40B4-BE49-F238E27FC236}">
-                <a16:creationId xmlns:a16="http://schemas.microsoft.com/office/drawing/2014/main" id="{E3149BD3-9CC8-4160-B0DB-9F431767F448}"/>
+                <a16:creationId xmlns:a16="http://schemas.microsoft.com/office/drawing/2014/main" id="{6E8D73B4-BB53-40BC-A228-F9B99DD33AFE}"/>
               </a:ext>
             </a:extLst>
           </p:cNvPr>
@@ -20120,7 +20120,7 @@
           <p:cNvPr id="5" name="">
             <a:extLst xmlns:a="http://schemas.openxmlformats.org/drawingml/2006/main">
               <a:ext uri="{FF2B5EF4-FFF2-40B4-BE49-F238E27FC236}">
-                <a16:creationId xmlns:a16="http://schemas.microsoft.com/office/drawing/2014/main" id="{4F9FEF38-BC05-4866-9786-FFBD51EB2601}"/>
+                <a16:creationId xmlns:a16="http://schemas.microsoft.com/office/drawing/2014/main" id="{028A81DC-8D51-4C22-8790-2004D6DFC0CF}"/>
               </a:ext>
             </a:extLst>
           </p:cNvPr>
@@ -20170,7 +20170,7 @@
           <p:cNvPr id="6" name="">
             <a:extLst xmlns:a="http://schemas.openxmlformats.org/drawingml/2006/main">
               <a:ext uri="{FF2B5EF4-FFF2-40B4-BE49-F238E27FC236}">
-                <a16:creationId xmlns:a16="http://schemas.microsoft.com/office/drawing/2014/main" id="{B192C52D-C556-41C0-9E60-07D45A0B4158}"/>
+                <a16:creationId xmlns:a16="http://schemas.microsoft.com/office/drawing/2014/main" id="{3E88283F-46F9-423C-9137-C7A478031B5A}"/>
               </a:ext>
             </a:extLst>
           </p:cNvPr>
@@ -20203,7 +20203,7 @@
           <p:cNvPr id="7" name="">
             <a:extLst xmlns:a="http://schemas.openxmlformats.org/drawingml/2006/main">
               <a:ext uri="{FF2B5EF4-FFF2-40B4-BE49-F238E27FC236}">
-                <a16:creationId xmlns:a16="http://schemas.microsoft.com/office/drawing/2014/main" id="{08C44771-2ACE-4F0C-B130-714BF8ED0822}"/>
+                <a16:creationId xmlns:a16="http://schemas.microsoft.com/office/drawing/2014/main" id="{9032E146-46A2-42D4-A447-59CE1CB2D9FC}"/>
               </a:ext>
             </a:extLst>
           </p:cNvPr>
@@ -20238,7 +20238,7 @@
           <p:cNvPr id="8" name="">
             <a:extLst xmlns:a="http://schemas.openxmlformats.org/drawingml/2006/main">
               <a:ext uri="{FF2B5EF4-FFF2-40B4-BE49-F238E27FC236}">
-                <a16:creationId xmlns:a16="http://schemas.microsoft.com/office/drawing/2014/main" id="{F4A31284-1CE2-4EFB-9442-D73B948ED42A}"/>
+                <a16:creationId xmlns:a16="http://schemas.microsoft.com/office/drawing/2014/main" id="{BCB204AC-6EA2-4CE4-B0D4-3BA08C2BB8A4}"/>
               </a:ext>
             </a:extLst>
           </p:cNvPr>
@@ -20271,7 +20271,7 @@
           <p:cNvPr id="9" name="">
             <a:extLst xmlns:a="http://schemas.openxmlformats.org/drawingml/2006/main">
               <a:ext uri="{FF2B5EF4-FFF2-40B4-BE49-F238E27FC236}">
-                <a16:creationId xmlns:a16="http://schemas.microsoft.com/office/drawing/2014/main" id="{93DC0290-A41E-436D-AF1D-C6AAAE9BA09F}"/>
+                <a16:creationId xmlns:a16="http://schemas.microsoft.com/office/drawing/2014/main" id="{92E2429F-5CDE-43F7-B0DC-139CEA441A59}"/>
               </a:ext>
             </a:extLst>
           </p:cNvPr>
@@ -20321,7 +20321,7 @@
           <p:cNvPr id="10" name="">
             <a:extLst xmlns:a="http://schemas.openxmlformats.org/drawingml/2006/main">
               <a:ext uri="{FF2B5EF4-FFF2-40B4-BE49-F238E27FC236}">
-                <a16:creationId xmlns:a16="http://schemas.microsoft.com/office/drawing/2014/main" id="{FB084CA9-D5A7-4F69-989C-5F444EED10AF}"/>
+                <a16:creationId xmlns:a16="http://schemas.microsoft.com/office/drawing/2014/main" id="{EC98FC44-4BC4-4199-8E68-6B49E821181F}"/>
               </a:ext>
             </a:extLst>
           </p:cNvPr>
@@ -20371,7 +20371,7 @@
           <p:cNvPr id="11" name="">
             <a:extLst xmlns:a="http://schemas.openxmlformats.org/drawingml/2006/main">
               <a:ext uri="{FF2B5EF4-FFF2-40B4-BE49-F238E27FC236}">
-                <a16:creationId xmlns:a16="http://schemas.microsoft.com/office/drawing/2014/main" id="{2A56F864-A384-4BF3-B1F4-003F683A998E}"/>
+                <a16:creationId xmlns:a16="http://schemas.microsoft.com/office/drawing/2014/main" id="{DEB3F125-B0FE-4232-9D6C-261587044187}"/>
               </a:ext>
             </a:extLst>
           </p:cNvPr>
@@ -20421,7 +20421,7 @@
           <p:cNvPr id="12" name="">
             <a:extLst xmlns:a="http://schemas.openxmlformats.org/drawingml/2006/main">
               <a:ext uri="{FF2B5EF4-FFF2-40B4-BE49-F238E27FC236}">
-                <a16:creationId xmlns:a16="http://schemas.microsoft.com/office/drawing/2014/main" id="{FD2E39EB-5A77-4BC9-B500-0E6B1F58CA4F}"/>
+                <a16:creationId xmlns:a16="http://schemas.microsoft.com/office/drawing/2014/main" id="{0CF860F2-03FE-4150-9A0F-4B59FC28CC6A}"/>
               </a:ext>
             </a:extLst>
           </p:cNvPr>
@@ -20471,7 +20471,7 @@
           <p:cNvPr id="13" name="">
             <a:extLst xmlns:a="http://schemas.openxmlformats.org/drawingml/2006/main">
               <a:ext uri="{FF2B5EF4-FFF2-40B4-BE49-F238E27FC236}">
-                <a16:creationId xmlns:a16="http://schemas.microsoft.com/office/drawing/2014/main" id="{706A5CB3-1A14-4AAA-AEDD-2F72F65A87C0}"/>
+                <a16:creationId xmlns:a16="http://schemas.microsoft.com/office/drawing/2014/main" id="{33E50531-DC8E-4EC8-A1E3-5D3A61C54110}"/>
               </a:ext>
             </a:extLst>
           </p:cNvPr>
@@ -20504,7 +20504,7 @@
           <p:cNvPr id="14" name="">
             <a:extLst xmlns:a="http://schemas.openxmlformats.org/drawingml/2006/main">
               <a:ext uri="{FF2B5EF4-FFF2-40B4-BE49-F238E27FC236}">
-                <a16:creationId xmlns:a16="http://schemas.microsoft.com/office/drawing/2014/main" id="{3C3BD78E-DD5F-4632-9835-5F3C217F479A}"/>
+                <a16:creationId xmlns:a16="http://schemas.microsoft.com/office/drawing/2014/main" id="{B3C1A229-570E-4788-8335-3DB21D5021B2}"/>
               </a:ext>
             </a:extLst>
           </p:cNvPr>
@@ -20571,7 +20571,7 @@
           <p:cNvPr id="15" name="">
             <a:extLst xmlns:a="http://schemas.openxmlformats.org/drawingml/2006/main">
               <a:ext uri="{FF2B5EF4-FFF2-40B4-BE49-F238E27FC236}">
-                <a16:creationId xmlns:a16="http://schemas.microsoft.com/office/drawing/2014/main" id="{1604CC07-4EB2-4696-B6F0-DA6AFBADAF05}"/>
+                <a16:creationId xmlns:a16="http://schemas.microsoft.com/office/drawing/2014/main" id="{6138056A-8CA0-4672-8E88-1CE2AAB6ACD1}"/>
               </a:ext>
             </a:extLst>
           </p:cNvPr>
@@ -20638,7 +20638,7 @@
           <p:cNvPr id="16" name="">
             <a:extLst xmlns:a="http://schemas.openxmlformats.org/drawingml/2006/main">
               <a:ext uri="{FF2B5EF4-FFF2-40B4-BE49-F238E27FC236}">
-                <a16:creationId xmlns:a16="http://schemas.microsoft.com/office/drawing/2014/main" id="{4055FA7C-9FE0-4B64-946A-B94C6755A533}"/>
+                <a16:creationId xmlns:a16="http://schemas.microsoft.com/office/drawing/2014/main" id="{32E3A445-533B-49AB-AD6A-355E21D527EB}"/>
               </a:ext>
             </a:extLst>
           </p:cNvPr>
@@ -20673,7 +20673,7 @@
           <p:cNvPr id="17" name="">
             <a:extLst xmlns:a="http://schemas.openxmlformats.org/drawingml/2006/main">
               <a:ext uri="{FF2B5EF4-FFF2-40B4-BE49-F238E27FC236}">
-                <a16:creationId xmlns:a16="http://schemas.microsoft.com/office/drawing/2014/main" id="{B4F0CD02-6C96-41E0-9E79-04EDDD9F4BC0}"/>
+                <a16:creationId xmlns:a16="http://schemas.microsoft.com/office/drawing/2014/main" id="{B02D5982-E27C-494E-9A0E-0B6A21C78783}"/>
               </a:ext>
             </a:extLst>
           </p:cNvPr>
@@ -20706,7 +20706,7 @@
           <p:cNvPr id="18" name="">
             <a:extLst xmlns:a="http://schemas.openxmlformats.org/drawingml/2006/main">
               <a:ext uri="{FF2B5EF4-FFF2-40B4-BE49-F238E27FC236}">
-                <a16:creationId xmlns:a16="http://schemas.microsoft.com/office/drawing/2014/main" id="{B65EA7F3-1F45-440D-B54C-654D76D66CF9}"/>
+                <a16:creationId xmlns:a16="http://schemas.microsoft.com/office/drawing/2014/main" id="{132578AD-2B51-4EEA-851A-CC247C16E15F}"/>
               </a:ext>
             </a:extLst>
           </p:cNvPr>
@@ -20756,7 +20756,7 @@
           <p:cNvPr id="19" name="">
             <a:extLst xmlns:a="http://schemas.openxmlformats.org/drawingml/2006/main">
               <a:ext uri="{FF2B5EF4-FFF2-40B4-BE49-F238E27FC236}">
-                <a16:creationId xmlns:a16="http://schemas.microsoft.com/office/drawing/2014/main" id="{9B3DD440-5168-453B-A36B-92BD385F9BC2}"/>
+                <a16:creationId xmlns:a16="http://schemas.microsoft.com/office/drawing/2014/main" id="{C8982273-3101-478F-A7F1-A19530E21BB4}"/>
               </a:ext>
             </a:extLst>
           </p:cNvPr>
@@ -20806,7 +20806,7 @@
           <p:cNvPr id="20" name="">
             <a:extLst xmlns:a="http://schemas.openxmlformats.org/drawingml/2006/main">
               <a:ext uri="{FF2B5EF4-FFF2-40B4-BE49-F238E27FC236}">
-                <a16:creationId xmlns:a16="http://schemas.microsoft.com/office/drawing/2014/main" id="{771E46F8-4F14-4EAE-B64A-8589BD3C9969}"/>
+                <a16:creationId xmlns:a16="http://schemas.microsoft.com/office/drawing/2014/main" id="{A0C0FFB7-14E7-4DF8-80A2-0075BFBC2035}"/>
               </a:ext>
             </a:extLst>
           </p:cNvPr>
@@ -20856,7 +20856,7 @@
           <p:cNvPr id="21" name="">
             <a:extLst xmlns:a="http://schemas.openxmlformats.org/drawingml/2006/main">
               <a:ext uri="{FF2B5EF4-FFF2-40B4-BE49-F238E27FC236}">
-                <a16:creationId xmlns:a16="http://schemas.microsoft.com/office/drawing/2014/main" id="{7CB120DE-3C30-43DC-AA53-D1FF9FB690E5}"/>
+                <a16:creationId xmlns:a16="http://schemas.microsoft.com/office/drawing/2014/main" id="{37A9E4AD-32E7-4881-A426-B8A43315F7E5}"/>
               </a:ext>
             </a:extLst>
           </p:cNvPr>
@@ -20906,7 +20906,7 @@
           <p:cNvPr id="22" name="">
             <a:extLst xmlns:a="http://schemas.openxmlformats.org/drawingml/2006/main">
               <a:ext uri="{FF2B5EF4-FFF2-40B4-BE49-F238E27FC236}">
-                <a16:creationId xmlns:a16="http://schemas.microsoft.com/office/drawing/2014/main" id="{690AE5A0-B65E-4FA2-8C7F-1F63F7F69CCC}"/>
+                <a16:creationId xmlns:a16="http://schemas.microsoft.com/office/drawing/2014/main" id="{CF39CAC3-710C-4393-97BB-92EC31D121D8}"/>
               </a:ext>
             </a:extLst>
           </p:cNvPr>
@@ -20939,7 +20939,7 @@
           <p:cNvPr id="23" name="">
             <a:extLst xmlns:a="http://schemas.openxmlformats.org/drawingml/2006/main">
               <a:ext uri="{FF2B5EF4-FFF2-40B4-BE49-F238E27FC236}">
-                <a16:creationId xmlns:a16="http://schemas.microsoft.com/office/drawing/2014/main" id="{6A6CEA09-0883-4955-8B5F-9BEEA6B02A36}"/>
+                <a16:creationId xmlns:a16="http://schemas.microsoft.com/office/drawing/2014/main" id="{B63689D3-EAEC-4FC0-AFED-3FF4686F3D2E}"/>
               </a:ext>
             </a:extLst>
           </p:cNvPr>
@@ -20989,7 +20989,7 @@
           <p:cNvPr id="24" name="">
             <a:extLst xmlns:a="http://schemas.openxmlformats.org/drawingml/2006/main">
               <a:ext uri="{FF2B5EF4-FFF2-40B4-BE49-F238E27FC236}">
-                <a16:creationId xmlns:a16="http://schemas.microsoft.com/office/drawing/2014/main" id="{DCFA46DE-4868-49AE-B027-02C96076DBB3}"/>
+                <a16:creationId xmlns:a16="http://schemas.microsoft.com/office/drawing/2014/main" id="{F8ECBB72-3911-42EB-89FD-CD18B27DBC26}"/>
               </a:ext>
             </a:extLst>
           </p:cNvPr>
@@ -21039,7 +21039,7 @@
           <p:cNvPr id="25" name="">
             <a:extLst xmlns:a="http://schemas.openxmlformats.org/drawingml/2006/main">
               <a:ext uri="{FF2B5EF4-FFF2-40B4-BE49-F238E27FC236}">
-                <a16:creationId xmlns:a16="http://schemas.microsoft.com/office/drawing/2014/main" id="{BA6DCD44-6A03-434D-9409-94BFAB31BC30}"/>
+                <a16:creationId xmlns:a16="http://schemas.microsoft.com/office/drawing/2014/main" id="{58F4B6C7-0529-4677-80D8-EDCAB1895AC2}"/>
               </a:ext>
             </a:extLst>
           </p:cNvPr>
@@ -21074,7 +21074,7 @@
           <p:cNvPr id="26" name="">
             <a:extLst xmlns:a="http://schemas.openxmlformats.org/drawingml/2006/main">
               <a:ext uri="{FF2B5EF4-FFF2-40B4-BE49-F238E27FC236}">
-                <a16:creationId xmlns:a16="http://schemas.microsoft.com/office/drawing/2014/main" id="{D298537D-1ECE-4121-85DB-D2C21E46E753}"/>
+                <a16:creationId xmlns:a16="http://schemas.microsoft.com/office/drawing/2014/main" id="{5D9861F3-803E-42A2-9649-1C8159AADE2C}"/>
               </a:ext>
             </a:extLst>
           </p:cNvPr>
@@ -21107,7 +21107,7 @@
           <p:cNvPr id="27" name="">
             <a:extLst xmlns:a="http://schemas.openxmlformats.org/drawingml/2006/main">
               <a:ext uri="{FF2B5EF4-FFF2-40B4-BE49-F238E27FC236}">
-                <a16:creationId xmlns:a16="http://schemas.microsoft.com/office/drawing/2014/main" id="{C6156D07-8919-456B-A627-5B4EEE062A5F}"/>
+                <a16:creationId xmlns:a16="http://schemas.microsoft.com/office/drawing/2014/main" id="{CFDA921E-2018-4D06-BE7F-124692EC8613}"/>
               </a:ext>
             </a:extLst>
           </p:cNvPr>
@@ -21157,7 +21157,7 @@
           <p:cNvPr id="28" name="">
             <a:extLst xmlns:a="http://schemas.openxmlformats.org/drawingml/2006/main">
               <a:ext uri="{FF2B5EF4-FFF2-40B4-BE49-F238E27FC236}">
-                <a16:creationId xmlns:a16="http://schemas.microsoft.com/office/drawing/2014/main" id="{0C878D16-D88E-4961-93D4-1C47886EB410}"/>
+                <a16:creationId xmlns:a16="http://schemas.microsoft.com/office/drawing/2014/main" id="{CAE00961-4C3D-4F82-8F7A-03616D22C9F0}"/>
               </a:ext>
             </a:extLst>
           </p:cNvPr>
@@ -21207,7 +21207,7 @@
           <p:cNvPr id="29" name="">
             <a:extLst xmlns:a="http://schemas.openxmlformats.org/drawingml/2006/main">
               <a:ext uri="{FF2B5EF4-FFF2-40B4-BE49-F238E27FC236}">
-                <a16:creationId xmlns:a16="http://schemas.microsoft.com/office/drawing/2014/main" id="{3D9D9A79-A4C2-4415-BDDE-A2E539537FED}"/>
+                <a16:creationId xmlns:a16="http://schemas.microsoft.com/office/drawing/2014/main" id="{412C385C-CFFC-4D9D-BEA6-F448115E18EB}"/>
               </a:ext>
             </a:extLst>
           </p:cNvPr>
@@ -21257,7 +21257,7 @@
           <p:cNvPr id="30" name="">
             <a:extLst xmlns:a="http://schemas.openxmlformats.org/drawingml/2006/main">
               <a:ext uri="{FF2B5EF4-FFF2-40B4-BE49-F238E27FC236}">
-                <a16:creationId xmlns:a16="http://schemas.microsoft.com/office/drawing/2014/main" id="{AECDA6CA-2067-42CE-957A-DE51CC83AB11}"/>
+                <a16:creationId xmlns:a16="http://schemas.microsoft.com/office/drawing/2014/main" id="{2933EAAC-8993-480C-8EFE-3D924C8DC81B}"/>
               </a:ext>
             </a:extLst>
           </p:cNvPr>
@@ -21307,7 +21307,7 @@
           <p:cNvPr id="31" name="">
             <a:extLst xmlns:a="http://schemas.openxmlformats.org/drawingml/2006/main">
               <a:ext uri="{FF2B5EF4-FFF2-40B4-BE49-F238E27FC236}">
-                <a16:creationId xmlns:a16="http://schemas.microsoft.com/office/drawing/2014/main" id="{A58F1935-F1D1-44FB-A2DF-27BEECEC08B0}"/>
+                <a16:creationId xmlns:a16="http://schemas.microsoft.com/office/drawing/2014/main" id="{6D18B4F7-E0B6-4015-9E8F-DF9BB822A2DE}"/>
               </a:ext>
             </a:extLst>
           </p:cNvPr>
@@ -21340,7 +21340,7 @@
           <p:cNvPr id="32" name="">
             <a:extLst xmlns:a="http://schemas.openxmlformats.org/drawingml/2006/main">
               <a:ext uri="{FF2B5EF4-FFF2-40B4-BE49-F238E27FC236}">
-                <a16:creationId xmlns:a16="http://schemas.microsoft.com/office/drawing/2014/main" id="{1255FDF5-6FE8-449F-85DC-EE2C524FDA10}"/>
+                <a16:creationId xmlns:a16="http://schemas.microsoft.com/office/drawing/2014/main" id="{184509D4-AE80-464B-81D0-EDA8F12BA88C}"/>
               </a:ext>
             </a:extLst>
           </p:cNvPr>
@@ -21390,7 +21390,7 @@
           <p:cNvPr id="33" name="">
             <a:extLst xmlns:a="http://schemas.openxmlformats.org/drawingml/2006/main">
               <a:ext uri="{FF2B5EF4-FFF2-40B4-BE49-F238E27FC236}">
-                <a16:creationId xmlns:a16="http://schemas.microsoft.com/office/drawing/2014/main" id="{215EF68D-FD18-437B-A662-EA24563E0408}"/>
+                <a16:creationId xmlns:a16="http://schemas.microsoft.com/office/drawing/2014/main" id="{87D779D2-A8B9-4F35-98BE-F47BCF32FE08}"/>
               </a:ext>
             </a:extLst>
           </p:cNvPr>
@@ -21438,7 +21438,7 @@
     </p:spTree>
     <p:extLst>
       <p:ext uri="{BB962C8B-B14F-4D97-AF65-F5344CB8AC3E}">
-        <p14:creationId xmlns:p14="http://schemas.microsoft.com/office/powerpoint/2010/main" val="1366341025"/>
+        <p14:creationId xmlns:p14="http://schemas.microsoft.com/office/powerpoint/2010/main" val="17363515"/>
       </p:ext>
     </p:extLst>
   </p:cSld>

</xml_diff>